<commit_message>
Day 3: Add GitHub Agentic Workflows slide (Technical Preview Feb 13)
Split slide after CI/CD Integration Patterns.
Left: What it is (Markdown CI/CD, Claude Code + Copilot + Codex, GitHub MCP)
Right: Why it matters (Microsoft endorses Claude, multi-vendor, 50+ pre-built workflows)
Day 3 now 98 slides.
</commit_message>
<xml_diff>
--- a/slides/Day3_Claude_Code_Advanced.pptx
+++ b/slides/Day3_Claude_Code_Advanced.pptx
@@ -102,6 +102,7 @@
     <p:sldId id="350" r:id="rId102"/>
     <p:sldId id="351" r:id="rId103"/>
     <p:sldId id="352" r:id="rId104"/>
+    <p:sldId id="353" r:id="rId105"/>
   </p:sldIdLst>
   <p:sldSz cx="12191695" cy="6858000" type="screen4x3"/>
   <p:notesSz cx="6858000" cy="9144000"/>
@@ -10169,43 +10170,54 @@
           <a:lstStyle/>
           <a:p>
             <a:r>
-              <a:t>TIME: 4 min</a:t>
+              <a:t>TIME: 3 min</a:t>
             </a:r>
           </a:p>
           <a:p/>
           <a:p>
             <a:r>
+              <a:t>OPEN WITH:</a:t>
+            </a:r>
+          </a:p>
+          <a:p>
+            <a:r>
+              <a:t>   This dropped four days ago and it's a big deal. GitHub just launched Agentic Workflows in technical preview. Here's why you should care.</a:t>
+            </a:r>
+          </a:p>
+          <a:p/>
+          <a:p>
+            <a:r>
               <a:t>KEY POINTS:</a:t>
             </a:r>
           </a:p>
           <a:p>
             <a:r>
-              <a:t>   * Cost is sum of: model × thinking × context × frequency</a:t>
-            </a:r>
-          </a:p>
-          <a:p>
-            <a:r>
-              <a:t>   * Biggest saver: Haiku for research tasks</a:t>
-            </a:r>
-          </a:p>
-          <a:p>
-            <a:r>
-              <a:t>   * Second biggest: Low thinking for routine work</a:t>
-            </a:r>
-          </a:p>
-          <a:p>
-            <a:r>
-              <a:t>   * Context bloat from node_modules = wasted tokens</a:t>
-            </a:r>
-          </a:p>
-          <a:p>
-            <a:r>
-              <a:t>   * Batching 10 fixes in one session cheaper than 10 sessions</a:t>
-            </a:r>
-          </a:p>
-          <a:p>
-            <a:r>
-              <a:t>   * Measure to optimize: What tasks burn most tokens?</a:t>
+              <a:t>   * Instead of writing complex YAML for CI/CD pipelines, you write plain Markdown describing what you want. An AI agent — Claude Code, Copilot, or Codex — figures out how to execute it.</a:t>
+            </a:r>
+          </a:p>
+          <a:p>
+            <a:r>
+              <a:t>   * You drop a markdown file in .github/workflows/, run the gh aw CLI to compile it, and it becomes a standard GitHub Actions workflow. But instead of static steps, an AI agent handles the reasoning.</a:t>
+            </a:r>
+          </a:p>
+          <a:p>
+            <a:r>
+              <a:t>   * Use cases: automatic issue triage, PR code reviews, CI failure root cause analysis, documentation maintenance, test coverage improvements. All running autonomously on every push or PR.</a:t>
+            </a:r>
+          </a:p>
+          <a:p>
+            <a:r>
+              <a:t>   * The big story here isn't the feature — it's the signal. GitHub, owned by Microsoft, built their automation platform to explicitly support Claude Code as a first-class agent alongside their own Copilot. That's Microsoft validating everything we've been teaching.</a:t>
+            </a:r>
+          </a:p>
+          <a:p>
+            <a:r>
+              <a:t>   * It uses the GitHub MCP Server under the hood — the same MCP protocol we covered earlier today. Your MCP knowledge transfers directly.</a:t>
+            </a:r>
+          </a:p>
+          <a:p>
+            <a:r>
+              <a:t>   * Security model is solid: read-only by default, sandboxed execution, network isolation, SHA-pinned dependencies. Enterprise-ready design from day one.</a:t>
             </a:r>
           </a:p>
           <a:p/>
@@ -10216,7 +10228,7 @@
           </a:p>
           <a:p>
             <a:r>
-              <a:t>   Team audit: 60% of tokens on simple test generation (was using Sonnet). Switched to Haiku subagent for tests. 70% cost reduction on that workflow.</a:t>
+              <a:t>   Imagine: a developer opens a PR, and Claude Code automatically reviews the code, checks for security issues, validates test coverage, and posts a detailed review — all before a human looks at it. That's not future state. That's available now in technical preview.</a:t>
             </a:r>
           </a:p>
           <a:p/>
@@ -10227,7 +10239,7 @@
           </a:p>
           <a:p>
             <a:r>
-              <a:t>   Token efficiency techniques</a:t>
+              <a:t>   This is where the industry is heading — AI agents as part of your development infrastructure, not just your IDE. Let's look at the rest of the advanced workflow patterns.</a:t>
             </a:r>
           </a:p>
         </p:txBody>
@@ -10308,32 +10320,32 @@
           </a:p>
           <a:p>
             <a:r>
-              <a:t>   * /compact condenses long conversations, preserves key points</a:t>
-            </a:r>
-          </a:p>
-          <a:p>
-            <a:r>
-              <a:t>   * Fresh conversations prevent context bloat tax</a:t>
-            </a:r>
-          </a:p>
-          <a:p>
-            <a:r>
-              <a:t>   * .claudeignore can save 50-80% tokens on large projects</a:t>
-            </a:r>
-          </a:p>
-          <a:p>
-            <a:r>
-              <a:t>   * Periodic summaries compress history</a:t>
-            </a:r>
-          </a:p>
-          <a:p>
-            <a:r>
-              <a:t>   * @ mention 3 files, not 30 (be selective)</a:t>
-            </a:r>
-          </a:p>
-          <a:p>
-            <a:r>
-              <a:t>   * Plan mode offloads research to cheaper subagent</a:t>
+              <a:t>   * Cost is sum of: model × thinking × context × frequency</a:t>
+            </a:r>
+          </a:p>
+          <a:p>
+            <a:r>
+              <a:t>   * Biggest saver: Haiku for research tasks</a:t>
+            </a:r>
+          </a:p>
+          <a:p>
+            <a:r>
+              <a:t>   * Second biggest: Low thinking for routine work</a:t>
+            </a:r>
+          </a:p>
+          <a:p>
+            <a:r>
+              <a:t>   * Context bloat from node_modules = wasted tokens</a:t>
+            </a:r>
+          </a:p>
+          <a:p>
+            <a:r>
+              <a:t>   * Batching 10 fixes in one session cheaper than 10 sessions</a:t>
+            </a:r>
+          </a:p>
+          <a:p>
+            <a:r>
+              <a:t>   * Measure to optimize: What tasks burn most tokens?</a:t>
             </a:r>
           </a:p>
           <a:p/>
@@ -10344,7 +10356,7 @@
           </a:p>
           <a:p>
             <a:r>
-              <a:t>   Project with 50 files. Mentioning all 50 = 200K tokens. Using @explore to find relevant 3 files = 20K tokens. 90% savings.</a:t>
+              <a:t>   Team audit: 60% of tokens on simple test generation (was using Sonnet). Switched to Haiku subagent for tests. 70% cost reduction on that workflow.</a:t>
             </a:r>
           </a:p>
           <a:p/>
@@ -10355,7 +10367,7 @@
           </a:p>
           <a:p>
             <a:r>
-              <a:t>   Production deployment checklist</a:t>
+              <a:t>   Token efficiency techniques</a:t>
             </a:r>
           </a:p>
         </p:txBody>
@@ -10425,98 +10437,65 @@
           <a:lstStyle/>
           <a:p>
             <a:r>
-              <a:t>TIME: 2 min</a:t>
+              <a:t>TIME: 4 min</a:t>
             </a:r>
           </a:p>
           <a:p/>
           <a:p>
             <a:r>
-              <a:t>OPEN WITH:</a:t>
-            </a:r>
-          </a:p>
-          <a:p>
-            <a:r>
-              <a:t>   Nate B Jones: 'The smartest code you write today becomes the dumbest code someone else has to debug tomorrow.' Choose boring, readable solutions.</a:t>
+              <a:t>KEY POINTS:</a:t>
+            </a:r>
+          </a:p>
+          <a:p>
+            <a:r>
+              <a:t>   * /compact condenses long conversations, preserves key points</a:t>
+            </a:r>
+          </a:p>
+          <a:p>
+            <a:r>
+              <a:t>   * Fresh conversations prevent context bloat tax</a:t>
+            </a:r>
+          </a:p>
+          <a:p>
+            <a:r>
+              <a:t>   * .claudeignore can save 50-80% tokens on large projects</a:t>
+            </a:r>
+          </a:p>
+          <a:p>
+            <a:r>
+              <a:t>   * Periodic summaries compress history</a:t>
+            </a:r>
+          </a:p>
+          <a:p>
+            <a:r>
+              <a:t>   * @ mention 3 files, not 30 (be selective)</a:t>
+            </a:r>
+          </a:p>
+          <a:p>
+            <a:r>
+              <a:t>   * Plan mode offloads research to cheaper subagent</a:t>
             </a:r>
           </a:p>
           <a:p/>
           <a:p>
             <a:r>
-              <a:t>KEY POINTS:</a:t>
-            </a:r>
-          </a:p>
-          <a:p>
-            <a:r>
-              <a:t>   * Clever one-liner that saves 3 lines vs readable 10-line version a junior dev understands</a:t>
-            </a:r>
-          </a:p>
-          <a:p>
-            <a:r>
-              <a:t>   * Token efficiency matters, but not at the cost of team understanding</a:t>
-            </a:r>
-          </a:p>
-          <a:p>
-            <a:r>
-              <a:t>   * Future you (6 months later) is 'someone else' - be kind to them</a:t>
-            </a:r>
-          </a:p>
-          <a:p>
-            <a:r>
-              <a:t>   * Boring code is predictable, debuggable, maintainable</a:t>
-            </a:r>
-          </a:p>
-          <a:p>
-            <a:r>
-              <a:t>   * Ask: 'Can a junior developer maintain this?' If no, simplify</a:t>
+              <a:t>REAL-WORLD EXAMPLE:</a:t>
+            </a:r>
+          </a:p>
+          <a:p>
+            <a:r>
+              <a:t>   Project with 50 files. Mentioning all 50 = 200K tokens. Using @explore to find relevant 3 files = 20K tokens. 90% savings.</a:t>
             </a:r>
           </a:p>
           <a:p/>
           <a:p>
             <a:r>
-              <a:t>ASK THE CLASS:</a:t>
-            </a:r>
-          </a:p>
-          <a:p>
-            <a:r>
-              <a:t>   "What's the cleverest code you wrote that you later regretted?"</a:t>
-            </a:r>
-          </a:p>
-          <a:p>
-            <a:r>
-              <a:t>   [PAUSE for 30-60 seconds]</a:t>
-            </a:r>
-          </a:p>
-          <a:p/>
-          <a:p>
-            <a:r>
-              <a:t>REAL-WORLD EXAMPLE:</a:t>
-            </a:r>
-          </a:p>
-          <a:p>
-            <a:r>
-              <a:t>   Code review: Developer submits elegant regex one-liner that validates email format. Senior dev suggests 10-line version with clear steps (split @ check parts, validate domain, check TLD). Clever version: 1 line, impossible to debug. Boring version: 10 lines, obvious what each step does. Team chooses boring. Six months later, junior dev fixes bug in 5 minutes instead of 2 hours.</a:t>
-            </a:r>
-          </a:p>
-          <a:p/>
-          <a:p>
-            <a:r>
-              <a:t>DEMO:</a:t>
-            </a:r>
-          </a:p>
-          <a:p>
-            <a:r>
-              <a:t>   Show two solutions to same problem: 1) Clever: Nested ternary, regex, one-liner magic. 2) Boring: Named variables, clear conditionals, comments explaining why. Ask Claude (in demo) to evaluate both: 'Which would you rather debug at 3am?' Claude picks boring version. Emphasize Nate B Jones wisdom: 'Clever is a liability, boring is an asset.'</a:t>
-            </a:r>
-          </a:p>
-          <a:p/>
-          <a:p>
-            <a:r>
               <a:t>TRANSITION:</a:t>
             </a:r>
           </a:p>
           <a:p>
             <a:r>
-              <a:t>   This maintainability mindset is the perfect conclusion to our advanced patterns - build for the team, not for ego</a:t>
+              <a:t>   Production deployment checklist</a:t>
             </a:r>
           </a:p>
         </p:txBody>
@@ -10586,64 +10565,98 @@
           <a:lstStyle/>
           <a:p>
             <a:r>
-              <a:t>TIME: 3 min</a:t>
+              <a:t>TIME: 2 min</a:t>
             </a:r>
           </a:p>
           <a:p/>
           <a:p>
             <a:r>
+              <a:t>OPEN WITH:</a:t>
+            </a:r>
+          </a:p>
+          <a:p>
+            <a:r>
+              <a:t>   Nate B Jones: 'The smartest code you write today becomes the dumbest code someone else has to debug tomorrow.' Choose boring, readable solutions.</a:t>
+            </a:r>
+          </a:p>
+          <a:p/>
+          <a:p>
+            <a:r>
               <a:t>KEY POINTS:</a:t>
             </a:r>
           </a:p>
           <a:p>
             <a:r>
-              <a:t>   * CLAUDE.md: Team source of truth for Claude behavior</a:t>
-            </a:r>
-          </a:p>
-          <a:p>
-            <a:r>
-              <a:t>   * Commands: Shared via git, documented in README</a:t>
-            </a:r>
-          </a:p>
-          <a:p>
-            <a:r>
-              <a:t>   * Hooks: Safety and compliance from day 1</a:t>
-            </a:r>
-          </a:p>
-          <a:p>
-            <a:r>
-              <a:t>   * Audit logs: Required for enterprise compliance</a:t>
-            </a:r>
-          </a:p>
-          <a:p>
-            <a:r>
-              <a:t>   * .claudeignore: Performance and cost optimization</a:t>
-            </a:r>
-          </a:p>
-          <a:p>
-            <a:r>
-              <a:t>   * MCP: Security review before deployment</a:t>
-            </a:r>
-          </a:p>
-          <a:p>
-            <a:r>
-              <a:t>   * Training: Team knows how to use custom workflows</a:t>
-            </a:r>
-          </a:p>
-          <a:p>
-            <a:r>
-              <a:t>   * Budget: Monitor and optimize based on usage</a:t>
+              <a:t>   * Clever one-liner that saves 3 lines vs readable 10-line version a junior dev understands</a:t>
+            </a:r>
+          </a:p>
+          <a:p>
+            <a:r>
+              <a:t>   * Token efficiency matters, but not at the cost of team understanding</a:t>
+            </a:r>
+          </a:p>
+          <a:p>
+            <a:r>
+              <a:t>   * Future you (6 months later) is 'someone else' - be kind to them</a:t>
+            </a:r>
+          </a:p>
+          <a:p>
+            <a:r>
+              <a:t>   * Boring code is predictable, debuggable, maintainable</a:t>
+            </a:r>
+          </a:p>
+          <a:p>
+            <a:r>
+              <a:t>   * Ask: 'Can a junior developer maintain this?' If no, simplify</a:t>
             </a:r>
           </a:p>
           <a:p/>
           <a:p>
             <a:r>
+              <a:t>ASK THE CLASS:</a:t>
+            </a:r>
+          </a:p>
+          <a:p>
+            <a:r>
+              <a:t>   "What's the cleverest code you wrote that you later regretted?"</a:t>
+            </a:r>
+          </a:p>
+          <a:p>
+            <a:r>
+              <a:t>   [PAUSE for 30-60 seconds]</a:t>
+            </a:r>
+          </a:p>
+          <a:p/>
+          <a:p>
+            <a:r>
+              <a:t>REAL-WORLD EXAMPLE:</a:t>
+            </a:r>
+          </a:p>
+          <a:p>
+            <a:r>
+              <a:t>   Code review: Developer submits elegant regex one-liner that validates email format. Senior dev suggests 10-line version with clear steps (split @ check parts, validate domain, check TLD). Clever version: 1 line, impossible to debug. Boring version: 10 lines, obvious what each step does. Team chooses boring. Six months later, junior dev fixes bug in 5 minutes instead of 2 hours.</a:t>
+            </a:r>
+          </a:p>
+          <a:p/>
+          <a:p>
+            <a:r>
+              <a:t>DEMO:</a:t>
+            </a:r>
+          </a:p>
+          <a:p>
+            <a:r>
+              <a:t>   Show two solutions to same problem: 1) Clever: Nested ternary, regex, one-liner magic. 2) Boring: Named variables, clear conditionals, comments explaining why. Ask Claude (in demo) to evaluate both: 'Which would you rather debug at 3am?' Claude picks boring version. Emphasize Nate B Jones wisdom: 'Clever is a liability, boring is an asset.'</a:t>
+            </a:r>
+          </a:p>
+          <a:p/>
+          <a:p>
+            <a:r>
               <a:t>TRANSITION:</a:t>
             </a:r>
           </a:p>
           <a:p>
             <a:r>
-              <a:t>   Final section: Wrap-up and resources</a:t>
+              <a:t>   This maintainability mindset is the perfect conclusion to our advanced patterns - build for the team, not for ego</a:t>
             </a:r>
           </a:p>
         </p:txBody>
@@ -10836,91 +10849,64 @@
           <a:lstStyle/>
           <a:p>
             <a:r>
-              <a:t>TIME: 4 min</a:t>
+              <a:t>TIME: 3 min</a:t>
             </a:r>
           </a:p>
           <a:p/>
           <a:p>
             <a:r>
-              <a:t>OPEN WITH:</a:t>
-            </a:r>
-          </a:p>
-          <a:p>
-            <a:r>
-              <a:t>   I want to end with honesty about where Claude Code still struggles. This isn't pessimism — it's professionalism. Knowing the boundaries makes you more effective, not less. Reza Rezvani's quote: 'Vibecoding without metacognition is quite dangerous.' Meaning: if you're just accepting Claude's output without understanding it, you're building on sand.</a:t>
+              <a:t>KEY POINTS:</a:t>
+            </a:r>
+          </a:p>
+          <a:p>
+            <a:r>
+              <a:t>   * CLAUDE.md: Team source of truth for Claude behavior</a:t>
+            </a:r>
+          </a:p>
+          <a:p>
+            <a:r>
+              <a:t>   * Commands: Shared via git, documented in README</a:t>
+            </a:r>
+          </a:p>
+          <a:p>
+            <a:r>
+              <a:t>   * Hooks: Safety and compliance from day 1</a:t>
+            </a:r>
+          </a:p>
+          <a:p>
+            <a:r>
+              <a:t>   * Audit logs: Required for enterprise compliance</a:t>
+            </a:r>
+          </a:p>
+          <a:p>
+            <a:r>
+              <a:t>   * .claudeignore: Performance and cost optimization</a:t>
+            </a:r>
+          </a:p>
+          <a:p>
+            <a:r>
+              <a:t>   * MCP: Security review before deployment</a:t>
+            </a:r>
+          </a:p>
+          <a:p>
+            <a:r>
+              <a:t>   * Training: Team knows how to use custom workflows</a:t>
+            </a:r>
+          </a:p>
+          <a:p>
+            <a:r>
+              <a:t>   * Budget: Monitor and optimize based on usage</a:t>
             </a:r>
           </a:p>
           <a:p/>
           <a:p>
             <a:r>
-              <a:t>KEY POINTS:</a:t>
-            </a:r>
-          </a:p>
-          <a:p>
-            <a:r>
-              <a:t>   * Large changes (&gt;15 files): Context degrades, errors compound across files, Claude loses track of dependencies</a:t>
-            </a:r>
-          </a:p>
-          <a:p>
-            <a:r>
-              <a:t>   * Architecture decisions: Claude optimizes locally — it makes each function great but may miss system-level design issues</a:t>
-            </a:r>
-          </a:p>
-          <a:p>
-            <a:r>
-              <a:t>   * Verification boundary: If you can't review and understand the code, you shouldn't ship it. Period.</a:t>
-            </a:r>
-          </a:p>
-          <a:p>
-            <a:r>
-              <a:t>   * Novel work: Claude recombines known patterns brilliantly but doesn't truly invent new algorithms</a:t>
-            </a:r>
-          </a:p>
-          <a:p>
-            <a:r>
-              <a:t>   * The 3 AM test: Could you debug this code at 3 AM without Claude? If not, you need to understand it better before shipping.</a:t>
-            </a:r>
-          </a:p>
-          <a:p>
-            <a:r>
-              <a:t>   * This is why Plan Mode, decomposition, and verification matter — they keep you in control</a:t>
-            </a:r>
-          </a:p>
-          <a:p>
-            <a:r>
-              <a:t>   * Community feedback highlights real gaps: no team collaboration features, pricing confusion, and developer isolation. Each person's Claude Code session is independent — there's no shared workspace or context.</a:t>
-            </a:r>
-          </a:p>
-          <a:p>
-            <a:r>
-              <a:t>   * The practical fix today: shared CLAUDE.md committed to git, team conventions documented as custom commands, and skills versioned alongside your codebase. This creates de facto team collaboration until native features arrive.</a:t>
-            </a:r>
-          </a:p>
-          <a:p/>
-          <a:p>
-            <a:r>
-              <a:t>ASK THE CLASS:</a:t>
-            </a:r>
-          </a:p>
-          <a:p>
-            <a:r>
-              <a:t>   "What's the most complex task you've delegated to AI without fully understanding the output? What happened?"</a:t>
-            </a:r>
-          </a:p>
-          <a:p>
-            <a:r>
-              <a:t>   [PAUSE for 30-60 seconds]</a:t>
-            </a:r>
-          </a:p>
-          <a:p/>
-          <a:p>
-            <a:r>
               <a:t>TRANSITION:</a:t>
             </a:r>
           </a:p>
           <a:p>
             <a:r>
-              <a:t>   With those boundaries clear, let's recap what you've learned and preview tomorrow.</a:t>
+              <a:t>   Final section: Wrap-up and resources</a:t>
             </a:r>
           </a:p>
         </p:txBody>
@@ -10996,53 +10982,85 @@
           <a:p/>
           <a:p>
             <a:r>
+              <a:t>OPEN WITH:</a:t>
+            </a:r>
+          </a:p>
+          <a:p>
+            <a:r>
+              <a:t>   I want to end with honesty about where Claude Code still struggles. This isn't pessimism — it's professionalism. Knowing the boundaries makes you more effective, not less. Reza Rezvani's quote: 'Vibecoding without metacognition is quite dangerous.' Meaning: if you're just accepting Claude's output without understanding it, you're building on sand.</a:t>
+            </a:r>
+          </a:p>
+          <a:p/>
+          <a:p>
+            <a:r>
               <a:t>KEY POINTS:</a:t>
             </a:r>
           </a:p>
           <a:p>
             <a:r>
-              <a:t>   * You now have advanced patterns for production Claude Code use</a:t>
-            </a:r>
-          </a:p>
-          <a:p>
-            <a:r>
-              <a:t>   * Custom commands save hours daily on repetitive tasks</a:t>
-            </a:r>
-          </a:p>
-          <a:p>
-            <a:r>
-              <a:t>   * Hooks provide safety and compliance</a:t>
-            </a:r>
-          </a:p>
-          <a:p>
-            <a:r>
-              <a:t>   * MCP unlocks integration with any tool or database</a:t>
-            </a:r>
-          </a:p>
-          <a:p>
-            <a:r>
-              <a:t>   * Agent Teams enable work that would take days to complete in hours</a:t>
-            </a:r>
-          </a:p>
-          <a:p>
-            <a:r>
-              <a:t>   * These patterns scale from 1 developer to enterprise teams</a:t>
-            </a:r>
-          </a:p>
-          <a:p>
-            <a:r>
-              <a:t>   * Remember: Claude Code's current limitation is team isolation — but shared CLAUDE.md via git, versioned custom commands, and team conventions bridge that gap until native collaboration features arrive.</a:t>
+              <a:t>   * Large changes (&gt;15 files): Context degrades, errors compound across files, Claude loses track of dependencies</a:t>
+            </a:r>
+          </a:p>
+          <a:p>
+            <a:r>
+              <a:t>   * Architecture decisions: Claude optimizes locally — it makes each function great but may miss system-level design issues</a:t>
+            </a:r>
+          </a:p>
+          <a:p>
+            <a:r>
+              <a:t>   * Verification boundary: If you can't review and understand the code, you shouldn't ship it. Period.</a:t>
+            </a:r>
+          </a:p>
+          <a:p>
+            <a:r>
+              <a:t>   * Novel work: Claude recombines known patterns brilliantly but doesn't truly invent new algorithms</a:t>
+            </a:r>
+          </a:p>
+          <a:p>
+            <a:r>
+              <a:t>   * The 3 AM test: Could you debug this code at 3 AM without Claude? If not, you need to understand it better before shipping.</a:t>
+            </a:r>
+          </a:p>
+          <a:p>
+            <a:r>
+              <a:t>   * This is why Plan Mode, decomposition, and verification matter — they keep you in control</a:t>
+            </a:r>
+          </a:p>
+          <a:p>
+            <a:r>
+              <a:t>   * Community feedback highlights real gaps: no team collaboration features, pricing confusion, and developer isolation. Each person's Claude Code session is independent — there's no shared workspace or context.</a:t>
+            </a:r>
+          </a:p>
+          <a:p>
+            <a:r>
+              <a:t>   * The practical fix today: shared CLAUDE.md committed to git, team conventions documented as custom commands, and skills versioned alongside your codebase. This creates de facto team collaboration until native features arrive.</a:t>
             </a:r>
           </a:p>
           <a:p/>
           <a:p>
             <a:r>
+              <a:t>ASK THE CLASS:</a:t>
+            </a:r>
+          </a:p>
+          <a:p>
+            <a:r>
+              <a:t>   "What's the most complex task you've delegated to AI without fully understanding the output? What happened?"</a:t>
+            </a:r>
+          </a:p>
+          <a:p>
+            <a:r>
+              <a:t>   [PAUSE for 30-60 seconds]</a:t>
+            </a:r>
+          </a:p>
+          <a:p/>
+          <a:p>
+            <a:r>
               <a:t>TRANSITION:</a:t>
             </a:r>
           </a:p>
           <a:p>
             <a:r>
-              <a:t>   Getting started roadmap</a:t>
+              <a:t>   With those boundaries clear, let's recap what you've learned and preview tomorrow.</a:t>
             </a:r>
           </a:p>
         </p:txBody>
@@ -11123,54 +11141,48 @@
           </a:p>
           <a:p>
             <a:r>
-              <a:t>   * Don't try everything at once</a:t>
-            </a:r>
-          </a:p>
-          <a:p>
-            <a:r>
-              <a:t>   * Start with custom commands (easiest, high value)</a:t>
-            </a:r>
-          </a:p>
-          <a:p>
-            <a:r>
-              <a:t>   * Add security hooks early (build good habits)</a:t>
-            </a:r>
-          </a:p>
-          <a:p>
-            <a:r>
-              <a:t>   * MCP integration provides immediate workflow improvement</a:t>
-            </a:r>
-          </a:p>
-          <a:p>
-            <a:r>
-              <a:t>   * Advanced patterns (Agent Teams) after basics are solid</a:t>
-            </a:r>
-          </a:p>
-          <a:p>
-            <a:r>
-              <a:t>   * Measure value at each stage, celebrate wins</a:t>
+              <a:t>   * You now have advanced patterns for production Claude Code use</a:t>
+            </a:r>
+          </a:p>
+          <a:p>
+            <a:r>
+              <a:t>   * Custom commands save hours daily on repetitive tasks</a:t>
+            </a:r>
+          </a:p>
+          <a:p>
+            <a:r>
+              <a:t>   * Hooks provide safety and compliance</a:t>
+            </a:r>
+          </a:p>
+          <a:p>
+            <a:r>
+              <a:t>   * MCP unlocks integration with any tool or database</a:t>
+            </a:r>
+          </a:p>
+          <a:p>
+            <a:r>
+              <a:t>   * Agent Teams enable work that would take days to complete in hours</a:t>
+            </a:r>
+          </a:p>
+          <a:p>
+            <a:r>
+              <a:t>   * These patterns scale from 1 developer to enterprise teams</a:t>
+            </a:r>
+          </a:p>
+          <a:p>
+            <a:r>
+              <a:t>   * Remember: Claude Code's current limitation is team isolation — but shared CLAUDE.md via git, versioned custom commands, and team conventions bridge that gap until native collaboration features arrive.</a:t>
             </a:r>
           </a:p>
           <a:p/>
           <a:p>
             <a:r>
-              <a:t>REAL-WORLD EXAMPLE:</a:t>
-            </a:r>
-          </a:p>
-          <a:p>
-            <a:r>
-              <a:t>   Team followed this roadmap. After month 1: saving 5 hours/week with commands and hooks. After month 3: Agent Teams cutting complex feature time in half.</a:t>
-            </a:r>
-          </a:p>
-          <a:p/>
-          <a:p>
-            <a:r>
               <a:t>TRANSITION:</a:t>
             </a:r>
           </a:p>
           <a:p>
             <a:r>
-              <a:t>   Resources and community</a:t>
+              <a:t>   Getting started roadmap</a:t>
             </a:r>
           </a:p>
         </p:txBody>
@@ -11240,7 +11252,7 @@
           <a:lstStyle/>
           <a:p>
             <a:r>
-              <a:t>TIME: 3 min</a:t>
+              <a:t>TIME: 4 min</a:t>
             </a:r>
           </a:p>
           <a:p/>
@@ -11251,43 +11263,54 @@
           </a:p>
           <a:p>
             <a:r>
-              <a:t>   * Official docs are comprehensive and up-to-date</a:t>
-            </a:r>
-          </a:p>
-          <a:p>
-            <a:r>
-              <a:t>   * MCP ecosystem growing rapidly</a:t>
-            </a:r>
-          </a:p>
-          <a:p>
-            <a:r>
-              <a:t>   * Community shares custom commands and patterns</a:t>
-            </a:r>
-          </a:p>
-          <a:p>
-            <a:r>
-              <a:t>   * Discord active for questions and troubleshooting</a:t>
-            </a:r>
-          </a:p>
-          <a:p>
-            <a:r>
-              <a:t>   * Learn from others' Agent Teams examples</a:t>
-            </a:r>
-          </a:p>
-          <a:p>
-            <a:r>
-              <a:t>   * Internal team knowledge sharing multiplies value</a:t>
+              <a:t>   * Don't try everything at once</a:t>
+            </a:r>
+          </a:p>
+          <a:p>
+            <a:r>
+              <a:t>   * Start with custom commands (easiest, high value)</a:t>
+            </a:r>
+          </a:p>
+          <a:p>
+            <a:r>
+              <a:t>   * Add security hooks early (build good habits)</a:t>
+            </a:r>
+          </a:p>
+          <a:p>
+            <a:r>
+              <a:t>   * MCP integration provides immediate workflow improvement</a:t>
+            </a:r>
+          </a:p>
+          <a:p>
+            <a:r>
+              <a:t>   * Advanced patterns (Agent Teams) after basics are solid</a:t>
+            </a:r>
+          </a:p>
+          <a:p>
+            <a:r>
+              <a:t>   * Measure value at each stage, celebrate wins</a:t>
             </a:r>
           </a:p>
           <a:p/>
           <a:p>
             <a:r>
+              <a:t>REAL-WORLD EXAMPLE:</a:t>
+            </a:r>
+          </a:p>
+          <a:p>
+            <a:r>
+              <a:t>   Team followed this roadmap. After month 1: saving 5 hours/week with commands and hooks. After month 3: Agent Teams cutting complex feature time in half.</a:t>
+            </a:r>
+          </a:p>
+          <a:p/>
+          <a:p>
+            <a:r>
               <a:t>TRANSITION:</a:t>
             </a:r>
           </a:p>
           <a:p>
             <a:r>
-              <a:t>   Thank you and Q&amp;A</a:t>
+              <a:t>   Resources and community</a:t>
             </a:r>
           </a:p>
         </p:txBody>
@@ -11313,6 +11336,123 @@
 </file>
 
 <file path=ppt/notesSlides/notesSlide84.xml><?xml version="1.0" encoding="utf-8"?>
+<p:notes xmlns:a="http://schemas.openxmlformats.org/drawingml/2006/main" xmlns:p="http://schemas.openxmlformats.org/presentationml/2006/main" xmlns:r="http://schemas.openxmlformats.org/officeDocument/2006/relationships">
+  <p:cSld>
+    <p:spTree>
+      <p:nvGrpSpPr>
+        <p:cNvPr id="1" name=""/>
+        <p:cNvGrpSpPr/>
+        <p:nvPr/>
+      </p:nvGrpSpPr>
+      <p:grpSpPr>
+        <a:xfrm>
+          <a:off x="0" y="0"/>
+          <a:ext cx="0" cy="0"/>
+          <a:chOff x="0" y="0"/>
+          <a:chExt cx="0" cy="0"/>
+        </a:xfrm>
+      </p:grpSpPr>
+      <p:sp>
+        <p:nvSpPr>
+          <p:cNvPr id="2" name="Slide Image Placeholder 1"/>
+          <p:cNvSpPr>
+            <a:spLocks noGrp="1"/>
+          </p:cNvSpPr>
+          <p:nvPr>
+            <p:ph type="sldImg" idx="2"/>
+          </p:nvPr>
+        </p:nvSpPr>
+        <p:spPr/>
+      </p:sp>
+      <p:sp>
+        <p:nvSpPr>
+          <p:cNvPr id="3" name="Notes Placeholder 2"/>
+          <p:cNvSpPr>
+            <a:spLocks noGrp="1"/>
+          </p:cNvSpPr>
+          <p:nvPr>
+            <p:ph type="body" idx="3" sz="quarter"/>
+          </p:nvPr>
+        </p:nvSpPr>
+        <p:spPr/>
+        <p:txBody>
+          <a:bodyPr/>
+          <a:lstStyle/>
+          <a:p>
+            <a:r>
+              <a:t>TIME: 3 min</a:t>
+            </a:r>
+          </a:p>
+          <a:p/>
+          <a:p>
+            <a:r>
+              <a:t>KEY POINTS:</a:t>
+            </a:r>
+          </a:p>
+          <a:p>
+            <a:r>
+              <a:t>   * Official docs are comprehensive and up-to-date</a:t>
+            </a:r>
+          </a:p>
+          <a:p>
+            <a:r>
+              <a:t>   * MCP ecosystem growing rapidly</a:t>
+            </a:r>
+          </a:p>
+          <a:p>
+            <a:r>
+              <a:t>   * Community shares custom commands and patterns</a:t>
+            </a:r>
+          </a:p>
+          <a:p>
+            <a:r>
+              <a:t>   * Discord active for questions and troubleshooting</a:t>
+            </a:r>
+          </a:p>
+          <a:p>
+            <a:r>
+              <a:t>   * Learn from others' Agent Teams examples</a:t>
+            </a:r>
+          </a:p>
+          <a:p>
+            <a:r>
+              <a:t>   * Internal team knowledge sharing multiplies value</a:t>
+            </a:r>
+          </a:p>
+          <a:p/>
+          <a:p>
+            <a:r>
+              <a:t>TRANSITION:</a:t>
+            </a:r>
+          </a:p>
+          <a:p>
+            <a:r>
+              <a:t>   Thank you and Q&amp;A</a:t>
+            </a:r>
+          </a:p>
+        </p:txBody>
+      </p:sp>
+      <p:sp>
+        <p:nvSpPr>
+          <p:cNvPr id="4" name="Slide Number Placeholder 3"/>
+          <p:cNvSpPr>
+            <a:spLocks noGrp="1"/>
+          </p:cNvSpPr>
+          <p:nvPr>
+            <p:ph type="sldNum" idx="5" sz="quarter"/>
+          </p:nvPr>
+        </p:nvSpPr>
+        <p:spPr/>
+      </p:sp>
+    </p:spTree>
+  </p:cSld>
+  <p:clrMapOvr>
+    <a:masterClrMapping/>
+  </p:clrMapOvr>
+</p:notes>
+</file>
+
+<file path=ppt/notesSlides/notesSlide85.xml><?xml version="1.0" encoding="utf-8"?>
 <p:notes xmlns:a="http://schemas.openxmlformats.org/drawingml/2006/main" xmlns:p="http://schemas.openxmlformats.org/presentationml/2006/main" xmlns:r="http://schemas.openxmlformats.org/officeDocument/2006/relationships">
   <p:cSld>
     <p:spTree>
@@ -40081,8 +40221,8 @@
         </p:nvSpPr>
         <p:spPr>
           <a:xfrm>
-            <a:off x="457200" y="365760"/>
-            <a:ext cx="11277295" cy="822960"/>
+            <a:off x="457200" y="457200"/>
+            <a:ext cx="11277295" cy="731520"/>
           </a:xfrm>
           <a:prstGeom prst="rect">
             <a:avLst/>
@@ -40095,15 +40235,15 @@
           </a:bodyPr>
           <a:lstStyle/>
           <a:p>
-            <a:pPr>
-              <a:defRPr sz="4000" b="1">
+            <a:pPr algn="ctr">
+              <a:defRPr sz="3600" b="1">
                 <a:solidFill>
                   <a:srgbClr val="FFFFFF"/>
                 </a:solidFill>
               </a:defRPr>
             </a:pPr>
             <a:r>
-              <a:t>Cost Management &amp; Optimization</a:t>
+              <a:t>GitHub Agentic Workflows (Technical Preview)</a:t>
             </a:r>
           </a:p>
         </p:txBody>
@@ -40116,8 +40256,8 @@
         </p:nvSpPr>
         <p:spPr>
           <a:xfrm>
-            <a:off x="457200" y="1234440"/>
-            <a:ext cx="1828800" cy="36576"/>
+            <a:off x="6077559" y="1371600"/>
+            <a:ext cx="36576" cy="4572000"/>
           </a:xfrm>
           <a:prstGeom prst="rect">
             <a:avLst/>
@@ -40160,7 +40300,7 @@
         <p:spPr>
           <a:xfrm>
             <a:off x="457200" y="1463040"/>
-            <a:ext cx="11277295" cy="4572000"/>
+            <a:ext cx="5364327" cy="731520"/>
           </a:xfrm>
           <a:prstGeom prst="rect">
             <a:avLst/>
@@ -40168,116 +40308,55 @@
           <a:noFill/>
         </p:spPr>
         <p:txBody>
-          <a:bodyPr wrap="square">
+          <a:bodyPr wrap="none">
             <a:spAutoFit/>
           </a:bodyPr>
           <a:lstStyle/>
           <a:p>
-            <a:pPr>
-              <a:spcBef>
-                <a:spcPts val="800"/>
-              </a:spcBef>
-              <a:spcAft>
-                <a:spcPts val="800"/>
-              </a:spcAft>
-              <a:defRPr sz="2200">
-                <a:solidFill>
-                  <a:srgbClr val="FFFFFF"/>
-                </a:solidFill>
-              </a:defRPr>
-            </a:pPr>
-            <a:r>
-              <a:t>  Model selection: Haiku for simple tasks, Sonnet default, Opus for critical</a:t>
-            </a:r>
-          </a:p>
-          <a:p>
-            <a:pPr>
-              <a:spcBef>
-                <a:spcPts val="800"/>
-              </a:spcBef>
-              <a:spcAft>
-                <a:spcPts val="800"/>
-              </a:spcAft>
-              <a:defRPr sz="2200">
-                <a:solidFill>
-                  <a:srgbClr val="FFFFFF"/>
-                </a:solidFill>
-              </a:defRPr>
-            </a:pPr>
-            <a:r>
-              <a:t>  Thinking levels: Low for routine, High for complex (3-5× cost difference)</a:t>
-            </a:r>
-          </a:p>
-          <a:p>
-            <a:pPr>
-              <a:spcBef>
-                <a:spcPts val="800"/>
-              </a:spcBef>
-              <a:spcAft>
-                <a:spcPts val="800"/>
-              </a:spcAft>
-              <a:defRPr sz="2200">
-                <a:solidFill>
-                  <a:srgbClr val="FFFFFF"/>
-                </a:solidFill>
-              </a:defRPr>
-            </a:pPr>
-            <a:r>
-              <a:t>  Subagents: Use Haiku subagents for research (10× cheaper)</a:t>
-            </a:r>
-          </a:p>
-          <a:p>
-            <a:pPr>
-              <a:spcBef>
-                <a:spcPts val="800"/>
-              </a:spcBef>
-              <a:spcAft>
-                <a:spcPts val="800"/>
-              </a:spcAft>
-              <a:defRPr sz="2200">
-                <a:solidFill>
-                  <a:srgbClr val="FFFFFF"/>
-                </a:solidFill>
-              </a:defRPr>
-            </a:pPr>
-            <a:r>
-              <a:t>  Context management: .claudeignore reduces unnecessary tokens</a:t>
-            </a:r>
-          </a:p>
-          <a:p>
-            <a:pPr>
-              <a:spcBef>
-                <a:spcPts val="800"/>
-              </a:spcBef>
-              <a:spcAft>
-                <a:spcPts val="800"/>
-              </a:spcAft>
-              <a:defRPr sz="2200">
-                <a:solidFill>
-                  <a:srgbClr val="FFFFFF"/>
-                </a:solidFill>
-              </a:defRPr>
-            </a:pPr>
-            <a:r>
-              <a:t>  Batch work: Multiple small changes in one session vs many sessions</a:t>
-            </a:r>
-          </a:p>
-          <a:p>
-            <a:pPr>
-              <a:spcBef>
-                <a:spcPts val="800"/>
-              </a:spcBef>
-              <a:spcAft>
-                <a:spcPts val="800"/>
-              </a:spcAft>
-              <a:defRPr sz="2200">
-                <a:solidFill>
-                  <a:srgbClr val="FFFFFF"/>
-                </a:solidFill>
-              </a:defRPr>
-            </a:pPr>
-            <a:r>
-              <a:t>  Monitor usage: Track tokens per task type, optimize high-volume patterns</a:t>
+            <a:pPr algn="ctr">
+              <a:defRPr sz="2800" b="1">
+                <a:solidFill>
+                  <a:srgbClr val="E86B4A"/>
+                </a:solidFill>
+              </a:defRPr>
+            </a:pPr>
+            <a:r>
+              <a:t>Before</a:t>
+            </a:r>
+          </a:p>
+        </p:txBody>
+      </p:sp>
+      <p:sp>
+        <p:nvSpPr>
+          <p:cNvPr id="5" name="TextBox 4"/>
+          <p:cNvSpPr txBox="1"/>
+          <p:nvPr/>
+        </p:nvSpPr>
+        <p:spPr>
+          <a:xfrm>
+            <a:off x="6370167" y="1463040"/>
+            <a:ext cx="5364327" cy="731520"/>
+          </a:xfrm>
+          <a:prstGeom prst="rect">
+            <a:avLst/>
+          </a:prstGeom>
+          <a:noFill/>
+        </p:spPr>
+        <p:txBody>
+          <a:bodyPr wrap="none">
+            <a:spAutoFit/>
+          </a:bodyPr>
+          <a:lstStyle/>
+          <a:p>
+            <a:pPr algn="ctr">
+              <a:defRPr sz="2800" b="1">
+                <a:solidFill>
+                  <a:srgbClr val="00D4AA"/>
+                </a:solidFill>
+              </a:defRPr>
+            </a:pPr>
+            <a:r>
+              <a:t>After</a:t>
             </a:r>
           </a:p>
         </p:txBody>
@@ -40338,7 +40417,7 @@
               </a:defRPr>
             </a:pPr>
             <a:r>
-              <a:t>Token Efficiency Techniques</a:t>
+              <a:t>Cost Management &amp; Optimization</a:t>
             </a:r>
           </a:p>
         </p:txBody>
@@ -40422,7 +40501,7 @@
               </a:defRPr>
             </a:pPr>
             <a:r>
-              <a:t>  Use /compact to compress context mid-conversation</a:t>
+              <a:t>  Model selection: Haiku for simple tasks, Sonnet default, Opus for critical</a:t>
             </a:r>
           </a:p>
           <a:p>
@@ -40440,7 +40519,7 @@
               </a:defRPr>
             </a:pPr>
             <a:r>
-              <a:t>  Start fresh conversation for unrelated tasks (don't bloat context)</a:t>
+              <a:t>  Thinking levels: Low for routine, High for complex (3-5× cost difference)</a:t>
             </a:r>
           </a:p>
           <a:p>
@@ -40458,7 +40537,7 @@
               </a:defRPr>
             </a:pPr>
             <a:r>
-              <a:t>  .claudeignore aggressively: build/, dist/, node_modules/, .git/</a:t>
+              <a:t>  Subagents: Use Haiku subagents for research (10× cheaper)</a:t>
             </a:r>
           </a:p>
           <a:p>
@@ -40476,7 +40555,7 @@
               </a:defRPr>
             </a:pPr>
             <a:r>
-              <a:t>  Summarize long discussions: 'Summarize what we've accomplished'</a:t>
+              <a:t>  Context management: .claudeignore reduces unnecessary tokens</a:t>
             </a:r>
           </a:p>
           <a:p>
@@ -40494,7 +40573,7 @@
               </a:defRPr>
             </a:pPr>
             <a:r>
-              <a:t>  Avoid unnecessary file attachments (@mention only what's needed)</a:t>
+              <a:t>  Batch work: Multiple small changes in one session vs many sessions</a:t>
             </a:r>
           </a:p>
           <a:p>
@@ -40512,7 +40591,7 @@
               </a:defRPr>
             </a:pPr>
             <a:r>
-              <a:t>  Plan mode research uses @plan subagent (saves main context)</a:t>
+              <a:t>  Monitor usage: Track tokens per task type, optimize high-volume patterns</a:t>
             </a:r>
           </a:p>
         </p:txBody>
@@ -40921,8 +41000,86 @@
         </p:nvSpPr>
         <p:spPr>
           <a:xfrm>
-            <a:off x="731520" y="2286000"/>
-            <a:ext cx="10728655" cy="1371600"/>
+            <a:off x="457200" y="365760"/>
+            <a:ext cx="11277295" cy="822960"/>
+          </a:xfrm>
+          <a:prstGeom prst="rect">
+            <a:avLst/>
+          </a:prstGeom>
+          <a:noFill/>
+        </p:spPr>
+        <p:txBody>
+          <a:bodyPr wrap="none">
+            <a:spAutoFit/>
+          </a:bodyPr>
+          <a:lstStyle/>
+          <a:p>
+            <a:pPr>
+              <a:defRPr sz="4000" b="1">
+                <a:solidFill>
+                  <a:srgbClr val="FFFFFF"/>
+                </a:solidFill>
+              </a:defRPr>
+            </a:pPr>
+            <a:r>
+              <a:t>Token Efficiency Techniques</a:t>
+            </a:r>
+          </a:p>
+        </p:txBody>
+      </p:sp>
+      <p:sp>
+        <p:nvSpPr>
+          <p:cNvPr id="3" name="Rectangle 2"/>
+          <p:cNvSpPr/>
+          <p:nvPr/>
+        </p:nvSpPr>
+        <p:spPr>
+          <a:xfrm>
+            <a:off x="457200" y="1234440"/>
+            <a:ext cx="1828800" cy="36576"/>
+          </a:xfrm>
+          <a:prstGeom prst="rect">
+            <a:avLst/>
+          </a:prstGeom>
+          <a:solidFill>
+            <a:srgbClr val="00D4AA"/>
+          </a:solidFill>
+          <a:ln>
+            <a:noFill/>
+          </a:ln>
+        </p:spPr>
+        <p:style>
+          <a:lnRef idx="1">
+            <a:schemeClr val="accent1"/>
+          </a:lnRef>
+          <a:fillRef idx="3">
+            <a:schemeClr val="accent1"/>
+          </a:fillRef>
+          <a:effectRef idx="2">
+            <a:schemeClr val="accent1"/>
+          </a:effectRef>
+          <a:fontRef idx="minor">
+            <a:schemeClr val="lt1"/>
+          </a:fontRef>
+        </p:style>
+        <p:txBody>
+          <a:bodyPr rtlCol="0" anchor="ctr"/>
+          <a:lstStyle/>
+          <a:p>
+            <a:pPr algn="ctr"/>
+          </a:p>
+        </p:txBody>
+      </p:sp>
+      <p:sp>
+        <p:nvSpPr>
+          <p:cNvPr id="4" name="TextBox 3"/>
+          <p:cNvSpPr txBox="1"/>
+          <p:nvPr/>
+        </p:nvSpPr>
+        <p:spPr>
+          <a:xfrm>
+            <a:off x="457200" y="1463040"/>
+            <a:ext cx="11277295" cy="4572000"/>
           </a:xfrm>
           <a:prstGeom prst="rect">
             <a:avLst/>
@@ -40935,50 +41092,111 @@
           </a:bodyPr>
           <a:lstStyle/>
           <a:p>
-            <a:pPr algn="ctr">
-              <a:defRPr sz="5200" b="1">
+            <a:pPr>
+              <a:spcBef>
+                <a:spcPts val="800"/>
+              </a:spcBef>
+              <a:spcAft>
+                <a:spcPts val="800"/>
+              </a:spcAft>
+              <a:defRPr sz="2200">
                 <a:solidFill>
                   <a:srgbClr val="FFFFFF"/>
                 </a:solidFill>
               </a:defRPr>
             </a:pPr>
             <a:r>
-              <a:t>Engineering Principle: Optimize for Maintainability Over Cleverness</a:t>
-            </a:r>
-          </a:p>
-        </p:txBody>
-      </p:sp>
-      <p:sp>
-        <p:nvSpPr>
-          <p:cNvPr id="3" name="TextBox 2"/>
-          <p:cNvSpPr txBox="1"/>
-          <p:nvPr/>
-        </p:nvSpPr>
-        <p:spPr>
-          <a:xfrm>
-            <a:off x="914400" y="3840480"/>
-            <a:ext cx="10362895" cy="914400"/>
-          </a:xfrm>
-          <a:prstGeom prst="rect">
-            <a:avLst/>
-          </a:prstGeom>
-          <a:noFill/>
-        </p:spPr>
-        <p:txBody>
-          <a:bodyPr wrap="square">
-            <a:spAutoFit/>
-          </a:bodyPr>
-          <a:lstStyle/>
-          <a:p>
-            <a:pPr algn="ctr">
-              <a:defRPr sz="2400">
-                <a:solidFill>
-                  <a:srgbClr val="8B95A5"/>
-                </a:solidFill>
-              </a:defRPr>
-            </a:pPr>
-            <a:r>
-              <a:t>Source: Nate B Jones, 'Second Brain' video</a:t>
+              <a:t>  Use /compact to compress context mid-conversation</a:t>
+            </a:r>
+          </a:p>
+          <a:p>
+            <a:pPr>
+              <a:spcBef>
+                <a:spcPts val="800"/>
+              </a:spcBef>
+              <a:spcAft>
+                <a:spcPts val="800"/>
+              </a:spcAft>
+              <a:defRPr sz="2200">
+                <a:solidFill>
+                  <a:srgbClr val="FFFFFF"/>
+                </a:solidFill>
+              </a:defRPr>
+            </a:pPr>
+            <a:r>
+              <a:t>  Start fresh conversation for unrelated tasks (don't bloat context)</a:t>
+            </a:r>
+          </a:p>
+          <a:p>
+            <a:pPr>
+              <a:spcBef>
+                <a:spcPts val="800"/>
+              </a:spcBef>
+              <a:spcAft>
+                <a:spcPts val="800"/>
+              </a:spcAft>
+              <a:defRPr sz="2200">
+                <a:solidFill>
+                  <a:srgbClr val="FFFFFF"/>
+                </a:solidFill>
+              </a:defRPr>
+            </a:pPr>
+            <a:r>
+              <a:t>  .claudeignore aggressively: build/, dist/, node_modules/, .git/</a:t>
+            </a:r>
+          </a:p>
+          <a:p>
+            <a:pPr>
+              <a:spcBef>
+                <a:spcPts val="800"/>
+              </a:spcBef>
+              <a:spcAft>
+                <a:spcPts val="800"/>
+              </a:spcAft>
+              <a:defRPr sz="2200">
+                <a:solidFill>
+                  <a:srgbClr val="FFFFFF"/>
+                </a:solidFill>
+              </a:defRPr>
+            </a:pPr>
+            <a:r>
+              <a:t>  Summarize long discussions: 'Summarize what we've accomplished'</a:t>
+            </a:r>
+          </a:p>
+          <a:p>
+            <a:pPr>
+              <a:spcBef>
+                <a:spcPts val="800"/>
+              </a:spcBef>
+              <a:spcAft>
+                <a:spcPts val="800"/>
+              </a:spcAft>
+              <a:defRPr sz="2200">
+                <a:solidFill>
+                  <a:srgbClr val="FFFFFF"/>
+                </a:solidFill>
+              </a:defRPr>
+            </a:pPr>
+            <a:r>
+              <a:t>  Avoid unnecessary file attachments (@mention only what's needed)</a:t>
+            </a:r>
+          </a:p>
+          <a:p>
+            <a:pPr>
+              <a:spcBef>
+                <a:spcPts val="800"/>
+              </a:spcBef>
+              <a:spcAft>
+                <a:spcPts val="800"/>
+              </a:spcAft>
+              <a:defRPr sz="2200">
+                <a:solidFill>
+                  <a:srgbClr val="FFFFFF"/>
+                </a:solidFill>
+              </a:defRPr>
+            </a:pPr>
+            <a:r>
+              <a:t>  Plan mode research uses @plan subagent (saves main context)</a:t>
             </a:r>
           </a:p>
         </p:txBody>
@@ -41017,86 +41235,8 @@
         </p:nvSpPr>
         <p:spPr>
           <a:xfrm>
-            <a:off x="457200" y="365760"/>
-            <a:ext cx="11277295" cy="822960"/>
-          </a:xfrm>
-          <a:prstGeom prst="rect">
-            <a:avLst/>
-          </a:prstGeom>
-          <a:noFill/>
-        </p:spPr>
-        <p:txBody>
-          <a:bodyPr wrap="none">
-            <a:spAutoFit/>
-          </a:bodyPr>
-          <a:lstStyle/>
-          <a:p>
-            <a:pPr>
-              <a:defRPr sz="4000" b="1">
-                <a:solidFill>
-                  <a:srgbClr val="FFFFFF"/>
-                </a:solidFill>
-              </a:defRPr>
-            </a:pPr>
-            <a:r>
-              <a:t>Production Deployment Checklist</a:t>
-            </a:r>
-          </a:p>
-        </p:txBody>
-      </p:sp>
-      <p:sp>
-        <p:nvSpPr>
-          <p:cNvPr id="3" name="Rectangle 2"/>
-          <p:cNvSpPr/>
-          <p:nvPr/>
-        </p:nvSpPr>
-        <p:spPr>
-          <a:xfrm>
-            <a:off x="457200" y="1234440"/>
-            <a:ext cx="1828800" cy="36576"/>
-          </a:xfrm>
-          <a:prstGeom prst="rect">
-            <a:avLst/>
-          </a:prstGeom>
-          <a:solidFill>
-            <a:srgbClr val="00D4AA"/>
-          </a:solidFill>
-          <a:ln>
-            <a:noFill/>
-          </a:ln>
-        </p:spPr>
-        <p:style>
-          <a:lnRef idx="1">
-            <a:schemeClr val="accent1"/>
-          </a:lnRef>
-          <a:fillRef idx="3">
-            <a:schemeClr val="accent1"/>
-          </a:fillRef>
-          <a:effectRef idx="2">
-            <a:schemeClr val="accent1"/>
-          </a:effectRef>
-          <a:fontRef idx="minor">
-            <a:schemeClr val="lt1"/>
-          </a:fontRef>
-        </p:style>
-        <p:txBody>
-          <a:bodyPr rtlCol="0" anchor="ctr"/>
-          <a:lstStyle/>
-          <a:p>
-            <a:pPr algn="ctr"/>
-          </a:p>
-        </p:txBody>
-      </p:sp>
-      <p:sp>
-        <p:nvSpPr>
-          <p:cNvPr id="4" name="TextBox 3"/>
-          <p:cNvSpPr txBox="1"/>
-          <p:nvPr/>
-        </p:nvSpPr>
-        <p:spPr>
-          <a:xfrm>
-            <a:off x="457200" y="1463040"/>
-            <a:ext cx="11277295" cy="4572000"/>
+            <a:off x="731520" y="2286000"/>
+            <a:ext cx="10728655" cy="1371600"/>
           </a:xfrm>
           <a:prstGeom prst="rect">
             <a:avLst/>
@@ -41109,147 +41249,50 @@
           </a:bodyPr>
           <a:lstStyle/>
           <a:p>
-            <a:pPr>
-              <a:spcBef>
-                <a:spcPts val="800"/>
-              </a:spcBef>
-              <a:spcAft>
-                <a:spcPts val="800"/>
-              </a:spcAft>
-              <a:defRPr sz="2200">
+            <a:pPr algn="ctr">
+              <a:defRPr sz="5200" b="1">
                 <a:solidFill>
                   <a:srgbClr val="FFFFFF"/>
                 </a:solidFill>
               </a:defRPr>
             </a:pPr>
             <a:r>
-              <a:t>  ✅ CLAUDE.md configured with team standards</a:t>
-            </a:r>
-          </a:p>
-          <a:p>
-            <a:pPr>
-              <a:spcBef>
-                <a:spcPts val="800"/>
-              </a:spcBef>
-              <a:spcAft>
-                <a:spcPts val="800"/>
-              </a:spcAft>
-              <a:defRPr sz="2200">
-                <a:solidFill>
-                  <a:srgbClr val="FFFFFF"/>
-                </a:solidFill>
-              </a:defRPr>
-            </a:pPr>
-            <a:r>
-              <a:t>  ✅ Custom commands in .claude/commands/ (versioned in git)</a:t>
-            </a:r>
-          </a:p>
-          <a:p>
-            <a:pPr>
-              <a:spcBef>
-                <a:spcPts val="800"/>
-              </a:spcBef>
-              <a:spcAft>
-                <a:spcPts val="800"/>
-              </a:spcAft>
-              <a:defRPr sz="2200">
-                <a:solidFill>
-                  <a:srgbClr val="FFFFFF"/>
-                </a:solidFill>
-              </a:defRPr>
-            </a:pPr>
-            <a:r>
-              <a:t>  ✅ Pre-tool hooks for security (no secrets, safe commands)</a:t>
-            </a:r>
-          </a:p>
-          <a:p>
-            <a:pPr>
-              <a:spcBef>
-                <a:spcPts val="800"/>
-              </a:spcBef>
-              <a:spcAft>
-                <a:spcPts val="800"/>
-              </a:spcAft>
-              <a:defRPr sz="2200">
-                <a:solidFill>
-                  <a:srgbClr val="FFFFFF"/>
-                </a:solidFill>
-              </a:defRPr>
-            </a:pPr>
-            <a:r>
-              <a:t>  ✅ Post-tool hooks for audit logging</a:t>
-            </a:r>
-          </a:p>
-          <a:p>
-            <a:pPr>
-              <a:spcBef>
-                <a:spcPts val="800"/>
-              </a:spcBef>
-              <a:spcAft>
-                <a:spcPts val="800"/>
-              </a:spcAft>
-              <a:defRPr sz="2200">
-                <a:solidFill>
-                  <a:srgbClr val="FFFFFF"/>
-                </a:solidFill>
-              </a:defRPr>
-            </a:pPr>
-            <a:r>
-              <a:t>  ✅ .claudeignore optimized for project</a:t>
-            </a:r>
-          </a:p>
-          <a:p>
-            <a:pPr>
-              <a:spcBef>
-                <a:spcPts val="800"/>
-              </a:spcBef>
-              <a:spcAft>
-                <a:spcPts val="800"/>
-              </a:spcAft>
-              <a:defRPr sz="2200">
-                <a:solidFill>
-                  <a:srgbClr val="FFFFFF"/>
-                </a:solidFill>
-              </a:defRPr>
-            </a:pPr>
-            <a:r>
-              <a:t>  ✅ MCP servers approved and configured</a:t>
-            </a:r>
-          </a:p>
-          <a:p>
-            <a:pPr>
-              <a:spcBef>
-                <a:spcPts val="800"/>
-              </a:spcBef>
-              <a:spcAft>
-                <a:spcPts val="800"/>
-              </a:spcAft>
-              <a:defRPr sz="2200">
-                <a:solidFill>
-                  <a:srgbClr val="FFFFFF"/>
-                </a:solidFill>
-              </a:defRPr>
-            </a:pPr>
-            <a:r>
-              <a:t>  ✅ Team training on custom commands and workflows</a:t>
-            </a:r>
-          </a:p>
-          <a:p>
-            <a:pPr>
-              <a:spcBef>
-                <a:spcPts val="800"/>
-              </a:spcBef>
-              <a:spcAft>
-                <a:spcPts val="800"/>
-              </a:spcAft>
-              <a:defRPr sz="2200">
-                <a:solidFill>
-                  <a:srgbClr val="FFFFFF"/>
-                </a:solidFill>
-              </a:defRPr>
-            </a:pPr>
-            <a:r>
-              <a:t>  ✅ Cost monitoring and budgets in place</a:t>
+              <a:t>Engineering Principle: Optimize for Maintainability Over Cleverness</a:t>
+            </a:r>
+          </a:p>
+        </p:txBody>
+      </p:sp>
+      <p:sp>
+        <p:nvSpPr>
+          <p:cNvPr id="3" name="TextBox 2"/>
+          <p:cNvSpPr txBox="1"/>
+          <p:nvPr/>
+        </p:nvSpPr>
+        <p:spPr>
+          <a:xfrm>
+            <a:off x="914400" y="3840480"/>
+            <a:ext cx="10362895" cy="914400"/>
+          </a:xfrm>
+          <a:prstGeom prst="rect">
+            <a:avLst/>
+          </a:prstGeom>
+          <a:noFill/>
+        </p:spPr>
+        <p:txBody>
+          <a:bodyPr wrap="square">
+            <a:spAutoFit/>
+          </a:bodyPr>
+          <a:lstStyle/>
+          <a:p>
+            <a:pPr algn="ctr">
+              <a:defRPr sz="2400">
+                <a:solidFill>
+                  <a:srgbClr val="8B95A5"/>
+                </a:solidFill>
+              </a:defRPr>
+            </a:pPr>
+            <a:r>
+              <a:t>Source: Nate B Jones, 'Second Brain' video</a:t>
             </a:r>
           </a:p>
         </p:txBody>
@@ -41282,14 +41325,49 @@
       <p:grpSpPr/>
       <p:sp>
         <p:nvSpPr>
-          <p:cNvPr id="2" name="Rectangle 1"/>
+          <p:cNvPr id="2" name="TextBox 1"/>
+          <p:cNvSpPr txBox="1"/>
+          <p:nvPr/>
+        </p:nvSpPr>
+        <p:spPr>
+          <a:xfrm>
+            <a:off x="457200" y="365760"/>
+            <a:ext cx="11277295" cy="822960"/>
+          </a:xfrm>
+          <a:prstGeom prst="rect">
+            <a:avLst/>
+          </a:prstGeom>
+          <a:noFill/>
+        </p:spPr>
+        <p:txBody>
+          <a:bodyPr wrap="none">
+            <a:spAutoFit/>
+          </a:bodyPr>
+          <a:lstStyle/>
+          <a:p>
+            <a:pPr>
+              <a:defRPr sz="4000" b="1">
+                <a:solidFill>
+                  <a:srgbClr val="FFFFFF"/>
+                </a:solidFill>
+              </a:defRPr>
+            </a:pPr>
+            <a:r>
+              <a:t>Production Deployment Checklist</a:t>
+            </a:r>
+          </a:p>
+        </p:txBody>
+      </p:sp>
+      <p:sp>
+        <p:nvSpPr>
+          <p:cNvPr id="3" name="Rectangle 2"/>
           <p:cNvSpPr/>
           <p:nvPr/>
         </p:nvSpPr>
         <p:spPr>
           <a:xfrm>
-            <a:off x="0" y="1828800"/>
-            <a:ext cx="137160" cy="3200400"/>
+            <a:off x="457200" y="1234440"/>
+            <a:ext cx="1828800" cy="36576"/>
           </a:xfrm>
           <a:prstGeom prst="rect">
             <a:avLst/>
@@ -41325,14 +41403,14 @@
       </p:sp>
       <p:sp>
         <p:nvSpPr>
-          <p:cNvPr id="3" name="TextBox 2"/>
+          <p:cNvPr id="4" name="TextBox 3"/>
           <p:cNvSpPr txBox="1"/>
           <p:nvPr/>
         </p:nvSpPr>
         <p:spPr>
           <a:xfrm>
-            <a:off x="457200" y="2286000"/>
-            <a:ext cx="11277295" cy="1371600"/>
+            <a:off x="457200" y="1463040"/>
+            <a:ext cx="11277295" cy="4572000"/>
           </a:xfrm>
           <a:prstGeom prst="rect">
             <a:avLst/>
@@ -41346,49 +41424,146 @@
           <a:lstStyle/>
           <a:p>
             <a:pPr>
-              <a:defRPr sz="5600" b="1">
+              <a:spcBef>
+                <a:spcPts val="800"/>
+              </a:spcBef>
+              <a:spcAft>
+                <a:spcPts val="800"/>
+              </a:spcAft>
+              <a:defRPr sz="2200">
                 <a:solidFill>
                   <a:srgbClr val="FFFFFF"/>
                 </a:solidFill>
               </a:defRPr>
             </a:pPr>
             <a:r>
-              <a:t>Wrap-up</a:t>
-            </a:r>
-          </a:p>
-        </p:txBody>
-      </p:sp>
-      <p:sp>
-        <p:nvSpPr>
-          <p:cNvPr id="4" name="TextBox 3"/>
-          <p:cNvSpPr txBox="1"/>
-          <p:nvPr/>
-        </p:nvSpPr>
-        <p:spPr>
-          <a:xfrm>
-            <a:off x="457200" y="3840480"/>
-            <a:ext cx="11277295" cy="914400"/>
-          </a:xfrm>
-          <a:prstGeom prst="rect">
-            <a:avLst/>
-          </a:prstGeom>
-          <a:noFill/>
-        </p:spPr>
-        <p:txBody>
-          <a:bodyPr wrap="square">
-            <a:spAutoFit/>
-          </a:bodyPr>
-          <a:lstStyle/>
+              <a:t>  ✅ CLAUDE.md configured with team standards</a:t>
+            </a:r>
+          </a:p>
           <a:p>
             <a:pPr>
-              <a:defRPr sz="2400">
-                <a:solidFill>
-                  <a:srgbClr val="8B95A5"/>
-                </a:solidFill>
-              </a:defRPr>
-            </a:pPr>
-            <a:r>
-              <a:t>Key takeaways and next steps</a:t>
+              <a:spcBef>
+                <a:spcPts val="800"/>
+              </a:spcBef>
+              <a:spcAft>
+                <a:spcPts val="800"/>
+              </a:spcAft>
+              <a:defRPr sz="2200">
+                <a:solidFill>
+                  <a:srgbClr val="FFFFFF"/>
+                </a:solidFill>
+              </a:defRPr>
+            </a:pPr>
+            <a:r>
+              <a:t>  ✅ Custom commands in .claude/commands/ (versioned in git)</a:t>
+            </a:r>
+          </a:p>
+          <a:p>
+            <a:pPr>
+              <a:spcBef>
+                <a:spcPts val="800"/>
+              </a:spcBef>
+              <a:spcAft>
+                <a:spcPts val="800"/>
+              </a:spcAft>
+              <a:defRPr sz="2200">
+                <a:solidFill>
+                  <a:srgbClr val="FFFFFF"/>
+                </a:solidFill>
+              </a:defRPr>
+            </a:pPr>
+            <a:r>
+              <a:t>  ✅ Pre-tool hooks for security (no secrets, safe commands)</a:t>
+            </a:r>
+          </a:p>
+          <a:p>
+            <a:pPr>
+              <a:spcBef>
+                <a:spcPts val="800"/>
+              </a:spcBef>
+              <a:spcAft>
+                <a:spcPts val="800"/>
+              </a:spcAft>
+              <a:defRPr sz="2200">
+                <a:solidFill>
+                  <a:srgbClr val="FFFFFF"/>
+                </a:solidFill>
+              </a:defRPr>
+            </a:pPr>
+            <a:r>
+              <a:t>  ✅ Post-tool hooks for audit logging</a:t>
+            </a:r>
+          </a:p>
+          <a:p>
+            <a:pPr>
+              <a:spcBef>
+                <a:spcPts val="800"/>
+              </a:spcBef>
+              <a:spcAft>
+                <a:spcPts val="800"/>
+              </a:spcAft>
+              <a:defRPr sz="2200">
+                <a:solidFill>
+                  <a:srgbClr val="FFFFFF"/>
+                </a:solidFill>
+              </a:defRPr>
+            </a:pPr>
+            <a:r>
+              <a:t>  ✅ .claudeignore optimized for project</a:t>
+            </a:r>
+          </a:p>
+          <a:p>
+            <a:pPr>
+              <a:spcBef>
+                <a:spcPts val="800"/>
+              </a:spcBef>
+              <a:spcAft>
+                <a:spcPts val="800"/>
+              </a:spcAft>
+              <a:defRPr sz="2200">
+                <a:solidFill>
+                  <a:srgbClr val="FFFFFF"/>
+                </a:solidFill>
+              </a:defRPr>
+            </a:pPr>
+            <a:r>
+              <a:t>  ✅ MCP servers approved and configured</a:t>
+            </a:r>
+          </a:p>
+          <a:p>
+            <a:pPr>
+              <a:spcBef>
+                <a:spcPts val="800"/>
+              </a:spcBef>
+              <a:spcAft>
+                <a:spcPts val="800"/>
+              </a:spcAft>
+              <a:defRPr sz="2200">
+                <a:solidFill>
+                  <a:srgbClr val="FFFFFF"/>
+                </a:solidFill>
+              </a:defRPr>
+            </a:pPr>
+            <a:r>
+              <a:t>  ✅ Team training on custom commands and workflows</a:t>
+            </a:r>
+          </a:p>
+          <a:p>
+            <a:pPr>
+              <a:spcBef>
+                <a:spcPts val="800"/>
+              </a:spcBef>
+              <a:spcAft>
+                <a:spcPts val="800"/>
+              </a:spcAft>
+              <a:defRPr sz="2200">
+                <a:solidFill>
+                  <a:srgbClr val="FFFFFF"/>
+                </a:solidFill>
+              </a:defRPr>
+            </a:pPr>
+            <a:r>
+              <a:t>  ✅ Cost monitoring and budgets in place</a:t>
             </a:r>
           </a:p>
         </p:txBody>
@@ -41421,49 +41596,14 @@
       <p:grpSpPr/>
       <p:sp>
         <p:nvSpPr>
-          <p:cNvPr id="2" name="TextBox 1"/>
-          <p:cNvSpPr txBox="1"/>
-          <p:nvPr/>
-        </p:nvSpPr>
-        <p:spPr>
-          <a:xfrm>
-            <a:off x="457200" y="365760"/>
-            <a:ext cx="11277295" cy="822960"/>
-          </a:xfrm>
-          <a:prstGeom prst="rect">
-            <a:avLst/>
-          </a:prstGeom>
-          <a:noFill/>
-        </p:spPr>
-        <p:txBody>
-          <a:bodyPr wrap="none">
-            <a:spAutoFit/>
-          </a:bodyPr>
-          <a:lstStyle/>
-          <a:p>
-            <a:pPr>
-              <a:defRPr sz="4000" b="1">
-                <a:solidFill>
-                  <a:srgbClr val="FFFFFF"/>
-                </a:solidFill>
-              </a:defRPr>
-            </a:pPr>
-            <a:r>
-              <a:t>Where Claude Code Still Struggles</a:t>
-            </a:r>
-          </a:p>
-        </p:txBody>
-      </p:sp>
-      <p:sp>
-        <p:nvSpPr>
-          <p:cNvPr id="3" name="Rectangle 2"/>
+          <p:cNvPr id="2" name="Rectangle 1"/>
           <p:cNvSpPr/>
           <p:nvPr/>
         </p:nvSpPr>
         <p:spPr>
           <a:xfrm>
-            <a:off x="457200" y="1234440"/>
-            <a:ext cx="1828800" cy="36576"/>
+            <a:off x="0" y="1828800"/>
+            <a:ext cx="137160" cy="3200400"/>
           </a:xfrm>
           <a:prstGeom prst="rect">
             <a:avLst/>
@@ -41494,6 +41634,76 @@
           <a:lstStyle/>
           <a:p>
             <a:pPr algn="ctr"/>
+          </a:p>
+        </p:txBody>
+      </p:sp>
+      <p:sp>
+        <p:nvSpPr>
+          <p:cNvPr id="3" name="TextBox 2"/>
+          <p:cNvSpPr txBox="1"/>
+          <p:nvPr/>
+        </p:nvSpPr>
+        <p:spPr>
+          <a:xfrm>
+            <a:off x="457200" y="2286000"/>
+            <a:ext cx="11277295" cy="1371600"/>
+          </a:xfrm>
+          <a:prstGeom prst="rect">
+            <a:avLst/>
+          </a:prstGeom>
+          <a:noFill/>
+        </p:spPr>
+        <p:txBody>
+          <a:bodyPr wrap="square">
+            <a:spAutoFit/>
+          </a:bodyPr>
+          <a:lstStyle/>
+          <a:p>
+            <a:pPr>
+              <a:defRPr sz="5600" b="1">
+                <a:solidFill>
+                  <a:srgbClr val="FFFFFF"/>
+                </a:solidFill>
+              </a:defRPr>
+            </a:pPr>
+            <a:r>
+              <a:t>Wrap-up</a:t>
+            </a:r>
+          </a:p>
+        </p:txBody>
+      </p:sp>
+      <p:sp>
+        <p:nvSpPr>
+          <p:cNvPr id="4" name="TextBox 3"/>
+          <p:cNvSpPr txBox="1"/>
+          <p:nvPr/>
+        </p:nvSpPr>
+        <p:spPr>
+          <a:xfrm>
+            <a:off x="457200" y="3840480"/>
+            <a:ext cx="11277295" cy="914400"/>
+          </a:xfrm>
+          <a:prstGeom prst="rect">
+            <a:avLst/>
+          </a:prstGeom>
+          <a:noFill/>
+        </p:spPr>
+        <p:txBody>
+          <a:bodyPr wrap="square">
+            <a:spAutoFit/>
+          </a:bodyPr>
+          <a:lstStyle/>
+          <a:p>
+            <a:pPr>
+              <a:defRPr sz="2400">
+                <a:solidFill>
+                  <a:srgbClr val="8B95A5"/>
+                </a:solidFill>
+              </a:defRPr>
+            </a:pPr>
+            <a:r>
+              <a:t>Key takeaways and next steps</a:t>
+            </a:r>
           </a:p>
         </p:txBody>
       </p:sp>
@@ -41525,14 +41735,49 @@
       <p:grpSpPr/>
       <p:sp>
         <p:nvSpPr>
-          <p:cNvPr id="2" name="Rectangle 1"/>
+          <p:cNvPr id="2" name="TextBox 1"/>
+          <p:cNvSpPr txBox="1"/>
+          <p:nvPr/>
+        </p:nvSpPr>
+        <p:spPr>
+          <a:xfrm>
+            <a:off x="457200" y="365760"/>
+            <a:ext cx="11277295" cy="822960"/>
+          </a:xfrm>
+          <a:prstGeom prst="rect">
+            <a:avLst/>
+          </a:prstGeom>
+          <a:noFill/>
+        </p:spPr>
+        <p:txBody>
+          <a:bodyPr wrap="none">
+            <a:spAutoFit/>
+          </a:bodyPr>
+          <a:lstStyle/>
+          <a:p>
+            <a:pPr>
+              <a:defRPr sz="4000" b="1">
+                <a:solidFill>
+                  <a:srgbClr val="FFFFFF"/>
+                </a:solidFill>
+              </a:defRPr>
+            </a:pPr>
+            <a:r>
+              <a:t>Where Claude Code Still Struggles</a:t>
+            </a:r>
+          </a:p>
+        </p:txBody>
+      </p:sp>
+      <p:sp>
+        <p:nvSpPr>
+          <p:cNvPr id="3" name="Rectangle 2"/>
           <p:cNvSpPr/>
           <p:nvPr/>
         </p:nvSpPr>
         <p:spPr>
           <a:xfrm>
-            <a:off x="0" y="1188720"/>
-            <a:ext cx="91440" cy="5029200"/>
+            <a:off x="457200" y="1234440"/>
+            <a:ext cx="1828800" cy="36576"/>
           </a:xfrm>
           <a:prstGeom prst="rect">
             <a:avLst/>
@@ -41563,719 +41808,6 @@
           <a:lstStyle/>
           <a:p>
             <a:pPr algn="ctr"/>
-          </a:p>
-        </p:txBody>
-      </p:sp>
-      <p:sp>
-        <p:nvSpPr>
-          <p:cNvPr id="3" name="TextBox 2"/>
-          <p:cNvSpPr txBox="1"/>
-          <p:nvPr/>
-        </p:nvSpPr>
-        <p:spPr>
-          <a:xfrm>
-            <a:off x="457200" y="365760"/>
-            <a:ext cx="11277295" cy="822960"/>
-          </a:xfrm>
-          <a:prstGeom prst="rect">
-            <a:avLst/>
-          </a:prstGeom>
-          <a:noFill/>
-        </p:spPr>
-        <p:txBody>
-          <a:bodyPr wrap="none">
-            <a:spAutoFit/>
-          </a:bodyPr>
-          <a:lstStyle/>
-          <a:p>
-            <a:pPr>
-              <a:defRPr sz="4000" b="1">
-                <a:solidFill>
-                  <a:srgbClr val="FFFFFF"/>
-                </a:solidFill>
-              </a:defRPr>
-            </a:pPr>
-            <a:r>
-              <a:t>Day 3 Key Takeaways</a:t>
-            </a:r>
-          </a:p>
-        </p:txBody>
-      </p:sp>
-      <p:sp>
-        <p:nvSpPr>
-          <p:cNvPr id="4" name="Oval 3"/>
-          <p:cNvSpPr/>
-          <p:nvPr/>
-        </p:nvSpPr>
-        <p:spPr>
-          <a:xfrm>
-            <a:off x="457200" y="1371600"/>
-            <a:ext cx="411480" cy="411480"/>
-          </a:xfrm>
-          <a:prstGeom prst="ellipse">
-            <a:avLst/>
-          </a:prstGeom>
-          <a:solidFill>
-            <a:srgbClr val="00D4AA"/>
-          </a:solidFill>
-          <a:ln>
-            <a:noFill/>
-          </a:ln>
-        </p:spPr>
-        <p:style>
-          <a:lnRef idx="1">
-            <a:schemeClr val="accent1"/>
-          </a:lnRef>
-          <a:fillRef idx="3">
-            <a:schemeClr val="accent1"/>
-          </a:fillRef>
-          <a:effectRef idx="2">
-            <a:schemeClr val="accent1"/>
-          </a:effectRef>
-          <a:fontRef idx="minor">
-            <a:schemeClr val="lt1"/>
-          </a:fontRef>
-        </p:style>
-        <p:txBody>
-          <a:bodyPr rtlCol="0" anchor="ctr"/>
-          <a:lstStyle/>
-          <a:p>
-            <a:pPr algn="ctr"/>
-          </a:p>
-        </p:txBody>
-      </p:sp>
-      <p:sp>
-        <p:nvSpPr>
-          <p:cNvPr id="5" name="TextBox 4"/>
-          <p:cNvSpPr txBox="1"/>
-          <p:nvPr/>
-        </p:nvSpPr>
-        <p:spPr>
-          <a:xfrm>
-            <a:off x="457200" y="1371600"/>
-            <a:ext cx="411480" cy="411480"/>
-          </a:xfrm>
-          <a:prstGeom prst="rect">
-            <a:avLst/>
-          </a:prstGeom>
-          <a:noFill/>
-        </p:spPr>
-        <p:txBody>
-          <a:bodyPr wrap="none" anchor="ctr">
-            <a:spAutoFit/>
-          </a:bodyPr>
-          <a:lstStyle/>
-          <a:p>
-            <a:pPr algn="ctr">
-              <a:defRPr sz="2000" b="1">
-                <a:solidFill>
-                  <a:srgbClr val="0B0F1A"/>
-                </a:solidFill>
-              </a:defRPr>
-            </a:pPr>
-            <a:r>
-              <a:t>v</a:t>
-            </a:r>
-          </a:p>
-        </p:txBody>
-      </p:sp>
-      <p:sp>
-        <p:nvSpPr>
-          <p:cNvPr id="6" name="TextBox 5"/>
-          <p:cNvSpPr txBox="1"/>
-          <p:nvPr/>
-        </p:nvSpPr>
-        <p:spPr>
-          <a:xfrm>
-            <a:off x="1005840" y="1417320"/>
-            <a:ext cx="10728655" cy="731520"/>
-          </a:xfrm>
-          <a:prstGeom prst="rect">
-            <a:avLst/>
-          </a:prstGeom>
-          <a:noFill/>
-        </p:spPr>
-        <p:txBody>
-          <a:bodyPr wrap="square">
-            <a:spAutoFit/>
-          </a:bodyPr>
-          <a:lstStyle/>
-          <a:p>
-            <a:pPr>
-              <a:defRPr sz="2200">
-                <a:solidFill>
-                  <a:srgbClr val="FFFFFF"/>
-                </a:solidFill>
-              </a:defRPr>
-            </a:pPr>
-            <a:r>
-              <a:t>Custom commands: Reusable workflows in .claude/commands/</a:t>
-            </a:r>
-          </a:p>
-        </p:txBody>
-      </p:sp>
-      <p:sp>
-        <p:nvSpPr>
-          <p:cNvPr id="7" name="Oval 6"/>
-          <p:cNvSpPr/>
-          <p:nvPr/>
-        </p:nvSpPr>
-        <p:spPr>
-          <a:xfrm>
-            <a:off x="457200" y="2194560"/>
-            <a:ext cx="411480" cy="411480"/>
-          </a:xfrm>
-          <a:prstGeom prst="ellipse">
-            <a:avLst/>
-          </a:prstGeom>
-          <a:solidFill>
-            <a:srgbClr val="00D4AA"/>
-          </a:solidFill>
-          <a:ln>
-            <a:noFill/>
-          </a:ln>
-        </p:spPr>
-        <p:style>
-          <a:lnRef idx="1">
-            <a:schemeClr val="accent1"/>
-          </a:lnRef>
-          <a:fillRef idx="3">
-            <a:schemeClr val="accent1"/>
-          </a:fillRef>
-          <a:effectRef idx="2">
-            <a:schemeClr val="accent1"/>
-          </a:effectRef>
-          <a:fontRef idx="minor">
-            <a:schemeClr val="lt1"/>
-          </a:fontRef>
-        </p:style>
-        <p:txBody>
-          <a:bodyPr rtlCol="0" anchor="ctr"/>
-          <a:lstStyle/>
-          <a:p>
-            <a:pPr algn="ctr"/>
-          </a:p>
-        </p:txBody>
-      </p:sp>
-      <p:sp>
-        <p:nvSpPr>
-          <p:cNvPr id="8" name="TextBox 7"/>
-          <p:cNvSpPr txBox="1"/>
-          <p:nvPr/>
-        </p:nvSpPr>
-        <p:spPr>
-          <a:xfrm>
-            <a:off x="457200" y="2194560"/>
-            <a:ext cx="411480" cy="411480"/>
-          </a:xfrm>
-          <a:prstGeom prst="rect">
-            <a:avLst/>
-          </a:prstGeom>
-          <a:noFill/>
-        </p:spPr>
-        <p:txBody>
-          <a:bodyPr wrap="none" anchor="ctr">
-            <a:spAutoFit/>
-          </a:bodyPr>
-          <a:lstStyle/>
-          <a:p>
-            <a:pPr algn="ctr">
-              <a:defRPr sz="2000" b="1">
-                <a:solidFill>
-                  <a:srgbClr val="0B0F1A"/>
-                </a:solidFill>
-              </a:defRPr>
-            </a:pPr>
-            <a:r>
-              <a:t>v</a:t>
-            </a:r>
-          </a:p>
-        </p:txBody>
-      </p:sp>
-      <p:sp>
-        <p:nvSpPr>
-          <p:cNvPr id="9" name="TextBox 8"/>
-          <p:cNvSpPr txBox="1"/>
-          <p:nvPr/>
-        </p:nvSpPr>
-        <p:spPr>
-          <a:xfrm>
-            <a:off x="1005840" y="2240280"/>
-            <a:ext cx="10728655" cy="731520"/>
-          </a:xfrm>
-          <a:prstGeom prst="rect">
-            <a:avLst/>
-          </a:prstGeom>
-          <a:noFill/>
-        </p:spPr>
-        <p:txBody>
-          <a:bodyPr wrap="square">
-            <a:spAutoFit/>
-          </a:bodyPr>
-          <a:lstStyle/>
-          <a:p>
-            <a:pPr>
-              <a:defRPr sz="2200">
-                <a:solidFill>
-                  <a:srgbClr val="FFFFFF"/>
-                </a:solidFill>
-              </a:defRPr>
-            </a:pPr>
-            <a:r>
-              <a:t>Subagents: Specialized AI workers for focused tasks</a:t>
-            </a:r>
-          </a:p>
-        </p:txBody>
-      </p:sp>
-      <p:sp>
-        <p:nvSpPr>
-          <p:cNvPr id="10" name="Oval 9"/>
-          <p:cNvSpPr/>
-          <p:nvPr/>
-        </p:nvSpPr>
-        <p:spPr>
-          <a:xfrm>
-            <a:off x="457200" y="3017520"/>
-            <a:ext cx="411480" cy="411480"/>
-          </a:xfrm>
-          <a:prstGeom prst="ellipse">
-            <a:avLst/>
-          </a:prstGeom>
-          <a:solidFill>
-            <a:srgbClr val="00D4AA"/>
-          </a:solidFill>
-          <a:ln>
-            <a:noFill/>
-          </a:ln>
-        </p:spPr>
-        <p:style>
-          <a:lnRef idx="1">
-            <a:schemeClr val="accent1"/>
-          </a:lnRef>
-          <a:fillRef idx="3">
-            <a:schemeClr val="accent1"/>
-          </a:fillRef>
-          <a:effectRef idx="2">
-            <a:schemeClr val="accent1"/>
-          </a:effectRef>
-          <a:fontRef idx="minor">
-            <a:schemeClr val="lt1"/>
-          </a:fontRef>
-        </p:style>
-        <p:txBody>
-          <a:bodyPr rtlCol="0" anchor="ctr"/>
-          <a:lstStyle/>
-          <a:p>
-            <a:pPr algn="ctr"/>
-          </a:p>
-        </p:txBody>
-      </p:sp>
-      <p:sp>
-        <p:nvSpPr>
-          <p:cNvPr id="11" name="TextBox 10"/>
-          <p:cNvSpPr txBox="1"/>
-          <p:nvPr/>
-        </p:nvSpPr>
-        <p:spPr>
-          <a:xfrm>
-            <a:off x="457200" y="3017520"/>
-            <a:ext cx="411480" cy="411480"/>
-          </a:xfrm>
-          <a:prstGeom prst="rect">
-            <a:avLst/>
-          </a:prstGeom>
-          <a:noFill/>
-        </p:spPr>
-        <p:txBody>
-          <a:bodyPr wrap="none" anchor="ctr">
-            <a:spAutoFit/>
-          </a:bodyPr>
-          <a:lstStyle/>
-          <a:p>
-            <a:pPr algn="ctr">
-              <a:defRPr sz="2000" b="1">
-                <a:solidFill>
-                  <a:srgbClr val="0B0F1A"/>
-                </a:solidFill>
-              </a:defRPr>
-            </a:pPr>
-            <a:r>
-              <a:t>v</a:t>
-            </a:r>
-          </a:p>
-        </p:txBody>
-      </p:sp>
-      <p:sp>
-        <p:nvSpPr>
-          <p:cNvPr id="12" name="TextBox 11"/>
-          <p:cNvSpPr txBox="1"/>
-          <p:nvPr/>
-        </p:nvSpPr>
-        <p:spPr>
-          <a:xfrm>
-            <a:off x="1005840" y="3063240"/>
-            <a:ext cx="10728655" cy="731520"/>
-          </a:xfrm>
-          <a:prstGeom prst="rect">
-            <a:avLst/>
-          </a:prstGeom>
-          <a:noFill/>
-        </p:spPr>
-        <p:txBody>
-          <a:bodyPr wrap="square">
-            <a:spAutoFit/>
-          </a:bodyPr>
-          <a:lstStyle/>
-          <a:p>
-            <a:pPr>
-              <a:defRPr sz="2200">
-                <a:solidFill>
-                  <a:srgbClr val="FFFFFF"/>
-                </a:solidFill>
-              </a:defRPr>
-            </a:pPr>
-            <a:r>
-              <a:t>Hooks: Safety guardrails and audit logging</a:t>
-            </a:r>
-          </a:p>
-        </p:txBody>
-      </p:sp>
-      <p:sp>
-        <p:nvSpPr>
-          <p:cNvPr id="13" name="Oval 12"/>
-          <p:cNvSpPr/>
-          <p:nvPr/>
-        </p:nvSpPr>
-        <p:spPr>
-          <a:xfrm>
-            <a:off x="457200" y="3840480"/>
-            <a:ext cx="411480" cy="411480"/>
-          </a:xfrm>
-          <a:prstGeom prst="ellipse">
-            <a:avLst/>
-          </a:prstGeom>
-          <a:solidFill>
-            <a:srgbClr val="00D4AA"/>
-          </a:solidFill>
-          <a:ln>
-            <a:noFill/>
-          </a:ln>
-        </p:spPr>
-        <p:style>
-          <a:lnRef idx="1">
-            <a:schemeClr val="accent1"/>
-          </a:lnRef>
-          <a:fillRef idx="3">
-            <a:schemeClr val="accent1"/>
-          </a:fillRef>
-          <a:effectRef idx="2">
-            <a:schemeClr val="accent1"/>
-          </a:effectRef>
-          <a:fontRef idx="minor">
-            <a:schemeClr val="lt1"/>
-          </a:fontRef>
-        </p:style>
-        <p:txBody>
-          <a:bodyPr rtlCol="0" anchor="ctr"/>
-          <a:lstStyle/>
-          <a:p>
-            <a:pPr algn="ctr"/>
-          </a:p>
-        </p:txBody>
-      </p:sp>
-      <p:sp>
-        <p:nvSpPr>
-          <p:cNvPr id="14" name="TextBox 13"/>
-          <p:cNvSpPr txBox="1"/>
-          <p:nvPr/>
-        </p:nvSpPr>
-        <p:spPr>
-          <a:xfrm>
-            <a:off x="457200" y="3840480"/>
-            <a:ext cx="411480" cy="411480"/>
-          </a:xfrm>
-          <a:prstGeom prst="rect">
-            <a:avLst/>
-          </a:prstGeom>
-          <a:noFill/>
-        </p:spPr>
-        <p:txBody>
-          <a:bodyPr wrap="none" anchor="ctr">
-            <a:spAutoFit/>
-          </a:bodyPr>
-          <a:lstStyle/>
-          <a:p>
-            <a:pPr algn="ctr">
-              <a:defRPr sz="2000" b="1">
-                <a:solidFill>
-                  <a:srgbClr val="0B0F1A"/>
-                </a:solidFill>
-              </a:defRPr>
-            </a:pPr>
-            <a:r>
-              <a:t>v</a:t>
-            </a:r>
-          </a:p>
-        </p:txBody>
-      </p:sp>
-      <p:sp>
-        <p:nvSpPr>
-          <p:cNvPr id="15" name="TextBox 14"/>
-          <p:cNvSpPr txBox="1"/>
-          <p:nvPr/>
-        </p:nvSpPr>
-        <p:spPr>
-          <a:xfrm>
-            <a:off x="1005840" y="3886200"/>
-            <a:ext cx="10728655" cy="731520"/>
-          </a:xfrm>
-          <a:prstGeom prst="rect">
-            <a:avLst/>
-          </a:prstGeom>
-          <a:noFill/>
-        </p:spPr>
-        <p:txBody>
-          <a:bodyPr wrap="square">
-            <a:spAutoFit/>
-          </a:bodyPr>
-          <a:lstStyle/>
-          <a:p>
-            <a:pPr>
-              <a:defRPr sz="2200">
-                <a:solidFill>
-                  <a:srgbClr val="FFFFFF"/>
-                </a:solidFill>
-              </a:defRPr>
-            </a:pPr>
-            <a:r>
-              <a:t>Plan mode + thinking levels: Control quality/speed/cost tradeoffs</a:t>
-            </a:r>
-          </a:p>
-        </p:txBody>
-      </p:sp>
-      <p:sp>
-        <p:nvSpPr>
-          <p:cNvPr id="16" name="Oval 15"/>
-          <p:cNvSpPr/>
-          <p:nvPr/>
-        </p:nvSpPr>
-        <p:spPr>
-          <a:xfrm>
-            <a:off x="457200" y="4663440"/>
-            <a:ext cx="411480" cy="411480"/>
-          </a:xfrm>
-          <a:prstGeom prst="ellipse">
-            <a:avLst/>
-          </a:prstGeom>
-          <a:solidFill>
-            <a:srgbClr val="00D4AA"/>
-          </a:solidFill>
-          <a:ln>
-            <a:noFill/>
-          </a:ln>
-        </p:spPr>
-        <p:style>
-          <a:lnRef idx="1">
-            <a:schemeClr val="accent1"/>
-          </a:lnRef>
-          <a:fillRef idx="3">
-            <a:schemeClr val="accent1"/>
-          </a:fillRef>
-          <a:effectRef idx="2">
-            <a:schemeClr val="accent1"/>
-          </a:effectRef>
-          <a:fontRef idx="minor">
-            <a:schemeClr val="lt1"/>
-          </a:fontRef>
-        </p:style>
-        <p:txBody>
-          <a:bodyPr rtlCol="0" anchor="ctr"/>
-          <a:lstStyle/>
-          <a:p>
-            <a:pPr algn="ctr"/>
-          </a:p>
-        </p:txBody>
-      </p:sp>
-      <p:sp>
-        <p:nvSpPr>
-          <p:cNvPr id="17" name="TextBox 16"/>
-          <p:cNvSpPr txBox="1"/>
-          <p:nvPr/>
-        </p:nvSpPr>
-        <p:spPr>
-          <a:xfrm>
-            <a:off x="457200" y="4663440"/>
-            <a:ext cx="411480" cy="411480"/>
-          </a:xfrm>
-          <a:prstGeom prst="rect">
-            <a:avLst/>
-          </a:prstGeom>
-          <a:noFill/>
-        </p:spPr>
-        <p:txBody>
-          <a:bodyPr wrap="none" anchor="ctr">
-            <a:spAutoFit/>
-          </a:bodyPr>
-          <a:lstStyle/>
-          <a:p>
-            <a:pPr algn="ctr">
-              <a:defRPr sz="2000" b="1">
-                <a:solidFill>
-                  <a:srgbClr val="0B0F1A"/>
-                </a:solidFill>
-              </a:defRPr>
-            </a:pPr>
-            <a:r>
-              <a:t>v</a:t>
-            </a:r>
-          </a:p>
-        </p:txBody>
-      </p:sp>
-      <p:sp>
-        <p:nvSpPr>
-          <p:cNvPr id="18" name="TextBox 17"/>
-          <p:cNvSpPr txBox="1"/>
-          <p:nvPr/>
-        </p:nvSpPr>
-        <p:spPr>
-          <a:xfrm>
-            <a:off x="1005840" y="4709160"/>
-            <a:ext cx="10728655" cy="731520"/>
-          </a:xfrm>
-          <a:prstGeom prst="rect">
-            <a:avLst/>
-          </a:prstGeom>
-          <a:noFill/>
-        </p:spPr>
-        <p:txBody>
-          <a:bodyPr wrap="square">
-            <a:spAutoFit/>
-          </a:bodyPr>
-          <a:lstStyle/>
-          <a:p>
-            <a:pPr>
-              <a:defRPr sz="2200">
-                <a:solidFill>
-                  <a:srgbClr val="FFFFFF"/>
-                </a:solidFill>
-              </a:defRPr>
-            </a:pPr>
-            <a:r>
-              <a:t>MCP: Connect Claude to any external system</a:t>
-            </a:r>
-          </a:p>
-        </p:txBody>
-      </p:sp>
-      <p:sp>
-        <p:nvSpPr>
-          <p:cNvPr id="19" name="Oval 18"/>
-          <p:cNvSpPr/>
-          <p:nvPr/>
-        </p:nvSpPr>
-        <p:spPr>
-          <a:xfrm>
-            <a:off x="457200" y="5486400"/>
-            <a:ext cx="411480" cy="411480"/>
-          </a:xfrm>
-          <a:prstGeom prst="ellipse">
-            <a:avLst/>
-          </a:prstGeom>
-          <a:solidFill>
-            <a:srgbClr val="00D4AA"/>
-          </a:solidFill>
-          <a:ln>
-            <a:noFill/>
-          </a:ln>
-        </p:spPr>
-        <p:style>
-          <a:lnRef idx="1">
-            <a:schemeClr val="accent1"/>
-          </a:lnRef>
-          <a:fillRef idx="3">
-            <a:schemeClr val="accent1"/>
-          </a:fillRef>
-          <a:effectRef idx="2">
-            <a:schemeClr val="accent1"/>
-          </a:effectRef>
-          <a:fontRef idx="minor">
-            <a:schemeClr val="lt1"/>
-          </a:fontRef>
-        </p:style>
-        <p:txBody>
-          <a:bodyPr rtlCol="0" anchor="ctr"/>
-          <a:lstStyle/>
-          <a:p>
-            <a:pPr algn="ctr"/>
-          </a:p>
-        </p:txBody>
-      </p:sp>
-      <p:sp>
-        <p:nvSpPr>
-          <p:cNvPr id="20" name="TextBox 19"/>
-          <p:cNvSpPr txBox="1"/>
-          <p:nvPr/>
-        </p:nvSpPr>
-        <p:spPr>
-          <a:xfrm>
-            <a:off x="457200" y="5486400"/>
-            <a:ext cx="411480" cy="411480"/>
-          </a:xfrm>
-          <a:prstGeom prst="rect">
-            <a:avLst/>
-          </a:prstGeom>
-          <a:noFill/>
-        </p:spPr>
-        <p:txBody>
-          <a:bodyPr wrap="none" anchor="ctr">
-            <a:spAutoFit/>
-          </a:bodyPr>
-          <a:lstStyle/>
-          <a:p>
-            <a:pPr algn="ctr">
-              <a:defRPr sz="2000" b="1">
-                <a:solidFill>
-                  <a:srgbClr val="0B0F1A"/>
-                </a:solidFill>
-              </a:defRPr>
-            </a:pPr>
-            <a:r>
-              <a:t>v</a:t>
-            </a:r>
-          </a:p>
-        </p:txBody>
-      </p:sp>
-      <p:sp>
-        <p:nvSpPr>
-          <p:cNvPr id="21" name="TextBox 20"/>
-          <p:cNvSpPr txBox="1"/>
-          <p:nvPr/>
-        </p:nvSpPr>
-        <p:spPr>
-          <a:xfrm>
-            <a:off x="1005840" y="5532120"/>
-            <a:ext cx="10728655" cy="731520"/>
-          </a:xfrm>
-          <a:prstGeom prst="rect">
-            <a:avLst/>
-          </a:prstGeom>
-          <a:noFill/>
-        </p:spPr>
-        <p:txBody>
-          <a:bodyPr wrap="square">
-            <a:spAutoFit/>
-          </a:bodyPr>
-          <a:lstStyle/>
-          <a:p>
-            <a:pPr>
-              <a:defRPr sz="2200">
-                <a:solidFill>
-                  <a:srgbClr val="FFFFFF"/>
-                </a:solidFill>
-              </a:defRPr>
-            </a:pPr>
-            <a:r>
-              <a:t>Agent Teams: Parallel coordination for complex work</a:t>
-            </a:r>
           </a:p>
         </p:txBody>
       </p:sp>
@@ -42307,49 +41839,14 @@
       <p:grpSpPr/>
       <p:sp>
         <p:nvSpPr>
-          <p:cNvPr id="2" name="TextBox 1"/>
-          <p:cNvSpPr txBox="1"/>
-          <p:nvPr/>
-        </p:nvSpPr>
-        <p:spPr>
-          <a:xfrm>
-            <a:off x="457200" y="365760"/>
-            <a:ext cx="11277295" cy="822960"/>
-          </a:xfrm>
-          <a:prstGeom prst="rect">
-            <a:avLst/>
-          </a:prstGeom>
-          <a:noFill/>
-        </p:spPr>
-        <p:txBody>
-          <a:bodyPr wrap="none">
-            <a:spAutoFit/>
-          </a:bodyPr>
-          <a:lstStyle/>
-          <a:p>
-            <a:pPr>
-              <a:defRPr sz="4000" b="1">
-                <a:solidFill>
-                  <a:srgbClr val="FFFFFF"/>
-                </a:solidFill>
-              </a:defRPr>
-            </a:pPr>
-            <a:r>
-              <a:t>Getting Started Roadmap</a:t>
-            </a:r>
-          </a:p>
-        </p:txBody>
-      </p:sp>
-      <p:sp>
-        <p:nvSpPr>
-          <p:cNvPr id="3" name="Rectangle 2"/>
+          <p:cNvPr id="2" name="Rectangle 1"/>
           <p:cNvSpPr/>
           <p:nvPr/>
         </p:nvSpPr>
         <p:spPr>
           <a:xfrm>
-            <a:off x="457200" y="1234440"/>
-            <a:ext cx="1828800" cy="36576"/>
+            <a:off x="0" y="1188720"/>
+            <a:ext cx="91440" cy="5029200"/>
           </a:xfrm>
           <a:prstGeom prst="rect">
             <a:avLst/>
@@ -42385,14 +41882,127 @@
       </p:sp>
       <p:sp>
         <p:nvSpPr>
-          <p:cNvPr id="4" name="TextBox 3"/>
+          <p:cNvPr id="3" name="TextBox 2"/>
           <p:cNvSpPr txBox="1"/>
           <p:nvPr/>
         </p:nvSpPr>
         <p:spPr>
           <a:xfrm>
-            <a:off x="457200" y="1463040"/>
-            <a:ext cx="11277295" cy="4572000"/>
+            <a:off x="457200" y="365760"/>
+            <a:ext cx="11277295" cy="822960"/>
+          </a:xfrm>
+          <a:prstGeom prst="rect">
+            <a:avLst/>
+          </a:prstGeom>
+          <a:noFill/>
+        </p:spPr>
+        <p:txBody>
+          <a:bodyPr wrap="none">
+            <a:spAutoFit/>
+          </a:bodyPr>
+          <a:lstStyle/>
+          <a:p>
+            <a:pPr>
+              <a:defRPr sz="4000" b="1">
+                <a:solidFill>
+                  <a:srgbClr val="FFFFFF"/>
+                </a:solidFill>
+              </a:defRPr>
+            </a:pPr>
+            <a:r>
+              <a:t>Day 3 Key Takeaways</a:t>
+            </a:r>
+          </a:p>
+        </p:txBody>
+      </p:sp>
+      <p:sp>
+        <p:nvSpPr>
+          <p:cNvPr id="4" name="Oval 3"/>
+          <p:cNvSpPr/>
+          <p:nvPr/>
+        </p:nvSpPr>
+        <p:spPr>
+          <a:xfrm>
+            <a:off x="457200" y="1371600"/>
+            <a:ext cx="411480" cy="411480"/>
+          </a:xfrm>
+          <a:prstGeom prst="ellipse">
+            <a:avLst/>
+          </a:prstGeom>
+          <a:solidFill>
+            <a:srgbClr val="00D4AA"/>
+          </a:solidFill>
+          <a:ln>
+            <a:noFill/>
+          </a:ln>
+        </p:spPr>
+        <p:style>
+          <a:lnRef idx="1">
+            <a:schemeClr val="accent1"/>
+          </a:lnRef>
+          <a:fillRef idx="3">
+            <a:schemeClr val="accent1"/>
+          </a:fillRef>
+          <a:effectRef idx="2">
+            <a:schemeClr val="accent1"/>
+          </a:effectRef>
+          <a:fontRef idx="minor">
+            <a:schemeClr val="lt1"/>
+          </a:fontRef>
+        </p:style>
+        <p:txBody>
+          <a:bodyPr rtlCol="0" anchor="ctr"/>
+          <a:lstStyle/>
+          <a:p>
+            <a:pPr algn="ctr"/>
+          </a:p>
+        </p:txBody>
+      </p:sp>
+      <p:sp>
+        <p:nvSpPr>
+          <p:cNvPr id="5" name="TextBox 4"/>
+          <p:cNvSpPr txBox="1"/>
+          <p:nvPr/>
+        </p:nvSpPr>
+        <p:spPr>
+          <a:xfrm>
+            <a:off x="457200" y="1371600"/>
+            <a:ext cx="411480" cy="411480"/>
+          </a:xfrm>
+          <a:prstGeom prst="rect">
+            <a:avLst/>
+          </a:prstGeom>
+          <a:noFill/>
+        </p:spPr>
+        <p:txBody>
+          <a:bodyPr wrap="none" anchor="ctr">
+            <a:spAutoFit/>
+          </a:bodyPr>
+          <a:lstStyle/>
+          <a:p>
+            <a:pPr algn="ctr">
+              <a:defRPr sz="2000" b="1">
+                <a:solidFill>
+                  <a:srgbClr val="0B0F1A"/>
+                </a:solidFill>
+              </a:defRPr>
+            </a:pPr>
+            <a:r>
+              <a:t>v</a:t>
+            </a:r>
+          </a:p>
+        </p:txBody>
+      </p:sp>
+      <p:sp>
+        <p:nvSpPr>
+          <p:cNvPr id="6" name="TextBox 5"/>
+          <p:cNvSpPr txBox="1"/>
+          <p:nvPr/>
+        </p:nvSpPr>
+        <p:spPr>
+          <a:xfrm>
+            <a:off x="1005840" y="1417320"/>
+            <a:ext cx="10728655" cy="731520"/>
           </a:xfrm>
           <a:prstGeom prst="rect">
             <a:avLst/>
@@ -42406,12 +42016,6 @@
           <a:lstStyle/>
           <a:p>
             <a:pPr>
-              <a:spcBef>
-                <a:spcPts val="800"/>
-              </a:spcBef>
-              <a:spcAft>
-                <a:spcPts val="800"/>
-              </a:spcAft>
               <a:defRPr sz="2200">
                 <a:solidFill>
                   <a:srgbClr val="FFFFFF"/>
@@ -42419,17 +42023,112 @@
               </a:defRPr>
             </a:pPr>
             <a:r>
-              <a:t>  Week 1: Create 2-3 custom commands for your daily workflows</a:t>
-            </a:r>
-          </a:p>
+              <a:t>Custom commands: Reusable workflows in .claude/commands/</a:t>
+            </a:r>
+          </a:p>
+        </p:txBody>
+      </p:sp>
+      <p:sp>
+        <p:nvSpPr>
+          <p:cNvPr id="7" name="Oval 6"/>
+          <p:cNvSpPr/>
+          <p:nvPr/>
+        </p:nvSpPr>
+        <p:spPr>
+          <a:xfrm>
+            <a:off x="457200" y="2194560"/>
+            <a:ext cx="411480" cy="411480"/>
+          </a:xfrm>
+          <a:prstGeom prst="ellipse">
+            <a:avLst/>
+          </a:prstGeom>
+          <a:solidFill>
+            <a:srgbClr val="00D4AA"/>
+          </a:solidFill>
+          <a:ln>
+            <a:noFill/>
+          </a:ln>
+        </p:spPr>
+        <p:style>
+          <a:lnRef idx="1">
+            <a:schemeClr val="accent1"/>
+          </a:lnRef>
+          <a:fillRef idx="3">
+            <a:schemeClr val="accent1"/>
+          </a:fillRef>
+          <a:effectRef idx="2">
+            <a:schemeClr val="accent1"/>
+          </a:effectRef>
+          <a:fontRef idx="minor">
+            <a:schemeClr val="lt1"/>
+          </a:fontRef>
+        </p:style>
+        <p:txBody>
+          <a:bodyPr rtlCol="0" anchor="ctr"/>
+          <a:lstStyle/>
+          <a:p>
+            <a:pPr algn="ctr"/>
+          </a:p>
+        </p:txBody>
+      </p:sp>
+      <p:sp>
+        <p:nvSpPr>
+          <p:cNvPr id="8" name="TextBox 7"/>
+          <p:cNvSpPr txBox="1"/>
+          <p:nvPr/>
+        </p:nvSpPr>
+        <p:spPr>
+          <a:xfrm>
+            <a:off x="457200" y="2194560"/>
+            <a:ext cx="411480" cy="411480"/>
+          </a:xfrm>
+          <a:prstGeom prst="rect">
+            <a:avLst/>
+          </a:prstGeom>
+          <a:noFill/>
+        </p:spPr>
+        <p:txBody>
+          <a:bodyPr wrap="none" anchor="ctr">
+            <a:spAutoFit/>
+          </a:bodyPr>
+          <a:lstStyle/>
+          <a:p>
+            <a:pPr algn="ctr">
+              <a:defRPr sz="2000" b="1">
+                <a:solidFill>
+                  <a:srgbClr val="0B0F1A"/>
+                </a:solidFill>
+              </a:defRPr>
+            </a:pPr>
+            <a:r>
+              <a:t>v</a:t>
+            </a:r>
+          </a:p>
+        </p:txBody>
+      </p:sp>
+      <p:sp>
+        <p:nvSpPr>
+          <p:cNvPr id="9" name="TextBox 8"/>
+          <p:cNvSpPr txBox="1"/>
+          <p:nvPr/>
+        </p:nvSpPr>
+        <p:spPr>
+          <a:xfrm>
+            <a:off x="1005840" y="2240280"/>
+            <a:ext cx="10728655" cy="731520"/>
+          </a:xfrm>
+          <a:prstGeom prst="rect">
+            <a:avLst/>
+          </a:prstGeom>
+          <a:noFill/>
+        </p:spPr>
+        <p:txBody>
+          <a:bodyPr wrap="square">
+            <a:spAutoFit/>
+          </a:bodyPr>
+          <a:lstStyle/>
           <a:p>
             <a:pPr>
-              <a:spcBef>
-                <a:spcPts val="800"/>
-              </a:spcBef>
-              <a:spcAft>
-                <a:spcPts val="800"/>
-              </a:spcAft>
               <a:defRPr sz="2200">
                 <a:solidFill>
                   <a:srgbClr val="FFFFFF"/>
@@ -42437,17 +42136,112 @@
               </a:defRPr>
             </a:pPr>
             <a:r>
-              <a:t>  Week 2: Implement pre-tool hook for security (no secrets)</a:t>
-            </a:r>
-          </a:p>
+              <a:t>Subagents: Specialized AI workers for focused tasks</a:t>
+            </a:r>
+          </a:p>
+        </p:txBody>
+      </p:sp>
+      <p:sp>
+        <p:nvSpPr>
+          <p:cNvPr id="10" name="Oval 9"/>
+          <p:cNvSpPr/>
+          <p:nvPr/>
+        </p:nvSpPr>
+        <p:spPr>
+          <a:xfrm>
+            <a:off x="457200" y="3017520"/>
+            <a:ext cx="411480" cy="411480"/>
+          </a:xfrm>
+          <a:prstGeom prst="ellipse">
+            <a:avLst/>
+          </a:prstGeom>
+          <a:solidFill>
+            <a:srgbClr val="00D4AA"/>
+          </a:solidFill>
+          <a:ln>
+            <a:noFill/>
+          </a:ln>
+        </p:spPr>
+        <p:style>
+          <a:lnRef idx="1">
+            <a:schemeClr val="accent1"/>
+          </a:lnRef>
+          <a:fillRef idx="3">
+            <a:schemeClr val="accent1"/>
+          </a:fillRef>
+          <a:effectRef idx="2">
+            <a:schemeClr val="accent1"/>
+          </a:effectRef>
+          <a:fontRef idx="minor">
+            <a:schemeClr val="lt1"/>
+          </a:fontRef>
+        </p:style>
+        <p:txBody>
+          <a:bodyPr rtlCol="0" anchor="ctr"/>
+          <a:lstStyle/>
+          <a:p>
+            <a:pPr algn="ctr"/>
+          </a:p>
+        </p:txBody>
+      </p:sp>
+      <p:sp>
+        <p:nvSpPr>
+          <p:cNvPr id="11" name="TextBox 10"/>
+          <p:cNvSpPr txBox="1"/>
+          <p:nvPr/>
+        </p:nvSpPr>
+        <p:spPr>
+          <a:xfrm>
+            <a:off x="457200" y="3017520"/>
+            <a:ext cx="411480" cy="411480"/>
+          </a:xfrm>
+          <a:prstGeom prst="rect">
+            <a:avLst/>
+          </a:prstGeom>
+          <a:noFill/>
+        </p:spPr>
+        <p:txBody>
+          <a:bodyPr wrap="none" anchor="ctr">
+            <a:spAutoFit/>
+          </a:bodyPr>
+          <a:lstStyle/>
+          <a:p>
+            <a:pPr algn="ctr">
+              <a:defRPr sz="2000" b="1">
+                <a:solidFill>
+                  <a:srgbClr val="0B0F1A"/>
+                </a:solidFill>
+              </a:defRPr>
+            </a:pPr>
+            <a:r>
+              <a:t>v</a:t>
+            </a:r>
+          </a:p>
+        </p:txBody>
+      </p:sp>
+      <p:sp>
+        <p:nvSpPr>
+          <p:cNvPr id="12" name="TextBox 11"/>
+          <p:cNvSpPr txBox="1"/>
+          <p:nvPr/>
+        </p:nvSpPr>
+        <p:spPr>
+          <a:xfrm>
+            <a:off x="1005840" y="3063240"/>
+            <a:ext cx="10728655" cy="731520"/>
+          </a:xfrm>
+          <a:prstGeom prst="rect">
+            <a:avLst/>
+          </a:prstGeom>
+          <a:noFill/>
+        </p:spPr>
+        <p:txBody>
+          <a:bodyPr wrap="square">
+            <a:spAutoFit/>
+          </a:bodyPr>
+          <a:lstStyle/>
           <a:p>
             <a:pPr>
-              <a:spcBef>
-                <a:spcPts val="800"/>
-              </a:spcBef>
-              <a:spcAft>
-                <a:spcPts val="800"/>
-              </a:spcAft>
               <a:defRPr sz="2200">
                 <a:solidFill>
                   <a:srgbClr val="FFFFFF"/>
@@ -42455,17 +42249,112 @@
               </a:defRPr>
             </a:pPr>
             <a:r>
-              <a:t>  Week 3: Install 1 MCP server (GitHub or your most-used tool)</a:t>
-            </a:r>
-          </a:p>
+              <a:t>Hooks: Safety guardrails and audit logging</a:t>
+            </a:r>
+          </a:p>
+        </p:txBody>
+      </p:sp>
+      <p:sp>
+        <p:nvSpPr>
+          <p:cNvPr id="13" name="Oval 12"/>
+          <p:cNvSpPr/>
+          <p:nvPr/>
+        </p:nvSpPr>
+        <p:spPr>
+          <a:xfrm>
+            <a:off x="457200" y="3840480"/>
+            <a:ext cx="411480" cy="411480"/>
+          </a:xfrm>
+          <a:prstGeom prst="ellipse">
+            <a:avLst/>
+          </a:prstGeom>
+          <a:solidFill>
+            <a:srgbClr val="00D4AA"/>
+          </a:solidFill>
+          <a:ln>
+            <a:noFill/>
+          </a:ln>
+        </p:spPr>
+        <p:style>
+          <a:lnRef idx="1">
+            <a:schemeClr val="accent1"/>
+          </a:lnRef>
+          <a:fillRef idx="3">
+            <a:schemeClr val="accent1"/>
+          </a:fillRef>
+          <a:effectRef idx="2">
+            <a:schemeClr val="accent1"/>
+          </a:effectRef>
+          <a:fontRef idx="minor">
+            <a:schemeClr val="lt1"/>
+          </a:fontRef>
+        </p:style>
+        <p:txBody>
+          <a:bodyPr rtlCol="0" anchor="ctr"/>
+          <a:lstStyle/>
+          <a:p>
+            <a:pPr algn="ctr"/>
+          </a:p>
+        </p:txBody>
+      </p:sp>
+      <p:sp>
+        <p:nvSpPr>
+          <p:cNvPr id="14" name="TextBox 13"/>
+          <p:cNvSpPr txBox="1"/>
+          <p:nvPr/>
+        </p:nvSpPr>
+        <p:spPr>
+          <a:xfrm>
+            <a:off x="457200" y="3840480"/>
+            <a:ext cx="411480" cy="411480"/>
+          </a:xfrm>
+          <a:prstGeom prst="rect">
+            <a:avLst/>
+          </a:prstGeom>
+          <a:noFill/>
+        </p:spPr>
+        <p:txBody>
+          <a:bodyPr wrap="none" anchor="ctr">
+            <a:spAutoFit/>
+          </a:bodyPr>
+          <a:lstStyle/>
+          <a:p>
+            <a:pPr algn="ctr">
+              <a:defRPr sz="2000" b="1">
+                <a:solidFill>
+                  <a:srgbClr val="0B0F1A"/>
+                </a:solidFill>
+              </a:defRPr>
+            </a:pPr>
+            <a:r>
+              <a:t>v</a:t>
+            </a:r>
+          </a:p>
+        </p:txBody>
+      </p:sp>
+      <p:sp>
+        <p:nvSpPr>
+          <p:cNvPr id="15" name="TextBox 14"/>
+          <p:cNvSpPr txBox="1"/>
+          <p:nvPr/>
+        </p:nvSpPr>
+        <p:spPr>
+          <a:xfrm>
+            <a:off x="1005840" y="3886200"/>
+            <a:ext cx="10728655" cy="731520"/>
+          </a:xfrm>
+          <a:prstGeom prst="rect">
+            <a:avLst/>
+          </a:prstGeom>
+          <a:noFill/>
+        </p:spPr>
+        <p:txBody>
+          <a:bodyPr wrap="square">
+            <a:spAutoFit/>
+          </a:bodyPr>
+          <a:lstStyle/>
           <a:p>
             <a:pPr>
-              <a:spcBef>
-                <a:spcPts val="800"/>
-              </a:spcBef>
-              <a:spcAft>
-                <a:spcPts val="800"/>
-              </a:spcAft>
               <a:defRPr sz="2200">
                 <a:solidFill>
                   <a:srgbClr val="FFFFFF"/>
@@ -42473,17 +42362,112 @@
               </a:defRPr>
             </a:pPr>
             <a:r>
-              <a:t>  Week 4: Create custom subagent for your domain</a:t>
-            </a:r>
-          </a:p>
+              <a:t>Plan mode + thinking levels: Control quality/speed/cost tradeoffs</a:t>
+            </a:r>
+          </a:p>
+        </p:txBody>
+      </p:sp>
+      <p:sp>
+        <p:nvSpPr>
+          <p:cNvPr id="16" name="Oval 15"/>
+          <p:cNvSpPr/>
+          <p:nvPr/>
+        </p:nvSpPr>
+        <p:spPr>
+          <a:xfrm>
+            <a:off x="457200" y="4663440"/>
+            <a:ext cx="411480" cy="411480"/>
+          </a:xfrm>
+          <a:prstGeom prst="ellipse">
+            <a:avLst/>
+          </a:prstGeom>
+          <a:solidFill>
+            <a:srgbClr val="00D4AA"/>
+          </a:solidFill>
+          <a:ln>
+            <a:noFill/>
+          </a:ln>
+        </p:spPr>
+        <p:style>
+          <a:lnRef idx="1">
+            <a:schemeClr val="accent1"/>
+          </a:lnRef>
+          <a:fillRef idx="3">
+            <a:schemeClr val="accent1"/>
+          </a:fillRef>
+          <a:effectRef idx="2">
+            <a:schemeClr val="accent1"/>
+          </a:effectRef>
+          <a:fontRef idx="minor">
+            <a:schemeClr val="lt1"/>
+          </a:fontRef>
+        </p:style>
+        <p:txBody>
+          <a:bodyPr rtlCol="0" anchor="ctr"/>
+          <a:lstStyle/>
+          <a:p>
+            <a:pPr algn="ctr"/>
+          </a:p>
+        </p:txBody>
+      </p:sp>
+      <p:sp>
+        <p:nvSpPr>
+          <p:cNvPr id="17" name="TextBox 16"/>
+          <p:cNvSpPr txBox="1"/>
+          <p:nvPr/>
+        </p:nvSpPr>
+        <p:spPr>
+          <a:xfrm>
+            <a:off x="457200" y="4663440"/>
+            <a:ext cx="411480" cy="411480"/>
+          </a:xfrm>
+          <a:prstGeom prst="rect">
+            <a:avLst/>
+          </a:prstGeom>
+          <a:noFill/>
+        </p:spPr>
+        <p:txBody>
+          <a:bodyPr wrap="none" anchor="ctr">
+            <a:spAutoFit/>
+          </a:bodyPr>
+          <a:lstStyle/>
+          <a:p>
+            <a:pPr algn="ctr">
+              <a:defRPr sz="2000" b="1">
+                <a:solidFill>
+                  <a:srgbClr val="0B0F1A"/>
+                </a:solidFill>
+              </a:defRPr>
+            </a:pPr>
+            <a:r>
+              <a:t>v</a:t>
+            </a:r>
+          </a:p>
+        </p:txBody>
+      </p:sp>
+      <p:sp>
+        <p:nvSpPr>
+          <p:cNvPr id="18" name="TextBox 17"/>
+          <p:cNvSpPr txBox="1"/>
+          <p:nvPr/>
+        </p:nvSpPr>
+        <p:spPr>
+          <a:xfrm>
+            <a:off x="1005840" y="4709160"/>
+            <a:ext cx="10728655" cy="731520"/>
+          </a:xfrm>
+          <a:prstGeom prst="rect">
+            <a:avLst/>
+          </a:prstGeom>
+          <a:noFill/>
+        </p:spPr>
+        <p:txBody>
+          <a:bodyPr wrap="square">
+            <a:spAutoFit/>
+          </a:bodyPr>
+          <a:lstStyle/>
           <a:p>
             <a:pPr>
-              <a:spcBef>
-                <a:spcPts val="800"/>
-              </a:spcBef>
-              <a:spcAft>
-                <a:spcPts val="800"/>
-              </a:spcAft>
               <a:defRPr sz="2200">
                 <a:solidFill>
                   <a:srgbClr val="FFFFFF"/>
@@ -42491,17 +42475,112 @@
               </a:defRPr>
             </a:pPr>
             <a:r>
-              <a:t>  Month 2: Optimize CLAUDE.md with team conventions</a:t>
-            </a:r>
-          </a:p>
+              <a:t>MCP: Connect Claude to any external system</a:t>
+            </a:r>
+          </a:p>
+        </p:txBody>
+      </p:sp>
+      <p:sp>
+        <p:nvSpPr>
+          <p:cNvPr id="19" name="Oval 18"/>
+          <p:cNvSpPr/>
+          <p:nvPr/>
+        </p:nvSpPr>
+        <p:spPr>
+          <a:xfrm>
+            <a:off x="457200" y="5486400"/>
+            <a:ext cx="411480" cy="411480"/>
+          </a:xfrm>
+          <a:prstGeom prst="ellipse">
+            <a:avLst/>
+          </a:prstGeom>
+          <a:solidFill>
+            <a:srgbClr val="00D4AA"/>
+          </a:solidFill>
+          <a:ln>
+            <a:noFill/>
+          </a:ln>
+        </p:spPr>
+        <p:style>
+          <a:lnRef idx="1">
+            <a:schemeClr val="accent1"/>
+          </a:lnRef>
+          <a:fillRef idx="3">
+            <a:schemeClr val="accent1"/>
+          </a:fillRef>
+          <a:effectRef idx="2">
+            <a:schemeClr val="accent1"/>
+          </a:effectRef>
+          <a:fontRef idx="minor">
+            <a:schemeClr val="lt1"/>
+          </a:fontRef>
+        </p:style>
+        <p:txBody>
+          <a:bodyPr rtlCol="0" anchor="ctr"/>
+          <a:lstStyle/>
+          <a:p>
+            <a:pPr algn="ctr"/>
+          </a:p>
+        </p:txBody>
+      </p:sp>
+      <p:sp>
+        <p:nvSpPr>
+          <p:cNvPr id="20" name="TextBox 19"/>
+          <p:cNvSpPr txBox="1"/>
+          <p:nvPr/>
+        </p:nvSpPr>
+        <p:spPr>
+          <a:xfrm>
+            <a:off x="457200" y="5486400"/>
+            <a:ext cx="411480" cy="411480"/>
+          </a:xfrm>
+          <a:prstGeom prst="rect">
+            <a:avLst/>
+          </a:prstGeom>
+          <a:noFill/>
+        </p:spPr>
+        <p:txBody>
+          <a:bodyPr wrap="none" anchor="ctr">
+            <a:spAutoFit/>
+          </a:bodyPr>
+          <a:lstStyle/>
+          <a:p>
+            <a:pPr algn="ctr">
+              <a:defRPr sz="2000" b="1">
+                <a:solidFill>
+                  <a:srgbClr val="0B0F1A"/>
+                </a:solidFill>
+              </a:defRPr>
+            </a:pPr>
+            <a:r>
+              <a:t>v</a:t>
+            </a:r>
+          </a:p>
+        </p:txBody>
+      </p:sp>
+      <p:sp>
+        <p:nvSpPr>
+          <p:cNvPr id="21" name="TextBox 20"/>
+          <p:cNvSpPr txBox="1"/>
+          <p:nvPr/>
+        </p:nvSpPr>
+        <p:spPr>
+          <a:xfrm>
+            <a:off x="1005840" y="5532120"/>
+            <a:ext cx="10728655" cy="731520"/>
+          </a:xfrm>
+          <a:prstGeom prst="rect">
+            <a:avLst/>
+          </a:prstGeom>
+          <a:noFill/>
+        </p:spPr>
+        <p:txBody>
+          <a:bodyPr wrap="square">
+            <a:spAutoFit/>
+          </a:bodyPr>
+          <a:lstStyle/>
           <a:p>
             <a:pPr>
-              <a:spcBef>
-                <a:spcPts val="800"/>
-              </a:spcBef>
-              <a:spcAft>
-                <a:spcPts val="800"/>
-              </a:spcAft>
               <a:defRPr sz="2200">
                 <a:solidFill>
                   <a:srgbClr val="FFFFFF"/>
@@ -42509,7 +42588,7 @@
               </a:defRPr>
             </a:pPr>
             <a:r>
-              <a:t>  Month 3: Pilot Agent Teams on complex project</a:t>
+              <a:t>Agent Teams: Parallel coordination for complex work</a:t>
             </a:r>
           </a:p>
         </p:txBody>
@@ -42570,7 +42649,7 @@
               </a:defRPr>
             </a:pPr>
             <a:r>
-              <a:t>Resources</a:t>
+              <a:t>Getting Started Roadmap</a:t>
             </a:r>
           </a:p>
         </p:txBody>
@@ -42654,7 +42733,7 @@
               </a:defRPr>
             </a:pPr>
             <a:r>
-              <a:t>  Claude Code Docs: docs.anthropic.com/claude-code</a:t>
+              <a:t>  Week 1: Create 2-3 custom commands for your daily workflows</a:t>
             </a:r>
           </a:p>
           <a:p>
@@ -42672,7 +42751,7 @@
               </a:defRPr>
             </a:pPr>
             <a:r>
-              <a:t>  MCP Protocol: modelcontextprotocol.io</a:t>
+              <a:t>  Week 2: Implement pre-tool hook for security (no secrets)</a:t>
             </a:r>
           </a:p>
           <a:p>
@@ -42690,7 +42769,7 @@
               </a:defRPr>
             </a:pPr>
             <a:r>
-              <a:t>  MCP Servers: github.com/modelcontextprotocol/servers</a:t>
+              <a:t>  Week 3: Install 1 MCP server (GitHub or your most-used tool)</a:t>
             </a:r>
           </a:p>
           <a:p>
@@ -42708,7 +42787,7 @@
               </a:defRPr>
             </a:pPr>
             <a:r>
-              <a:t>  Community Commands: github.com/hesreallyhim/awesome-claude-code</a:t>
+              <a:t>  Week 4: Create custom subagent for your domain</a:t>
             </a:r>
           </a:p>
           <a:p>
@@ -42726,7 +42805,7 @@
               </a:defRPr>
             </a:pPr>
             <a:r>
-              <a:t>  Agent Teams Examples: github.com/ColeMedin/AgentTeamsExamples</a:t>
+              <a:t>  Month 2: Optimize CLAUDE.md with team conventions</a:t>
             </a:r>
           </a:p>
           <a:p>
@@ -42744,25 +42823,7 @@
               </a:defRPr>
             </a:pPr>
             <a:r>
-              <a:t>  Discord: discord.gg/anthropic-community</a:t>
-            </a:r>
-          </a:p>
-          <a:p>
-            <a:pPr>
-              <a:spcBef>
-                <a:spcPts val="800"/>
-              </a:spcBef>
-              <a:spcAft>
-                <a:spcPts val="800"/>
-              </a:spcAft>
-              <a:defRPr sz="2200">
-                <a:solidFill>
-                  <a:srgbClr val="FFFFFF"/>
-                </a:solidFill>
-              </a:defRPr>
-            </a:pPr>
-            <a:r>
-              <a:t>  Your team: Schedule follow-up in 2 weeks to share learnings</a:t>
+              <a:t>  Month 3: Pilot Agent Teams on complex project</a:t>
             </a:r>
           </a:p>
         </p:txBody>
@@ -42776,6 +42837,259 @@
 </file>
 
 <file path=ppt/slides/slide97.xml><?xml version="1.0" encoding="utf-8"?>
+<p:sld xmlns:a="http://schemas.openxmlformats.org/drawingml/2006/main" xmlns:p="http://schemas.openxmlformats.org/presentationml/2006/main" xmlns:r="http://schemas.openxmlformats.org/officeDocument/2006/relationships">
+  <p:cSld>
+    <p:bg>
+      <p:bgPr>
+        <a:solidFill>
+          <a:srgbClr val="0B0F1A"/>
+        </a:solidFill>
+        <a:effectLst/>
+      </p:bgPr>
+    </p:bg>
+    <p:spTree>
+      <p:nvGrpSpPr>
+        <p:cNvPr id="1" name=""/>
+        <p:cNvGrpSpPr/>
+        <p:nvPr/>
+      </p:nvGrpSpPr>
+      <p:grpSpPr/>
+      <p:sp>
+        <p:nvSpPr>
+          <p:cNvPr id="2" name="TextBox 1"/>
+          <p:cNvSpPr txBox="1"/>
+          <p:nvPr/>
+        </p:nvSpPr>
+        <p:spPr>
+          <a:xfrm>
+            <a:off x="457200" y="365760"/>
+            <a:ext cx="11277295" cy="822960"/>
+          </a:xfrm>
+          <a:prstGeom prst="rect">
+            <a:avLst/>
+          </a:prstGeom>
+          <a:noFill/>
+        </p:spPr>
+        <p:txBody>
+          <a:bodyPr wrap="none">
+            <a:spAutoFit/>
+          </a:bodyPr>
+          <a:lstStyle/>
+          <a:p>
+            <a:pPr>
+              <a:defRPr sz="4000" b="1">
+                <a:solidFill>
+                  <a:srgbClr val="FFFFFF"/>
+                </a:solidFill>
+              </a:defRPr>
+            </a:pPr>
+            <a:r>
+              <a:t>Resources</a:t>
+            </a:r>
+          </a:p>
+        </p:txBody>
+      </p:sp>
+      <p:sp>
+        <p:nvSpPr>
+          <p:cNvPr id="3" name="Rectangle 2"/>
+          <p:cNvSpPr/>
+          <p:nvPr/>
+        </p:nvSpPr>
+        <p:spPr>
+          <a:xfrm>
+            <a:off x="457200" y="1234440"/>
+            <a:ext cx="1828800" cy="36576"/>
+          </a:xfrm>
+          <a:prstGeom prst="rect">
+            <a:avLst/>
+          </a:prstGeom>
+          <a:solidFill>
+            <a:srgbClr val="00D4AA"/>
+          </a:solidFill>
+          <a:ln>
+            <a:noFill/>
+          </a:ln>
+        </p:spPr>
+        <p:style>
+          <a:lnRef idx="1">
+            <a:schemeClr val="accent1"/>
+          </a:lnRef>
+          <a:fillRef idx="3">
+            <a:schemeClr val="accent1"/>
+          </a:fillRef>
+          <a:effectRef idx="2">
+            <a:schemeClr val="accent1"/>
+          </a:effectRef>
+          <a:fontRef idx="minor">
+            <a:schemeClr val="lt1"/>
+          </a:fontRef>
+        </p:style>
+        <p:txBody>
+          <a:bodyPr rtlCol="0" anchor="ctr"/>
+          <a:lstStyle/>
+          <a:p>
+            <a:pPr algn="ctr"/>
+          </a:p>
+        </p:txBody>
+      </p:sp>
+      <p:sp>
+        <p:nvSpPr>
+          <p:cNvPr id="4" name="TextBox 3"/>
+          <p:cNvSpPr txBox="1"/>
+          <p:nvPr/>
+        </p:nvSpPr>
+        <p:spPr>
+          <a:xfrm>
+            <a:off x="457200" y="1463040"/>
+            <a:ext cx="11277295" cy="4572000"/>
+          </a:xfrm>
+          <a:prstGeom prst="rect">
+            <a:avLst/>
+          </a:prstGeom>
+          <a:noFill/>
+        </p:spPr>
+        <p:txBody>
+          <a:bodyPr wrap="square">
+            <a:spAutoFit/>
+          </a:bodyPr>
+          <a:lstStyle/>
+          <a:p>
+            <a:pPr>
+              <a:spcBef>
+                <a:spcPts val="800"/>
+              </a:spcBef>
+              <a:spcAft>
+                <a:spcPts val="800"/>
+              </a:spcAft>
+              <a:defRPr sz="2200">
+                <a:solidFill>
+                  <a:srgbClr val="FFFFFF"/>
+                </a:solidFill>
+              </a:defRPr>
+            </a:pPr>
+            <a:r>
+              <a:t>  Claude Code Docs: docs.anthropic.com/claude-code</a:t>
+            </a:r>
+          </a:p>
+          <a:p>
+            <a:pPr>
+              <a:spcBef>
+                <a:spcPts val="800"/>
+              </a:spcBef>
+              <a:spcAft>
+                <a:spcPts val="800"/>
+              </a:spcAft>
+              <a:defRPr sz="2200">
+                <a:solidFill>
+                  <a:srgbClr val="FFFFFF"/>
+                </a:solidFill>
+              </a:defRPr>
+            </a:pPr>
+            <a:r>
+              <a:t>  MCP Protocol: modelcontextprotocol.io</a:t>
+            </a:r>
+          </a:p>
+          <a:p>
+            <a:pPr>
+              <a:spcBef>
+                <a:spcPts val="800"/>
+              </a:spcBef>
+              <a:spcAft>
+                <a:spcPts val="800"/>
+              </a:spcAft>
+              <a:defRPr sz="2200">
+                <a:solidFill>
+                  <a:srgbClr val="FFFFFF"/>
+                </a:solidFill>
+              </a:defRPr>
+            </a:pPr>
+            <a:r>
+              <a:t>  MCP Servers: github.com/modelcontextprotocol/servers</a:t>
+            </a:r>
+          </a:p>
+          <a:p>
+            <a:pPr>
+              <a:spcBef>
+                <a:spcPts val="800"/>
+              </a:spcBef>
+              <a:spcAft>
+                <a:spcPts val="800"/>
+              </a:spcAft>
+              <a:defRPr sz="2200">
+                <a:solidFill>
+                  <a:srgbClr val="FFFFFF"/>
+                </a:solidFill>
+              </a:defRPr>
+            </a:pPr>
+            <a:r>
+              <a:t>  Community Commands: github.com/hesreallyhim/awesome-claude-code</a:t>
+            </a:r>
+          </a:p>
+          <a:p>
+            <a:pPr>
+              <a:spcBef>
+                <a:spcPts val="800"/>
+              </a:spcBef>
+              <a:spcAft>
+                <a:spcPts val="800"/>
+              </a:spcAft>
+              <a:defRPr sz="2200">
+                <a:solidFill>
+                  <a:srgbClr val="FFFFFF"/>
+                </a:solidFill>
+              </a:defRPr>
+            </a:pPr>
+            <a:r>
+              <a:t>  Agent Teams Examples: github.com/ColeMedin/AgentTeamsExamples</a:t>
+            </a:r>
+          </a:p>
+          <a:p>
+            <a:pPr>
+              <a:spcBef>
+                <a:spcPts val="800"/>
+              </a:spcBef>
+              <a:spcAft>
+                <a:spcPts val="800"/>
+              </a:spcAft>
+              <a:defRPr sz="2200">
+                <a:solidFill>
+                  <a:srgbClr val="FFFFFF"/>
+                </a:solidFill>
+              </a:defRPr>
+            </a:pPr>
+            <a:r>
+              <a:t>  Discord: discord.gg/anthropic-community</a:t>
+            </a:r>
+          </a:p>
+          <a:p>
+            <a:pPr>
+              <a:spcBef>
+                <a:spcPts val="800"/>
+              </a:spcBef>
+              <a:spcAft>
+                <a:spcPts val="800"/>
+              </a:spcAft>
+              <a:defRPr sz="2200">
+                <a:solidFill>
+                  <a:srgbClr val="FFFFFF"/>
+                </a:solidFill>
+              </a:defRPr>
+            </a:pPr>
+            <a:r>
+              <a:t>  Your team: Schedule follow-up in 2 weeks to share learnings</a:t>
+            </a:r>
+          </a:p>
+        </p:txBody>
+      </p:sp>
+    </p:spTree>
+  </p:cSld>
+  <p:clrMapOvr>
+    <a:masterClrMapping/>
+  </p:clrMapOvr>
+</p:sld>
+</file>
+
+<file path=ppt/slides/slide98.xml><?xml version="1.0" encoding="utf-8"?>
 <p:sld xmlns:a="http://schemas.openxmlformats.org/drawingml/2006/main" xmlns:p="http://schemas.openxmlformats.org/presentationml/2006/main" xmlns:r="http://schemas.openxmlformats.org/officeDocument/2006/relationships">
   <p:cSld>
     <p:bg>

</xml_diff>

<commit_message>
Day 3: Add Remote Control slide (Research Preview, Feb 24 2026)
/remote-control — start local session, continue from phone.
Split slide: How It Works + Why This Matters.
Placed after GitHub Agentic Workflows in CI/CD section.
Day 3 now 105 slides.
</commit_message>
<xml_diff>
--- a/slides/Day3_Claude_Code_Advanced.pptx
+++ b/slides/Day3_Claude_Code_Advanced.pptx
@@ -109,6 +109,7 @@
     <p:sldId id="357" r:id="rId109"/>
     <p:sldId id="358" r:id="rId110"/>
     <p:sldId id="359" r:id="rId111"/>
+    <p:sldId id="360" r:id="rId112"/>
   </p:sldIdLst>
   <p:sldSz cx="12191695" cy="6858000" type="screen4x3"/>
   <p:notesSz cx="6858000" cy="9144000"/>
@@ -11162,54 +11163,60 @@
           <a:lstStyle/>
           <a:p>
             <a:r>
-              <a:t>TIME: 4 min</a:t>
+              <a:t>TIME: 3 min</a:t>
             </a:r>
           </a:p>
           <a:p/>
           <a:p>
             <a:r>
+              <a:t>OPEN WITH:</a:t>
+            </a:r>
+          </a:p>
+          <a:p>
+            <a:r>
+              <a:t>   This just dropped — Anthropic announced Remote Control for Claude Code. It's exactly what it sounds like: start a session on your laptop, then continue it from your phone.</a:t>
+            </a:r>
+          </a:p>
+          <a:p/>
+          <a:p>
+            <a:r>
               <a:t>KEY POINTS:</a:t>
             </a:r>
           </a:p>
           <a:p>
             <a:r>
-              <a:t>   * Cost is sum of: model × thinking × context × frequency</a:t>
-            </a:r>
-          </a:p>
-          <a:p>
-            <a:r>
-              <a:t>   * Biggest saver: Haiku for research tasks</a:t>
-            </a:r>
-          </a:p>
-          <a:p>
-            <a:r>
-              <a:t>   * Second biggest: Low thinking for routine work</a:t>
-            </a:r>
-          </a:p>
-          <a:p>
-            <a:r>
-              <a:t>   * Context bloat from node_modules = wasted tokens</a:t>
-            </a:r>
-          </a:p>
-          <a:p>
-            <a:r>
-              <a:t>   * Batching 10 fixes in one session cheaper than 10 sessions</a:t>
-            </a:r>
-          </a:p>
-          <a:p>
-            <a:r>
-              <a:t>   * Measure to optimize: What tasks burn most tokens?</a:t>
+              <a:t>   * Here's the scenario that makes this click. You kick off a big refactoring task — Claude is rewriting 15 files, running tests, fixing issues. That's going to take a while. Before Remote Control, you'd sit there watching the terminal, or you'd walk away and hope nothing needed your approval. Now you type /remote-control, get a secure link, and open it on your phone. You can walk your dog, grab lunch, sit in a meeting — and when Claude needs you to approve a file deletion or confirm an approach, you tap approve on your phone.</a:t>
+            </a:r>
+          </a:p>
+          <a:p>
+            <a:r>
+              <a:t>   * The technical implementation is straightforward. Your local Claude Code session stays running on your machine where it has access to your codebase and tools. The remote link gives you a lightweight interface to the same session — you can read Claude's output, send messages, and approve or reject tool uses. The compute stays local, only the interaction layer is remote.</a:t>
+            </a:r>
+          </a:p>
+          <a:p>
+            <a:r>
+              <a:t>   * This solves a real pain point the community has been hacking around. People were setting up SSH tunnels, using tools like Happy, or running Claude Code on remote servers just to get mobile access. Now it's built in, no infrastructure required.</a:t>
+            </a:r>
+          </a:p>
+          <a:p>
+            <a:r>
+              <a:t>   * Important caveats: this is Research Preview, currently rolling out to Max plan users. It's not on Pro, Team, or Enterprise yet. And there are some early bugs — the error messages for unsupported plans aren't great yet. But the direction is clear: Claude Code is becoming a tool you can supervise from anywhere, not just from your terminal.</a:t>
             </a:r>
           </a:p>
           <a:p/>
           <a:p>
             <a:r>
-              <a:t>REAL-WORLD EXAMPLE:</a:t>
-            </a:r>
-          </a:p>
-          <a:p>
-            <a:r>
-              <a:t>   Team audit: 60% of tokens on simple test generation (was using Sonnet). Switched to Haiku subagent for tests. 70% cost reduction on that workflow.</a:t>
+              <a:t>ASK THE CLASS:</a:t>
+            </a:r>
+          </a:p>
+          <a:p>
+            <a:r>
+              <a:t>   "Think about your longest-running Claude Code tasks. How would your workflow change if you could supervise them from your phone?"</a:t>
+            </a:r>
+          </a:p>
+          <a:p>
+            <a:r>
+              <a:t>   [PAUSE for 30-60 seconds]</a:t>
             </a:r>
           </a:p>
           <a:p/>
@@ -11220,7 +11227,7 @@
           </a:p>
           <a:p>
             <a:r>
-              <a:t>   Token efficiency techniques</a:t>
+              <a:t>   Between GitHub Agentic Workflows and Remote Control, you can see where this is headed — Claude Code as a continuously running development partner, not just an interactive chat session.</a:t>
             </a:r>
           </a:p>
         </p:txBody>
@@ -11301,32 +11308,32 @@
           </a:p>
           <a:p>
             <a:r>
-              <a:t>   * /compact condenses long conversations, preserves key points</a:t>
-            </a:r>
-          </a:p>
-          <a:p>
-            <a:r>
-              <a:t>   * Fresh conversations prevent context bloat tax</a:t>
-            </a:r>
-          </a:p>
-          <a:p>
-            <a:r>
-              <a:t>   * .claudeignore can save 50-80% tokens on large projects</a:t>
-            </a:r>
-          </a:p>
-          <a:p>
-            <a:r>
-              <a:t>   * Periodic summaries compress history</a:t>
-            </a:r>
-          </a:p>
-          <a:p>
-            <a:r>
-              <a:t>   * @ mention 3 files, not 30 (be selective)</a:t>
-            </a:r>
-          </a:p>
-          <a:p>
-            <a:r>
-              <a:t>   * Plan mode offloads research to cheaper subagent</a:t>
+              <a:t>   * Cost is sum of: model × thinking × context × frequency</a:t>
+            </a:r>
+          </a:p>
+          <a:p>
+            <a:r>
+              <a:t>   * Biggest saver: Haiku for research tasks</a:t>
+            </a:r>
+          </a:p>
+          <a:p>
+            <a:r>
+              <a:t>   * Second biggest: Low thinking for routine work</a:t>
+            </a:r>
+          </a:p>
+          <a:p>
+            <a:r>
+              <a:t>   * Context bloat from node_modules = wasted tokens</a:t>
+            </a:r>
+          </a:p>
+          <a:p>
+            <a:r>
+              <a:t>   * Batching 10 fixes in one session cheaper than 10 sessions</a:t>
+            </a:r>
+          </a:p>
+          <a:p>
+            <a:r>
+              <a:t>   * Measure to optimize: What tasks burn most tokens?</a:t>
             </a:r>
           </a:p>
           <a:p/>
@@ -11337,7 +11344,7 @@
           </a:p>
           <a:p>
             <a:r>
-              <a:t>   Project with 50 files. Mentioning all 50 = 200K tokens. Using @explore to find relevant 3 files = 20K tokens. 90% savings.</a:t>
+              <a:t>   Team audit: 60% of tokens on simple test generation (was using Sonnet). Switched to Haiku subagent for tests. 70% cost reduction on that workflow.</a:t>
             </a:r>
           </a:p>
           <a:p/>
@@ -11348,7 +11355,7 @@
           </a:p>
           <a:p>
             <a:r>
-              <a:t>   Production deployment checklist</a:t>
+              <a:t>   Token efficiency techniques</a:t>
             </a:r>
           </a:p>
         </p:txBody>
@@ -11418,98 +11425,65 @@
           <a:lstStyle/>
           <a:p>
             <a:r>
-              <a:t>TIME: 2 min</a:t>
+              <a:t>TIME: 4 min</a:t>
             </a:r>
           </a:p>
           <a:p/>
           <a:p>
             <a:r>
-              <a:t>OPEN WITH:</a:t>
-            </a:r>
-          </a:p>
-          <a:p>
-            <a:r>
-              <a:t>   Nate B Jones: 'The smartest code you write today becomes the dumbest code someone else has to debug tomorrow.' Choose boring, readable solutions.</a:t>
+              <a:t>KEY POINTS:</a:t>
+            </a:r>
+          </a:p>
+          <a:p>
+            <a:r>
+              <a:t>   * /compact condenses long conversations, preserves key points</a:t>
+            </a:r>
+          </a:p>
+          <a:p>
+            <a:r>
+              <a:t>   * Fresh conversations prevent context bloat tax</a:t>
+            </a:r>
+          </a:p>
+          <a:p>
+            <a:r>
+              <a:t>   * .claudeignore can save 50-80% tokens on large projects</a:t>
+            </a:r>
+          </a:p>
+          <a:p>
+            <a:r>
+              <a:t>   * Periodic summaries compress history</a:t>
+            </a:r>
+          </a:p>
+          <a:p>
+            <a:r>
+              <a:t>   * @ mention 3 files, not 30 (be selective)</a:t>
+            </a:r>
+          </a:p>
+          <a:p>
+            <a:r>
+              <a:t>   * Plan mode offloads research to cheaper subagent</a:t>
             </a:r>
           </a:p>
           <a:p/>
           <a:p>
             <a:r>
-              <a:t>KEY POINTS:</a:t>
-            </a:r>
-          </a:p>
-          <a:p>
-            <a:r>
-              <a:t>   * Clever one-liner that saves 3 lines vs readable 10-line version a junior dev understands</a:t>
-            </a:r>
-          </a:p>
-          <a:p>
-            <a:r>
-              <a:t>   * Token efficiency matters, but not at the cost of team understanding</a:t>
-            </a:r>
-          </a:p>
-          <a:p>
-            <a:r>
-              <a:t>   * Future you (6 months later) is 'someone else' - be kind to them</a:t>
-            </a:r>
-          </a:p>
-          <a:p>
-            <a:r>
-              <a:t>   * Boring code is predictable, debuggable, maintainable</a:t>
-            </a:r>
-          </a:p>
-          <a:p>
-            <a:r>
-              <a:t>   * Ask: 'Can a junior developer maintain this?' If no, simplify</a:t>
+              <a:t>REAL-WORLD EXAMPLE:</a:t>
+            </a:r>
+          </a:p>
+          <a:p>
+            <a:r>
+              <a:t>   Project with 50 files. Mentioning all 50 = 200K tokens. Using @explore to find relevant 3 files = 20K tokens. 90% savings.</a:t>
             </a:r>
           </a:p>
           <a:p/>
           <a:p>
             <a:r>
-              <a:t>ASK THE CLASS:</a:t>
-            </a:r>
-          </a:p>
-          <a:p>
-            <a:r>
-              <a:t>   "What's the cleverest code you wrote that you later regretted?"</a:t>
-            </a:r>
-          </a:p>
-          <a:p>
-            <a:r>
-              <a:t>   [PAUSE for 30-60 seconds]</a:t>
-            </a:r>
-          </a:p>
-          <a:p/>
-          <a:p>
-            <a:r>
-              <a:t>REAL-WORLD EXAMPLE:</a:t>
-            </a:r>
-          </a:p>
-          <a:p>
-            <a:r>
-              <a:t>   Code review: Developer submits elegant regex one-liner that validates email format. Senior dev suggests 10-line version with clear steps (split @ check parts, validate domain, check TLD). Clever version: 1 line, impossible to debug. Boring version: 10 lines, obvious what each step does. Team chooses boring. Six months later, junior dev fixes bug in 5 minutes instead of 2 hours.</a:t>
-            </a:r>
-          </a:p>
-          <a:p/>
-          <a:p>
-            <a:r>
-              <a:t>DEMO:</a:t>
-            </a:r>
-          </a:p>
-          <a:p>
-            <a:r>
-              <a:t>   Show two solutions to same problem: 1) Clever: Nested ternary, regex, one-liner magic. 2) Boring: Named variables, clear conditionals, comments explaining why. Ask Claude (in demo) to evaluate both: 'Which would you rather debug at 3am?' Claude picks boring version. Emphasize Nate B Jones wisdom: 'Clever is a liability, boring is an asset.'</a:t>
-            </a:r>
-          </a:p>
-          <a:p/>
-          <a:p>
-            <a:r>
               <a:t>TRANSITION:</a:t>
             </a:r>
           </a:p>
           <a:p>
             <a:r>
-              <a:t>   This maintainability mindset is the perfect conclusion to our advanced patterns - build for the team, not for ego</a:t>
+              <a:t>   Production deployment checklist</a:t>
             </a:r>
           </a:p>
         </p:txBody>
@@ -11579,64 +11553,98 @@
           <a:lstStyle/>
           <a:p>
             <a:r>
-              <a:t>TIME: 3 min</a:t>
+              <a:t>TIME: 2 min</a:t>
             </a:r>
           </a:p>
           <a:p/>
           <a:p>
             <a:r>
+              <a:t>OPEN WITH:</a:t>
+            </a:r>
+          </a:p>
+          <a:p>
+            <a:r>
+              <a:t>   Nate B Jones: 'The smartest code you write today becomes the dumbest code someone else has to debug tomorrow.' Choose boring, readable solutions.</a:t>
+            </a:r>
+          </a:p>
+          <a:p/>
+          <a:p>
+            <a:r>
               <a:t>KEY POINTS:</a:t>
             </a:r>
           </a:p>
           <a:p>
             <a:r>
-              <a:t>   * CLAUDE.md: Team source of truth for Claude behavior</a:t>
-            </a:r>
-          </a:p>
-          <a:p>
-            <a:r>
-              <a:t>   * Commands: Shared via git, documented in README</a:t>
-            </a:r>
-          </a:p>
-          <a:p>
-            <a:r>
-              <a:t>   * Hooks: Safety and compliance from day 1</a:t>
-            </a:r>
-          </a:p>
-          <a:p>
-            <a:r>
-              <a:t>   * Audit logs: Required for enterprise compliance</a:t>
-            </a:r>
-          </a:p>
-          <a:p>
-            <a:r>
-              <a:t>   * .claudeignore: Performance and cost optimization</a:t>
-            </a:r>
-          </a:p>
-          <a:p>
-            <a:r>
-              <a:t>   * MCP: Security review before deployment</a:t>
-            </a:r>
-          </a:p>
-          <a:p>
-            <a:r>
-              <a:t>   * Training: Team knows how to use custom workflows</a:t>
-            </a:r>
-          </a:p>
-          <a:p>
-            <a:r>
-              <a:t>   * Budget: Monitor and optimize based on usage</a:t>
+              <a:t>   * Clever one-liner that saves 3 lines vs readable 10-line version a junior dev understands</a:t>
+            </a:r>
+          </a:p>
+          <a:p>
+            <a:r>
+              <a:t>   * Token efficiency matters, but not at the cost of team understanding</a:t>
+            </a:r>
+          </a:p>
+          <a:p>
+            <a:r>
+              <a:t>   * Future you (6 months later) is 'someone else' - be kind to them</a:t>
+            </a:r>
+          </a:p>
+          <a:p>
+            <a:r>
+              <a:t>   * Boring code is predictable, debuggable, maintainable</a:t>
+            </a:r>
+          </a:p>
+          <a:p>
+            <a:r>
+              <a:t>   * Ask: 'Can a junior developer maintain this?' If no, simplify</a:t>
             </a:r>
           </a:p>
           <a:p/>
           <a:p>
             <a:r>
+              <a:t>ASK THE CLASS:</a:t>
+            </a:r>
+          </a:p>
+          <a:p>
+            <a:r>
+              <a:t>   "What's the cleverest code you wrote that you later regretted?"</a:t>
+            </a:r>
+          </a:p>
+          <a:p>
+            <a:r>
+              <a:t>   [PAUSE for 30-60 seconds]</a:t>
+            </a:r>
+          </a:p>
+          <a:p/>
+          <a:p>
+            <a:r>
+              <a:t>REAL-WORLD EXAMPLE:</a:t>
+            </a:r>
+          </a:p>
+          <a:p>
+            <a:r>
+              <a:t>   Code review: Developer submits elegant regex one-liner that validates email format. Senior dev suggests 10-line version with clear steps (split @ check parts, validate domain, check TLD). Clever version: 1 line, impossible to debug. Boring version: 10 lines, obvious what each step does. Team chooses boring. Six months later, junior dev fixes bug in 5 minutes instead of 2 hours.</a:t>
+            </a:r>
+          </a:p>
+          <a:p/>
+          <a:p>
+            <a:r>
+              <a:t>DEMO:</a:t>
+            </a:r>
+          </a:p>
+          <a:p>
+            <a:r>
+              <a:t>   Show two solutions to same problem: 1) Clever: Nested ternary, regex, one-liner magic. 2) Boring: Named variables, clear conditionals, comments explaining why. Ask Claude (in demo) to evaluate both: 'Which would you rather debug at 3am?' Claude picks boring version. Emphasize Nate B Jones wisdom: 'Clever is a liability, boring is an asset.'</a:t>
+            </a:r>
+          </a:p>
+          <a:p/>
+          <a:p>
+            <a:r>
               <a:t>TRANSITION:</a:t>
             </a:r>
           </a:p>
           <a:p>
             <a:r>
-              <a:t>   Final section: Wrap-up and resources</a:t>
+              <a:t>   This maintainability mindset is the perfect conclusion to our advanced patterns - build for the team, not for ego</a:t>
             </a:r>
           </a:p>
         </p:txBody>
@@ -11706,91 +11714,64 @@
           <a:lstStyle/>
           <a:p>
             <a:r>
-              <a:t>TIME: 4 min</a:t>
+              <a:t>TIME: 3 min</a:t>
             </a:r>
           </a:p>
           <a:p/>
           <a:p>
             <a:r>
-              <a:t>OPEN WITH:</a:t>
-            </a:r>
-          </a:p>
-          <a:p>
-            <a:r>
-              <a:t>   I want to end with honesty about where Claude Code still struggles. This isn't pessimism — it's professionalism. Knowing the boundaries makes you more effective, not less. Reza Rezvani's quote: 'Vibecoding without metacognition is quite dangerous.' Meaning: if you're just accepting Claude's output without understanding it, you're building on sand.</a:t>
+              <a:t>KEY POINTS:</a:t>
+            </a:r>
+          </a:p>
+          <a:p>
+            <a:r>
+              <a:t>   * CLAUDE.md: Team source of truth for Claude behavior</a:t>
+            </a:r>
+          </a:p>
+          <a:p>
+            <a:r>
+              <a:t>   * Commands: Shared via git, documented in README</a:t>
+            </a:r>
+          </a:p>
+          <a:p>
+            <a:r>
+              <a:t>   * Hooks: Safety and compliance from day 1</a:t>
+            </a:r>
+          </a:p>
+          <a:p>
+            <a:r>
+              <a:t>   * Audit logs: Required for enterprise compliance</a:t>
+            </a:r>
+          </a:p>
+          <a:p>
+            <a:r>
+              <a:t>   * .claudeignore: Performance and cost optimization</a:t>
+            </a:r>
+          </a:p>
+          <a:p>
+            <a:r>
+              <a:t>   * MCP: Security review before deployment</a:t>
+            </a:r>
+          </a:p>
+          <a:p>
+            <a:r>
+              <a:t>   * Training: Team knows how to use custom workflows</a:t>
+            </a:r>
+          </a:p>
+          <a:p>
+            <a:r>
+              <a:t>   * Budget: Monitor and optimize based on usage</a:t>
             </a:r>
           </a:p>
           <a:p/>
           <a:p>
             <a:r>
-              <a:t>KEY POINTS:</a:t>
-            </a:r>
-          </a:p>
-          <a:p>
-            <a:r>
-              <a:t>   * Large changes (&gt;15 files): Context degrades, errors compound across files, Claude loses track of dependencies</a:t>
-            </a:r>
-          </a:p>
-          <a:p>
-            <a:r>
-              <a:t>   * Architecture decisions: Claude optimizes locally — it makes each function great but may miss system-level design issues</a:t>
-            </a:r>
-          </a:p>
-          <a:p>
-            <a:r>
-              <a:t>   * Verification boundary: If you can't review and understand the code, you shouldn't ship it. Period.</a:t>
-            </a:r>
-          </a:p>
-          <a:p>
-            <a:r>
-              <a:t>   * Novel work: Claude recombines known patterns brilliantly but doesn't truly invent new algorithms</a:t>
-            </a:r>
-          </a:p>
-          <a:p>
-            <a:r>
-              <a:t>   * The 3 AM test: Could you debug this code at 3 AM without Claude? If not, you need to understand it better before shipping.</a:t>
-            </a:r>
-          </a:p>
-          <a:p>
-            <a:r>
-              <a:t>   * This is why Plan Mode, decomposition, and verification matter — they keep you in control</a:t>
-            </a:r>
-          </a:p>
-          <a:p>
-            <a:r>
-              <a:t>   * Community feedback highlights real gaps: no team collaboration features, pricing confusion, and developer isolation. Each person's Claude Code session is independent — there's no shared workspace or context.</a:t>
-            </a:r>
-          </a:p>
-          <a:p>
-            <a:r>
-              <a:t>   * The practical fix today: shared CLAUDE.md committed to git, team conventions documented as custom commands, and skills versioned alongside your codebase. This creates de facto team collaboration until native features arrive.</a:t>
-            </a:r>
-          </a:p>
-          <a:p/>
-          <a:p>
-            <a:r>
-              <a:t>ASK THE CLASS:</a:t>
-            </a:r>
-          </a:p>
-          <a:p>
-            <a:r>
-              <a:t>   "What's the most complex task you've delegated to AI without fully understanding the output? What happened?"</a:t>
-            </a:r>
-          </a:p>
-          <a:p>
-            <a:r>
-              <a:t>   [PAUSE for 30-60 seconds]</a:t>
-            </a:r>
-          </a:p>
-          <a:p/>
-          <a:p>
-            <a:r>
               <a:t>TRANSITION:</a:t>
             </a:r>
           </a:p>
           <a:p>
             <a:r>
-              <a:t>   With those boundaries clear, let's recap what you've learned and preview tomorrow.</a:t>
+              <a:t>   Final section: Wrap-up and resources</a:t>
             </a:r>
           </a:p>
         </p:txBody>
@@ -11866,53 +11847,85 @@
           <a:p/>
           <a:p>
             <a:r>
+              <a:t>OPEN WITH:</a:t>
+            </a:r>
+          </a:p>
+          <a:p>
+            <a:r>
+              <a:t>   I want to end with honesty about where Claude Code still struggles. This isn't pessimism — it's professionalism. Knowing the boundaries makes you more effective, not less. Reza Rezvani's quote: 'Vibecoding without metacognition is quite dangerous.' Meaning: if you're just accepting Claude's output without understanding it, you're building on sand.</a:t>
+            </a:r>
+          </a:p>
+          <a:p/>
+          <a:p>
+            <a:r>
               <a:t>KEY POINTS:</a:t>
             </a:r>
           </a:p>
           <a:p>
             <a:r>
-              <a:t>   * You now have advanced patterns for production Claude Code use</a:t>
-            </a:r>
-          </a:p>
-          <a:p>
-            <a:r>
-              <a:t>   * Custom commands save hours daily on repetitive tasks</a:t>
-            </a:r>
-          </a:p>
-          <a:p>
-            <a:r>
-              <a:t>   * Hooks provide safety and compliance</a:t>
-            </a:r>
-          </a:p>
-          <a:p>
-            <a:r>
-              <a:t>   * MCP unlocks integration with any tool or database</a:t>
-            </a:r>
-          </a:p>
-          <a:p>
-            <a:r>
-              <a:t>   * Agent Teams enable work that would take days to complete in hours</a:t>
-            </a:r>
-          </a:p>
-          <a:p>
-            <a:r>
-              <a:t>   * These patterns scale from 1 developer to enterprise teams</a:t>
-            </a:r>
-          </a:p>
-          <a:p>
-            <a:r>
-              <a:t>   * Remember: Claude Code's current limitation is team isolation — but shared CLAUDE.md via git, versioned custom commands, and team conventions bridge that gap until native collaboration features arrive.</a:t>
+              <a:t>   * Large changes (&gt;15 files): Context degrades, errors compound across files, Claude loses track of dependencies</a:t>
+            </a:r>
+          </a:p>
+          <a:p>
+            <a:r>
+              <a:t>   * Architecture decisions: Claude optimizes locally — it makes each function great but may miss system-level design issues</a:t>
+            </a:r>
+          </a:p>
+          <a:p>
+            <a:r>
+              <a:t>   * Verification boundary: If you can't review and understand the code, you shouldn't ship it. Period.</a:t>
+            </a:r>
+          </a:p>
+          <a:p>
+            <a:r>
+              <a:t>   * Novel work: Claude recombines known patterns brilliantly but doesn't truly invent new algorithms</a:t>
+            </a:r>
+          </a:p>
+          <a:p>
+            <a:r>
+              <a:t>   * The 3 AM test: Could you debug this code at 3 AM without Claude? If not, you need to understand it better before shipping.</a:t>
+            </a:r>
+          </a:p>
+          <a:p>
+            <a:r>
+              <a:t>   * This is why Plan Mode, decomposition, and verification matter — they keep you in control</a:t>
+            </a:r>
+          </a:p>
+          <a:p>
+            <a:r>
+              <a:t>   * Community feedback highlights real gaps: no team collaboration features, pricing confusion, and developer isolation. Each person's Claude Code session is independent — there's no shared workspace or context.</a:t>
+            </a:r>
+          </a:p>
+          <a:p>
+            <a:r>
+              <a:t>   * The practical fix today: shared CLAUDE.md committed to git, team conventions documented as custom commands, and skills versioned alongside your codebase. This creates de facto team collaboration until native features arrive.</a:t>
             </a:r>
           </a:p>
           <a:p/>
           <a:p>
             <a:r>
+              <a:t>ASK THE CLASS:</a:t>
+            </a:r>
+          </a:p>
+          <a:p>
+            <a:r>
+              <a:t>   "What's the most complex task you've delegated to AI without fully understanding the output? What happened?"</a:t>
+            </a:r>
+          </a:p>
+          <a:p>
+            <a:r>
+              <a:t>   [PAUSE for 30-60 seconds]</a:t>
+            </a:r>
+          </a:p>
+          <a:p/>
+          <a:p>
+            <a:r>
               <a:t>TRANSITION:</a:t>
             </a:r>
           </a:p>
           <a:p>
             <a:r>
-              <a:t>   Getting started roadmap</a:t>
+              <a:t>   With those boundaries clear, let's recap what you've learned and preview tomorrow.</a:t>
             </a:r>
           </a:p>
         </p:txBody>
@@ -11993,54 +12006,48 @@
           </a:p>
           <a:p>
             <a:r>
-              <a:t>   * Don't try everything at once</a:t>
-            </a:r>
-          </a:p>
-          <a:p>
-            <a:r>
-              <a:t>   * Start with custom commands (easiest, high value)</a:t>
-            </a:r>
-          </a:p>
-          <a:p>
-            <a:r>
-              <a:t>   * Add security hooks early (build good habits)</a:t>
-            </a:r>
-          </a:p>
-          <a:p>
-            <a:r>
-              <a:t>   * MCP integration provides immediate workflow improvement</a:t>
-            </a:r>
-          </a:p>
-          <a:p>
-            <a:r>
-              <a:t>   * Advanced patterns (Agent Teams) after basics are solid</a:t>
-            </a:r>
-          </a:p>
-          <a:p>
-            <a:r>
-              <a:t>   * Measure value at each stage, celebrate wins</a:t>
+              <a:t>   * You now have advanced patterns for production Claude Code use</a:t>
+            </a:r>
+          </a:p>
+          <a:p>
+            <a:r>
+              <a:t>   * Custom commands save hours daily on repetitive tasks</a:t>
+            </a:r>
+          </a:p>
+          <a:p>
+            <a:r>
+              <a:t>   * Hooks provide safety and compliance</a:t>
+            </a:r>
+          </a:p>
+          <a:p>
+            <a:r>
+              <a:t>   * MCP unlocks integration with any tool or database</a:t>
+            </a:r>
+          </a:p>
+          <a:p>
+            <a:r>
+              <a:t>   * Agent Teams enable work that would take days to complete in hours</a:t>
+            </a:r>
+          </a:p>
+          <a:p>
+            <a:r>
+              <a:t>   * These patterns scale from 1 developer to enterprise teams</a:t>
+            </a:r>
+          </a:p>
+          <a:p>
+            <a:r>
+              <a:t>   * Remember: Claude Code's current limitation is team isolation — but shared CLAUDE.md via git, versioned custom commands, and team conventions bridge that gap until native collaboration features arrive.</a:t>
             </a:r>
           </a:p>
           <a:p/>
           <a:p>
             <a:r>
-              <a:t>REAL-WORLD EXAMPLE:</a:t>
-            </a:r>
-          </a:p>
-          <a:p>
-            <a:r>
-              <a:t>   Team followed this roadmap. After month 1: saving 5 hours/week with commands and hooks. After month 3: Agent Teams cutting complex feature time in half.</a:t>
-            </a:r>
-          </a:p>
-          <a:p/>
-          <a:p>
-            <a:r>
               <a:t>TRANSITION:</a:t>
             </a:r>
           </a:p>
           <a:p>
             <a:r>
-              <a:t>   Resources and community</a:t>
+              <a:t>   Getting started roadmap</a:t>
             </a:r>
           </a:p>
         </p:txBody>
@@ -12233,7 +12240,7 @@
           <a:lstStyle/>
           <a:p>
             <a:r>
-              <a:t>TIME: 3 min</a:t>
+              <a:t>TIME: 4 min</a:t>
             </a:r>
           </a:p>
           <a:p/>
@@ -12244,43 +12251,54 @@
           </a:p>
           <a:p>
             <a:r>
-              <a:t>   * Official docs are comprehensive and up-to-date</a:t>
-            </a:r>
-          </a:p>
-          <a:p>
-            <a:r>
-              <a:t>   * MCP ecosystem growing rapidly</a:t>
-            </a:r>
-          </a:p>
-          <a:p>
-            <a:r>
-              <a:t>   * Community shares custom commands and patterns</a:t>
-            </a:r>
-          </a:p>
-          <a:p>
-            <a:r>
-              <a:t>   * Discord active for questions and troubleshooting</a:t>
-            </a:r>
-          </a:p>
-          <a:p>
-            <a:r>
-              <a:t>   * Learn from others' Agent Teams examples</a:t>
-            </a:r>
-          </a:p>
-          <a:p>
-            <a:r>
-              <a:t>   * Internal team knowledge sharing multiplies value</a:t>
+              <a:t>   * Don't try everything at once</a:t>
+            </a:r>
+          </a:p>
+          <a:p>
+            <a:r>
+              <a:t>   * Start with custom commands (easiest, high value)</a:t>
+            </a:r>
+          </a:p>
+          <a:p>
+            <a:r>
+              <a:t>   * Add security hooks early (build good habits)</a:t>
+            </a:r>
+          </a:p>
+          <a:p>
+            <a:r>
+              <a:t>   * MCP integration provides immediate workflow improvement</a:t>
+            </a:r>
+          </a:p>
+          <a:p>
+            <a:r>
+              <a:t>   * Advanced patterns (Agent Teams) after basics are solid</a:t>
+            </a:r>
+          </a:p>
+          <a:p>
+            <a:r>
+              <a:t>   * Measure value at each stage, celebrate wins</a:t>
             </a:r>
           </a:p>
           <a:p/>
           <a:p>
             <a:r>
+              <a:t>REAL-WORLD EXAMPLE:</a:t>
+            </a:r>
+          </a:p>
+          <a:p>
+            <a:r>
+              <a:t>   Team followed this roadmap. After month 1: saving 5 hours/week with commands and hooks. After month 3: Agent Teams cutting complex feature time in half.</a:t>
+            </a:r>
+          </a:p>
+          <a:p/>
+          <a:p>
+            <a:r>
               <a:t>TRANSITION:</a:t>
             </a:r>
           </a:p>
           <a:p>
             <a:r>
-              <a:t>   Thank you and Q&amp;A</a:t>
+              <a:t>   Resources and community</a:t>
             </a:r>
           </a:p>
         </p:txBody>
@@ -12306,6 +12324,123 @@
 </file>
 
 <file path=ppt/notesSlides/notesSlide91.xml><?xml version="1.0" encoding="utf-8"?>
+<p:notes xmlns:a="http://schemas.openxmlformats.org/drawingml/2006/main" xmlns:p="http://schemas.openxmlformats.org/presentationml/2006/main" xmlns:r="http://schemas.openxmlformats.org/officeDocument/2006/relationships">
+  <p:cSld>
+    <p:spTree>
+      <p:nvGrpSpPr>
+        <p:cNvPr id="1" name=""/>
+        <p:cNvGrpSpPr/>
+        <p:nvPr/>
+      </p:nvGrpSpPr>
+      <p:grpSpPr>
+        <a:xfrm>
+          <a:off x="0" y="0"/>
+          <a:ext cx="0" cy="0"/>
+          <a:chOff x="0" y="0"/>
+          <a:chExt cx="0" cy="0"/>
+        </a:xfrm>
+      </p:grpSpPr>
+      <p:sp>
+        <p:nvSpPr>
+          <p:cNvPr id="2" name="Slide Image Placeholder 1"/>
+          <p:cNvSpPr>
+            <a:spLocks noGrp="1"/>
+          </p:cNvSpPr>
+          <p:nvPr>
+            <p:ph type="sldImg" idx="2"/>
+          </p:nvPr>
+        </p:nvSpPr>
+        <p:spPr/>
+      </p:sp>
+      <p:sp>
+        <p:nvSpPr>
+          <p:cNvPr id="3" name="Notes Placeholder 2"/>
+          <p:cNvSpPr>
+            <a:spLocks noGrp="1"/>
+          </p:cNvSpPr>
+          <p:nvPr>
+            <p:ph type="body" idx="3" sz="quarter"/>
+          </p:nvPr>
+        </p:nvSpPr>
+        <p:spPr/>
+        <p:txBody>
+          <a:bodyPr/>
+          <a:lstStyle/>
+          <a:p>
+            <a:r>
+              <a:t>TIME: 3 min</a:t>
+            </a:r>
+          </a:p>
+          <a:p/>
+          <a:p>
+            <a:r>
+              <a:t>KEY POINTS:</a:t>
+            </a:r>
+          </a:p>
+          <a:p>
+            <a:r>
+              <a:t>   * Official docs are comprehensive and up-to-date</a:t>
+            </a:r>
+          </a:p>
+          <a:p>
+            <a:r>
+              <a:t>   * MCP ecosystem growing rapidly</a:t>
+            </a:r>
+          </a:p>
+          <a:p>
+            <a:r>
+              <a:t>   * Community shares custom commands and patterns</a:t>
+            </a:r>
+          </a:p>
+          <a:p>
+            <a:r>
+              <a:t>   * Discord active for questions and troubleshooting</a:t>
+            </a:r>
+          </a:p>
+          <a:p>
+            <a:r>
+              <a:t>   * Learn from others' Agent Teams examples</a:t>
+            </a:r>
+          </a:p>
+          <a:p>
+            <a:r>
+              <a:t>   * Internal team knowledge sharing multiplies value</a:t>
+            </a:r>
+          </a:p>
+          <a:p/>
+          <a:p>
+            <a:r>
+              <a:t>TRANSITION:</a:t>
+            </a:r>
+          </a:p>
+          <a:p>
+            <a:r>
+              <a:t>   Thank you and Q&amp;A</a:t>
+            </a:r>
+          </a:p>
+        </p:txBody>
+      </p:sp>
+      <p:sp>
+        <p:nvSpPr>
+          <p:cNvPr id="4" name="Slide Number Placeholder 3"/>
+          <p:cNvSpPr>
+            <a:spLocks noGrp="1"/>
+          </p:cNvSpPr>
+          <p:nvPr>
+            <p:ph type="sldNum" idx="5" sz="quarter"/>
+          </p:nvPr>
+        </p:nvSpPr>
+        <p:spPr/>
+      </p:sp>
+    </p:spTree>
+  </p:cSld>
+  <p:clrMapOvr>
+    <a:masterClrMapping/>
+  </p:clrMapOvr>
+</p:notes>
+</file>
+
+<file path=ppt/notesSlides/notesSlide92.xml><?xml version="1.0" encoding="utf-8"?>
 <p:notes xmlns:a="http://schemas.openxmlformats.org/drawingml/2006/main" xmlns:p="http://schemas.openxmlformats.org/presentationml/2006/main" xmlns:r="http://schemas.openxmlformats.org/officeDocument/2006/relationships">
   <p:cSld>
     <p:spTree>
@@ -15746,49 +15881,14 @@
       <p:grpSpPr/>
       <p:sp>
         <p:nvSpPr>
-          <p:cNvPr id="2" name="TextBox 1"/>
-          <p:cNvSpPr txBox="1"/>
-          <p:nvPr/>
-        </p:nvSpPr>
-        <p:spPr>
-          <a:xfrm>
-            <a:off x="457200" y="365760"/>
-            <a:ext cx="11277295" cy="822960"/>
-          </a:xfrm>
-          <a:prstGeom prst="rect">
-            <a:avLst/>
-          </a:prstGeom>
-          <a:noFill/>
-        </p:spPr>
-        <p:txBody>
-          <a:bodyPr wrap="none">
-            <a:spAutoFit/>
-          </a:bodyPr>
-          <a:lstStyle/>
-          <a:p>
-            <a:pPr>
-              <a:defRPr sz="4000" b="1">
-                <a:solidFill>
-                  <a:srgbClr val="FFFFFF"/>
-                </a:solidFill>
-              </a:defRPr>
-            </a:pPr>
-            <a:r>
-              <a:t>Where Claude Code Still Struggles</a:t>
-            </a:r>
-          </a:p>
-        </p:txBody>
-      </p:sp>
-      <p:sp>
-        <p:nvSpPr>
-          <p:cNvPr id="3" name="Rectangle 2"/>
+          <p:cNvPr id="2" name="Rectangle 1"/>
           <p:cNvSpPr/>
           <p:nvPr/>
         </p:nvSpPr>
         <p:spPr>
           <a:xfrm>
-            <a:off x="457200" y="1234440"/>
-            <a:ext cx="1828800" cy="36576"/>
+            <a:off x="0" y="1828800"/>
+            <a:ext cx="137160" cy="3200400"/>
           </a:xfrm>
           <a:prstGeom prst="rect">
             <a:avLst/>
@@ -15824,14 +15924,14 @@
       </p:sp>
       <p:sp>
         <p:nvSpPr>
-          <p:cNvPr id="4" name="TextBox 3"/>
+          <p:cNvPr id="3" name="TextBox 2"/>
           <p:cNvSpPr txBox="1"/>
           <p:nvPr/>
         </p:nvSpPr>
         <p:spPr>
           <a:xfrm>
-            <a:off x="457200" y="1463040"/>
-            <a:ext cx="11277295" cy="4572000"/>
+            <a:off x="457200" y="2286000"/>
+            <a:ext cx="11277295" cy="1371600"/>
           </a:xfrm>
           <a:prstGeom prst="rect">
             <a:avLst/>
@@ -15845,110 +15945,49 @@
           <a:lstStyle/>
           <a:p>
             <a:pPr>
-              <a:spcBef>
-                <a:spcPts val="800"/>
-              </a:spcBef>
-              <a:spcAft>
-                <a:spcPts val="800"/>
-              </a:spcAft>
-              <a:defRPr sz="2200">
+              <a:defRPr sz="5600" b="1">
                 <a:solidFill>
                   <a:srgbClr val="FFFFFF"/>
                 </a:solidFill>
               </a:defRPr>
             </a:pPr>
             <a:r>
-              <a:t>  Large changes (&gt;15 files): Context degrades, errors compound across files, Claude loses track of dependencies.</a:t>
-            </a:r>
-          </a:p>
+              <a:t>Wrap-up</a:t>
+            </a:r>
+          </a:p>
+        </p:txBody>
+      </p:sp>
+      <p:sp>
+        <p:nvSpPr>
+          <p:cNvPr id="4" name="TextBox 3"/>
+          <p:cNvSpPr txBox="1"/>
+          <p:nvPr/>
+        </p:nvSpPr>
+        <p:spPr>
+          <a:xfrm>
+            <a:off x="457200" y="3840480"/>
+            <a:ext cx="11277295" cy="914400"/>
+          </a:xfrm>
+          <a:prstGeom prst="rect">
+            <a:avLst/>
+          </a:prstGeom>
+          <a:noFill/>
+        </p:spPr>
+        <p:txBody>
+          <a:bodyPr wrap="square">
+            <a:spAutoFit/>
+          </a:bodyPr>
+          <a:lstStyle/>
           <a:p>
             <a:pPr>
-              <a:spcBef>
-                <a:spcPts val="800"/>
-              </a:spcBef>
-              <a:spcAft>
-                <a:spcPts val="800"/>
-              </a:spcAft>
-              <a:defRPr sz="2200">
-                <a:solidFill>
-                  <a:srgbClr val="FFFFFF"/>
-                </a:solidFill>
-              </a:defRPr>
-            </a:pPr>
-            <a:r>
-              <a:t>  Architecture decisions: Claude optimizes locally — it makes each function great but may miss system-level design issues.</a:t>
-            </a:r>
-          </a:p>
-          <a:p>
-            <a:pPr>
-              <a:spcBef>
-                <a:spcPts val="800"/>
-              </a:spcBef>
-              <a:spcAft>
-                <a:spcPts val="800"/>
-              </a:spcAft>
-              <a:defRPr sz="2200">
-                <a:solidFill>
-                  <a:srgbClr val="FFFFFF"/>
-                </a:solidFill>
-              </a:defRPr>
-            </a:pPr>
-            <a:r>
-              <a:t>  Verification boundary: If you can't review and understand the code, you shouldn't ship it.</a:t>
-            </a:r>
-          </a:p>
-          <a:p>
-            <a:pPr>
-              <a:spcBef>
-                <a:spcPts val="800"/>
-              </a:spcBef>
-              <a:spcAft>
-                <a:spcPts val="800"/>
-              </a:spcAft>
-              <a:defRPr sz="2200">
-                <a:solidFill>
-                  <a:srgbClr val="FFFFFF"/>
-                </a:solidFill>
-              </a:defRPr>
-            </a:pPr>
-            <a:r>
-              <a:t>  Novel work: Claude recombines known patterns brilliantly but doesn't truly invent new algorithms.</a:t>
-            </a:r>
-          </a:p>
-          <a:p>
-            <a:pPr>
-              <a:spcBef>
-                <a:spcPts val="800"/>
-              </a:spcBef>
-              <a:spcAft>
-                <a:spcPts val="800"/>
-              </a:spcAft>
-              <a:defRPr sz="2200">
-                <a:solidFill>
-                  <a:srgbClr val="FFFFFF"/>
-                </a:solidFill>
-              </a:defRPr>
-            </a:pPr>
-            <a:r>
-              <a:t>  The 3 AM test: Could you debug this code at 3 AM without Claude? If not, you need to understand it better before ship...</a:t>
-            </a:r>
-          </a:p>
-          <a:p>
-            <a:pPr>
-              <a:spcBef>
-                <a:spcPts val="800"/>
-              </a:spcBef>
-              <a:spcAft>
-                <a:spcPts val="800"/>
-              </a:spcAft>
-              <a:defRPr sz="2200">
-                <a:solidFill>
-                  <a:srgbClr val="FFFFFF"/>
-                </a:solidFill>
-              </a:defRPr>
-            </a:pPr>
-            <a:r>
-              <a:t>  This is why Plan Mode, decomposition, and verification matter — they keep you in control.</a:t>
+              <a:defRPr sz="2400">
+                <a:solidFill>
+                  <a:srgbClr val="8B95A5"/>
+                </a:solidFill>
+              </a:defRPr>
+            </a:pPr>
+            <a:r>
+              <a:t>Key takeaways and next steps</a:t>
             </a:r>
           </a:p>
         </p:txBody>
@@ -15981,14 +16020,49 @@
       <p:grpSpPr/>
       <p:sp>
         <p:nvSpPr>
-          <p:cNvPr id="2" name="Rectangle 1"/>
+          <p:cNvPr id="2" name="TextBox 1"/>
+          <p:cNvSpPr txBox="1"/>
+          <p:nvPr/>
+        </p:nvSpPr>
+        <p:spPr>
+          <a:xfrm>
+            <a:off x="457200" y="365760"/>
+            <a:ext cx="11277295" cy="822960"/>
+          </a:xfrm>
+          <a:prstGeom prst="rect">
+            <a:avLst/>
+          </a:prstGeom>
+          <a:noFill/>
+        </p:spPr>
+        <p:txBody>
+          <a:bodyPr wrap="none">
+            <a:spAutoFit/>
+          </a:bodyPr>
+          <a:lstStyle/>
+          <a:p>
+            <a:pPr>
+              <a:defRPr sz="4000" b="1">
+                <a:solidFill>
+                  <a:srgbClr val="FFFFFF"/>
+                </a:solidFill>
+              </a:defRPr>
+            </a:pPr>
+            <a:r>
+              <a:t>Where Claude Code Still Struggles</a:t>
+            </a:r>
+          </a:p>
+        </p:txBody>
+      </p:sp>
+      <p:sp>
+        <p:nvSpPr>
+          <p:cNvPr id="3" name="Rectangle 2"/>
           <p:cNvSpPr/>
           <p:nvPr/>
         </p:nvSpPr>
         <p:spPr>
           <a:xfrm>
-            <a:off x="0" y="1188720"/>
-            <a:ext cx="91440" cy="5029200"/>
+            <a:off x="457200" y="1234440"/>
+            <a:ext cx="1828800" cy="36576"/>
           </a:xfrm>
           <a:prstGeom prst="rect">
             <a:avLst/>
@@ -16024,127 +16098,14 @@
       </p:sp>
       <p:sp>
         <p:nvSpPr>
-          <p:cNvPr id="3" name="TextBox 2"/>
+          <p:cNvPr id="4" name="TextBox 3"/>
           <p:cNvSpPr txBox="1"/>
           <p:nvPr/>
         </p:nvSpPr>
         <p:spPr>
           <a:xfrm>
-            <a:off x="457200" y="365760"/>
-            <a:ext cx="11277295" cy="822960"/>
-          </a:xfrm>
-          <a:prstGeom prst="rect">
-            <a:avLst/>
-          </a:prstGeom>
-          <a:noFill/>
-        </p:spPr>
-        <p:txBody>
-          <a:bodyPr wrap="none">
-            <a:spAutoFit/>
-          </a:bodyPr>
-          <a:lstStyle/>
-          <a:p>
-            <a:pPr>
-              <a:defRPr sz="4000" b="1">
-                <a:solidFill>
-                  <a:srgbClr val="FFFFFF"/>
-                </a:solidFill>
-              </a:defRPr>
-            </a:pPr>
-            <a:r>
-              <a:t>Day 3 Key Takeaways</a:t>
-            </a:r>
-          </a:p>
-        </p:txBody>
-      </p:sp>
-      <p:sp>
-        <p:nvSpPr>
-          <p:cNvPr id="4" name="Oval 3"/>
-          <p:cNvSpPr/>
-          <p:nvPr/>
-        </p:nvSpPr>
-        <p:spPr>
-          <a:xfrm>
-            <a:off x="457200" y="1371600"/>
-            <a:ext cx="411480" cy="411480"/>
-          </a:xfrm>
-          <a:prstGeom prst="ellipse">
-            <a:avLst/>
-          </a:prstGeom>
-          <a:solidFill>
-            <a:srgbClr val="00D4AA"/>
-          </a:solidFill>
-          <a:ln>
-            <a:noFill/>
-          </a:ln>
-        </p:spPr>
-        <p:style>
-          <a:lnRef idx="1">
-            <a:schemeClr val="accent1"/>
-          </a:lnRef>
-          <a:fillRef idx="3">
-            <a:schemeClr val="accent1"/>
-          </a:fillRef>
-          <a:effectRef idx="2">
-            <a:schemeClr val="accent1"/>
-          </a:effectRef>
-          <a:fontRef idx="minor">
-            <a:schemeClr val="lt1"/>
-          </a:fontRef>
-        </p:style>
-        <p:txBody>
-          <a:bodyPr rtlCol="0" anchor="ctr"/>
-          <a:lstStyle/>
-          <a:p>
-            <a:pPr algn="ctr"/>
-          </a:p>
-        </p:txBody>
-      </p:sp>
-      <p:sp>
-        <p:nvSpPr>
-          <p:cNvPr id="5" name="TextBox 4"/>
-          <p:cNvSpPr txBox="1"/>
-          <p:nvPr/>
-        </p:nvSpPr>
-        <p:spPr>
-          <a:xfrm>
-            <a:off x="457200" y="1371600"/>
-            <a:ext cx="411480" cy="411480"/>
-          </a:xfrm>
-          <a:prstGeom prst="rect">
-            <a:avLst/>
-          </a:prstGeom>
-          <a:noFill/>
-        </p:spPr>
-        <p:txBody>
-          <a:bodyPr wrap="none" anchor="ctr">
-            <a:spAutoFit/>
-          </a:bodyPr>
-          <a:lstStyle/>
-          <a:p>
-            <a:pPr algn="ctr">
-              <a:defRPr sz="2000" b="1">
-                <a:solidFill>
-                  <a:srgbClr val="0B0F1A"/>
-                </a:solidFill>
-              </a:defRPr>
-            </a:pPr>
-            <a:r>
-              <a:t>v</a:t>
-            </a:r>
-          </a:p>
-        </p:txBody>
-      </p:sp>
-      <p:sp>
-        <p:nvSpPr>
-          <p:cNvPr id="6" name="TextBox 5"/>
-          <p:cNvSpPr txBox="1"/>
-          <p:nvPr/>
-        </p:nvSpPr>
-        <p:spPr>
-          <a:xfrm>
-            <a:off x="1005840" y="1417320"/>
-            <a:ext cx="10728655" cy="731520"/>
+            <a:off x="457200" y="1463040"/>
+            <a:ext cx="11277295" cy="4572000"/>
           </a:xfrm>
           <a:prstGeom prst="rect">
             <a:avLst/>
@@ -16158,6 +16119,12 @@
           <a:lstStyle/>
           <a:p>
             <a:pPr>
+              <a:spcBef>
+                <a:spcPts val="800"/>
+              </a:spcBef>
+              <a:spcAft>
+                <a:spcPts val="800"/>
+              </a:spcAft>
               <a:defRPr sz="2200">
                 <a:solidFill>
                   <a:srgbClr val="FFFFFF"/>
@@ -16165,112 +16132,17 @@
               </a:defRPr>
             </a:pPr>
             <a:r>
-              <a:t>Custom commands: Reusable workflows in .claude/commands/</a:t>
-            </a:r>
-          </a:p>
-        </p:txBody>
-      </p:sp>
-      <p:sp>
-        <p:nvSpPr>
-          <p:cNvPr id="7" name="Oval 6"/>
-          <p:cNvSpPr/>
-          <p:nvPr/>
-        </p:nvSpPr>
-        <p:spPr>
-          <a:xfrm>
-            <a:off x="457200" y="2194560"/>
-            <a:ext cx="411480" cy="411480"/>
-          </a:xfrm>
-          <a:prstGeom prst="ellipse">
-            <a:avLst/>
-          </a:prstGeom>
-          <a:solidFill>
-            <a:srgbClr val="00D4AA"/>
-          </a:solidFill>
-          <a:ln>
-            <a:noFill/>
-          </a:ln>
-        </p:spPr>
-        <p:style>
-          <a:lnRef idx="1">
-            <a:schemeClr val="accent1"/>
-          </a:lnRef>
-          <a:fillRef idx="3">
-            <a:schemeClr val="accent1"/>
-          </a:fillRef>
-          <a:effectRef idx="2">
-            <a:schemeClr val="accent1"/>
-          </a:effectRef>
-          <a:fontRef idx="minor">
-            <a:schemeClr val="lt1"/>
-          </a:fontRef>
-        </p:style>
-        <p:txBody>
-          <a:bodyPr rtlCol="0" anchor="ctr"/>
-          <a:lstStyle/>
-          <a:p>
-            <a:pPr algn="ctr"/>
-          </a:p>
-        </p:txBody>
-      </p:sp>
-      <p:sp>
-        <p:nvSpPr>
-          <p:cNvPr id="8" name="TextBox 7"/>
-          <p:cNvSpPr txBox="1"/>
-          <p:nvPr/>
-        </p:nvSpPr>
-        <p:spPr>
-          <a:xfrm>
-            <a:off x="457200" y="2194560"/>
-            <a:ext cx="411480" cy="411480"/>
-          </a:xfrm>
-          <a:prstGeom prst="rect">
-            <a:avLst/>
-          </a:prstGeom>
-          <a:noFill/>
-        </p:spPr>
-        <p:txBody>
-          <a:bodyPr wrap="none" anchor="ctr">
-            <a:spAutoFit/>
-          </a:bodyPr>
-          <a:lstStyle/>
-          <a:p>
-            <a:pPr algn="ctr">
-              <a:defRPr sz="2000" b="1">
-                <a:solidFill>
-                  <a:srgbClr val="0B0F1A"/>
-                </a:solidFill>
-              </a:defRPr>
-            </a:pPr>
-            <a:r>
-              <a:t>v</a:t>
-            </a:r>
-          </a:p>
-        </p:txBody>
-      </p:sp>
-      <p:sp>
-        <p:nvSpPr>
-          <p:cNvPr id="9" name="TextBox 8"/>
-          <p:cNvSpPr txBox="1"/>
-          <p:nvPr/>
-        </p:nvSpPr>
-        <p:spPr>
-          <a:xfrm>
-            <a:off x="1005840" y="2240280"/>
-            <a:ext cx="10728655" cy="731520"/>
-          </a:xfrm>
-          <a:prstGeom prst="rect">
-            <a:avLst/>
-          </a:prstGeom>
-          <a:noFill/>
-        </p:spPr>
-        <p:txBody>
-          <a:bodyPr wrap="square">
-            <a:spAutoFit/>
-          </a:bodyPr>
-          <a:lstStyle/>
+              <a:t>  Large changes (&gt;15 files): Context degrades, errors compound across files, Claude loses track of dependencies.</a:t>
+            </a:r>
+          </a:p>
           <a:p>
             <a:pPr>
+              <a:spcBef>
+                <a:spcPts val="800"/>
+              </a:spcBef>
+              <a:spcAft>
+                <a:spcPts val="800"/>
+              </a:spcAft>
               <a:defRPr sz="2200">
                 <a:solidFill>
                   <a:srgbClr val="FFFFFF"/>
@@ -16278,112 +16150,17 @@
               </a:defRPr>
             </a:pPr>
             <a:r>
-              <a:t>Subagents: Specialized AI workers for focused tasks</a:t>
-            </a:r>
-          </a:p>
-        </p:txBody>
-      </p:sp>
-      <p:sp>
-        <p:nvSpPr>
-          <p:cNvPr id="10" name="Oval 9"/>
-          <p:cNvSpPr/>
-          <p:nvPr/>
-        </p:nvSpPr>
-        <p:spPr>
-          <a:xfrm>
-            <a:off x="457200" y="3017520"/>
-            <a:ext cx="411480" cy="411480"/>
-          </a:xfrm>
-          <a:prstGeom prst="ellipse">
-            <a:avLst/>
-          </a:prstGeom>
-          <a:solidFill>
-            <a:srgbClr val="00D4AA"/>
-          </a:solidFill>
-          <a:ln>
-            <a:noFill/>
-          </a:ln>
-        </p:spPr>
-        <p:style>
-          <a:lnRef idx="1">
-            <a:schemeClr val="accent1"/>
-          </a:lnRef>
-          <a:fillRef idx="3">
-            <a:schemeClr val="accent1"/>
-          </a:fillRef>
-          <a:effectRef idx="2">
-            <a:schemeClr val="accent1"/>
-          </a:effectRef>
-          <a:fontRef idx="minor">
-            <a:schemeClr val="lt1"/>
-          </a:fontRef>
-        </p:style>
-        <p:txBody>
-          <a:bodyPr rtlCol="0" anchor="ctr"/>
-          <a:lstStyle/>
-          <a:p>
-            <a:pPr algn="ctr"/>
-          </a:p>
-        </p:txBody>
-      </p:sp>
-      <p:sp>
-        <p:nvSpPr>
-          <p:cNvPr id="11" name="TextBox 10"/>
-          <p:cNvSpPr txBox="1"/>
-          <p:nvPr/>
-        </p:nvSpPr>
-        <p:spPr>
-          <a:xfrm>
-            <a:off x="457200" y="3017520"/>
-            <a:ext cx="411480" cy="411480"/>
-          </a:xfrm>
-          <a:prstGeom prst="rect">
-            <a:avLst/>
-          </a:prstGeom>
-          <a:noFill/>
-        </p:spPr>
-        <p:txBody>
-          <a:bodyPr wrap="none" anchor="ctr">
-            <a:spAutoFit/>
-          </a:bodyPr>
-          <a:lstStyle/>
-          <a:p>
-            <a:pPr algn="ctr">
-              <a:defRPr sz="2000" b="1">
-                <a:solidFill>
-                  <a:srgbClr val="0B0F1A"/>
-                </a:solidFill>
-              </a:defRPr>
-            </a:pPr>
-            <a:r>
-              <a:t>v</a:t>
-            </a:r>
-          </a:p>
-        </p:txBody>
-      </p:sp>
-      <p:sp>
-        <p:nvSpPr>
-          <p:cNvPr id="12" name="TextBox 11"/>
-          <p:cNvSpPr txBox="1"/>
-          <p:nvPr/>
-        </p:nvSpPr>
-        <p:spPr>
-          <a:xfrm>
-            <a:off x="1005840" y="3063240"/>
-            <a:ext cx="10728655" cy="731520"/>
-          </a:xfrm>
-          <a:prstGeom prst="rect">
-            <a:avLst/>
-          </a:prstGeom>
-          <a:noFill/>
-        </p:spPr>
-        <p:txBody>
-          <a:bodyPr wrap="square">
-            <a:spAutoFit/>
-          </a:bodyPr>
-          <a:lstStyle/>
+              <a:t>  Architecture decisions: Claude optimizes locally — it makes each function great but may miss system-level design issues.</a:t>
+            </a:r>
+          </a:p>
           <a:p>
             <a:pPr>
+              <a:spcBef>
+                <a:spcPts val="800"/>
+              </a:spcBef>
+              <a:spcAft>
+                <a:spcPts val="800"/>
+              </a:spcAft>
               <a:defRPr sz="2200">
                 <a:solidFill>
                   <a:srgbClr val="FFFFFF"/>
@@ -16391,112 +16168,17 @@
               </a:defRPr>
             </a:pPr>
             <a:r>
-              <a:t>Hooks: Safety guardrails and audit logging</a:t>
-            </a:r>
-          </a:p>
-        </p:txBody>
-      </p:sp>
-      <p:sp>
-        <p:nvSpPr>
-          <p:cNvPr id="13" name="Oval 12"/>
-          <p:cNvSpPr/>
-          <p:nvPr/>
-        </p:nvSpPr>
-        <p:spPr>
-          <a:xfrm>
-            <a:off x="457200" y="3840480"/>
-            <a:ext cx="411480" cy="411480"/>
-          </a:xfrm>
-          <a:prstGeom prst="ellipse">
-            <a:avLst/>
-          </a:prstGeom>
-          <a:solidFill>
-            <a:srgbClr val="00D4AA"/>
-          </a:solidFill>
-          <a:ln>
-            <a:noFill/>
-          </a:ln>
-        </p:spPr>
-        <p:style>
-          <a:lnRef idx="1">
-            <a:schemeClr val="accent1"/>
-          </a:lnRef>
-          <a:fillRef idx="3">
-            <a:schemeClr val="accent1"/>
-          </a:fillRef>
-          <a:effectRef idx="2">
-            <a:schemeClr val="accent1"/>
-          </a:effectRef>
-          <a:fontRef idx="minor">
-            <a:schemeClr val="lt1"/>
-          </a:fontRef>
-        </p:style>
-        <p:txBody>
-          <a:bodyPr rtlCol="0" anchor="ctr"/>
-          <a:lstStyle/>
-          <a:p>
-            <a:pPr algn="ctr"/>
-          </a:p>
-        </p:txBody>
-      </p:sp>
-      <p:sp>
-        <p:nvSpPr>
-          <p:cNvPr id="14" name="TextBox 13"/>
-          <p:cNvSpPr txBox="1"/>
-          <p:nvPr/>
-        </p:nvSpPr>
-        <p:spPr>
-          <a:xfrm>
-            <a:off x="457200" y="3840480"/>
-            <a:ext cx="411480" cy="411480"/>
-          </a:xfrm>
-          <a:prstGeom prst="rect">
-            <a:avLst/>
-          </a:prstGeom>
-          <a:noFill/>
-        </p:spPr>
-        <p:txBody>
-          <a:bodyPr wrap="none" anchor="ctr">
-            <a:spAutoFit/>
-          </a:bodyPr>
-          <a:lstStyle/>
-          <a:p>
-            <a:pPr algn="ctr">
-              <a:defRPr sz="2000" b="1">
-                <a:solidFill>
-                  <a:srgbClr val="0B0F1A"/>
-                </a:solidFill>
-              </a:defRPr>
-            </a:pPr>
-            <a:r>
-              <a:t>v</a:t>
-            </a:r>
-          </a:p>
-        </p:txBody>
-      </p:sp>
-      <p:sp>
-        <p:nvSpPr>
-          <p:cNvPr id="15" name="TextBox 14"/>
-          <p:cNvSpPr txBox="1"/>
-          <p:nvPr/>
-        </p:nvSpPr>
-        <p:spPr>
-          <a:xfrm>
-            <a:off x="1005840" y="3886200"/>
-            <a:ext cx="10728655" cy="731520"/>
-          </a:xfrm>
-          <a:prstGeom prst="rect">
-            <a:avLst/>
-          </a:prstGeom>
-          <a:noFill/>
-        </p:spPr>
-        <p:txBody>
-          <a:bodyPr wrap="square">
-            <a:spAutoFit/>
-          </a:bodyPr>
-          <a:lstStyle/>
+              <a:t>  Verification boundary: If you can't review and understand the code, you shouldn't ship it.</a:t>
+            </a:r>
+          </a:p>
           <a:p>
             <a:pPr>
+              <a:spcBef>
+                <a:spcPts val="800"/>
+              </a:spcBef>
+              <a:spcAft>
+                <a:spcPts val="800"/>
+              </a:spcAft>
               <a:defRPr sz="2200">
                 <a:solidFill>
                   <a:srgbClr val="FFFFFF"/>
@@ -16504,112 +16186,17 @@
               </a:defRPr>
             </a:pPr>
             <a:r>
-              <a:t>Plan mode + thinking levels: Control quality/speed/cost tradeoffs</a:t>
-            </a:r>
-          </a:p>
-        </p:txBody>
-      </p:sp>
-      <p:sp>
-        <p:nvSpPr>
-          <p:cNvPr id="16" name="Oval 15"/>
-          <p:cNvSpPr/>
-          <p:nvPr/>
-        </p:nvSpPr>
-        <p:spPr>
-          <a:xfrm>
-            <a:off x="457200" y="4663440"/>
-            <a:ext cx="411480" cy="411480"/>
-          </a:xfrm>
-          <a:prstGeom prst="ellipse">
-            <a:avLst/>
-          </a:prstGeom>
-          <a:solidFill>
-            <a:srgbClr val="00D4AA"/>
-          </a:solidFill>
-          <a:ln>
-            <a:noFill/>
-          </a:ln>
-        </p:spPr>
-        <p:style>
-          <a:lnRef idx="1">
-            <a:schemeClr val="accent1"/>
-          </a:lnRef>
-          <a:fillRef idx="3">
-            <a:schemeClr val="accent1"/>
-          </a:fillRef>
-          <a:effectRef idx="2">
-            <a:schemeClr val="accent1"/>
-          </a:effectRef>
-          <a:fontRef idx="minor">
-            <a:schemeClr val="lt1"/>
-          </a:fontRef>
-        </p:style>
-        <p:txBody>
-          <a:bodyPr rtlCol="0" anchor="ctr"/>
-          <a:lstStyle/>
-          <a:p>
-            <a:pPr algn="ctr"/>
-          </a:p>
-        </p:txBody>
-      </p:sp>
-      <p:sp>
-        <p:nvSpPr>
-          <p:cNvPr id="17" name="TextBox 16"/>
-          <p:cNvSpPr txBox="1"/>
-          <p:nvPr/>
-        </p:nvSpPr>
-        <p:spPr>
-          <a:xfrm>
-            <a:off x="457200" y="4663440"/>
-            <a:ext cx="411480" cy="411480"/>
-          </a:xfrm>
-          <a:prstGeom prst="rect">
-            <a:avLst/>
-          </a:prstGeom>
-          <a:noFill/>
-        </p:spPr>
-        <p:txBody>
-          <a:bodyPr wrap="none" anchor="ctr">
-            <a:spAutoFit/>
-          </a:bodyPr>
-          <a:lstStyle/>
-          <a:p>
-            <a:pPr algn="ctr">
-              <a:defRPr sz="2000" b="1">
-                <a:solidFill>
-                  <a:srgbClr val="0B0F1A"/>
-                </a:solidFill>
-              </a:defRPr>
-            </a:pPr>
-            <a:r>
-              <a:t>v</a:t>
-            </a:r>
-          </a:p>
-        </p:txBody>
-      </p:sp>
-      <p:sp>
-        <p:nvSpPr>
-          <p:cNvPr id="18" name="TextBox 17"/>
-          <p:cNvSpPr txBox="1"/>
-          <p:nvPr/>
-        </p:nvSpPr>
-        <p:spPr>
-          <a:xfrm>
-            <a:off x="1005840" y="4709160"/>
-            <a:ext cx="10728655" cy="731520"/>
-          </a:xfrm>
-          <a:prstGeom prst="rect">
-            <a:avLst/>
-          </a:prstGeom>
-          <a:noFill/>
-        </p:spPr>
-        <p:txBody>
-          <a:bodyPr wrap="square">
-            <a:spAutoFit/>
-          </a:bodyPr>
-          <a:lstStyle/>
+              <a:t>  Novel work: Claude recombines known patterns brilliantly but doesn't truly invent new algorithms.</a:t>
+            </a:r>
+          </a:p>
           <a:p>
             <a:pPr>
+              <a:spcBef>
+                <a:spcPts val="800"/>
+              </a:spcBef>
+              <a:spcAft>
+                <a:spcPts val="800"/>
+              </a:spcAft>
               <a:defRPr sz="2200">
                 <a:solidFill>
                   <a:srgbClr val="FFFFFF"/>
@@ -16617,112 +16204,17 @@
               </a:defRPr>
             </a:pPr>
             <a:r>
-              <a:t>MCP: Connect Claude to any external system</a:t>
-            </a:r>
-          </a:p>
-        </p:txBody>
-      </p:sp>
-      <p:sp>
-        <p:nvSpPr>
-          <p:cNvPr id="19" name="Oval 18"/>
-          <p:cNvSpPr/>
-          <p:nvPr/>
-        </p:nvSpPr>
-        <p:spPr>
-          <a:xfrm>
-            <a:off x="457200" y="5486400"/>
-            <a:ext cx="411480" cy="411480"/>
-          </a:xfrm>
-          <a:prstGeom prst="ellipse">
-            <a:avLst/>
-          </a:prstGeom>
-          <a:solidFill>
-            <a:srgbClr val="00D4AA"/>
-          </a:solidFill>
-          <a:ln>
-            <a:noFill/>
-          </a:ln>
-        </p:spPr>
-        <p:style>
-          <a:lnRef idx="1">
-            <a:schemeClr val="accent1"/>
-          </a:lnRef>
-          <a:fillRef idx="3">
-            <a:schemeClr val="accent1"/>
-          </a:fillRef>
-          <a:effectRef idx="2">
-            <a:schemeClr val="accent1"/>
-          </a:effectRef>
-          <a:fontRef idx="minor">
-            <a:schemeClr val="lt1"/>
-          </a:fontRef>
-        </p:style>
-        <p:txBody>
-          <a:bodyPr rtlCol="0" anchor="ctr"/>
-          <a:lstStyle/>
-          <a:p>
-            <a:pPr algn="ctr"/>
-          </a:p>
-        </p:txBody>
-      </p:sp>
-      <p:sp>
-        <p:nvSpPr>
-          <p:cNvPr id="20" name="TextBox 19"/>
-          <p:cNvSpPr txBox="1"/>
-          <p:nvPr/>
-        </p:nvSpPr>
-        <p:spPr>
-          <a:xfrm>
-            <a:off x="457200" y="5486400"/>
-            <a:ext cx="411480" cy="411480"/>
-          </a:xfrm>
-          <a:prstGeom prst="rect">
-            <a:avLst/>
-          </a:prstGeom>
-          <a:noFill/>
-        </p:spPr>
-        <p:txBody>
-          <a:bodyPr wrap="none" anchor="ctr">
-            <a:spAutoFit/>
-          </a:bodyPr>
-          <a:lstStyle/>
-          <a:p>
-            <a:pPr algn="ctr">
-              <a:defRPr sz="2000" b="1">
-                <a:solidFill>
-                  <a:srgbClr val="0B0F1A"/>
-                </a:solidFill>
-              </a:defRPr>
-            </a:pPr>
-            <a:r>
-              <a:t>v</a:t>
-            </a:r>
-          </a:p>
-        </p:txBody>
-      </p:sp>
-      <p:sp>
-        <p:nvSpPr>
-          <p:cNvPr id="21" name="TextBox 20"/>
-          <p:cNvSpPr txBox="1"/>
-          <p:nvPr/>
-        </p:nvSpPr>
-        <p:spPr>
-          <a:xfrm>
-            <a:off x="1005840" y="5532120"/>
-            <a:ext cx="10728655" cy="731520"/>
-          </a:xfrm>
-          <a:prstGeom prst="rect">
-            <a:avLst/>
-          </a:prstGeom>
-          <a:noFill/>
-        </p:spPr>
-        <p:txBody>
-          <a:bodyPr wrap="square">
-            <a:spAutoFit/>
-          </a:bodyPr>
-          <a:lstStyle/>
+              <a:t>  The 3 AM test: Could you debug this code at 3 AM without Claude? If not, you need to understand it better before ship...</a:t>
+            </a:r>
+          </a:p>
           <a:p>
             <a:pPr>
+              <a:spcBef>
+                <a:spcPts val="800"/>
+              </a:spcBef>
+              <a:spcAft>
+                <a:spcPts val="800"/>
+              </a:spcAft>
               <a:defRPr sz="2200">
                 <a:solidFill>
                   <a:srgbClr val="FFFFFF"/>
@@ -16730,7 +16222,7 @@
               </a:defRPr>
             </a:pPr>
             <a:r>
-              <a:t>Agent Teams: Parallel coordination for complex work</a:t>
+              <a:t>  This is why Plan Mode, decomposition, and verification matter — they keep you in control.</a:t>
             </a:r>
           </a:p>
         </p:txBody>
@@ -16763,49 +16255,14 @@
       <p:grpSpPr/>
       <p:sp>
         <p:nvSpPr>
-          <p:cNvPr id="2" name="TextBox 1"/>
-          <p:cNvSpPr txBox="1"/>
-          <p:nvPr/>
-        </p:nvSpPr>
-        <p:spPr>
-          <a:xfrm>
-            <a:off x="457200" y="365760"/>
-            <a:ext cx="11277295" cy="822960"/>
-          </a:xfrm>
-          <a:prstGeom prst="rect">
-            <a:avLst/>
-          </a:prstGeom>
-          <a:noFill/>
-        </p:spPr>
-        <p:txBody>
-          <a:bodyPr wrap="none">
-            <a:spAutoFit/>
-          </a:bodyPr>
-          <a:lstStyle/>
-          <a:p>
-            <a:pPr>
-              <a:defRPr sz="4000" b="1">
-                <a:solidFill>
-                  <a:srgbClr val="FFFFFF"/>
-                </a:solidFill>
-              </a:defRPr>
-            </a:pPr>
-            <a:r>
-              <a:t>Getting Started Roadmap</a:t>
-            </a:r>
-          </a:p>
-        </p:txBody>
-      </p:sp>
-      <p:sp>
-        <p:nvSpPr>
-          <p:cNvPr id="3" name="Rectangle 2"/>
+          <p:cNvPr id="2" name="Rectangle 1"/>
           <p:cNvSpPr/>
           <p:nvPr/>
         </p:nvSpPr>
         <p:spPr>
           <a:xfrm>
-            <a:off x="457200" y="1234440"/>
-            <a:ext cx="1828800" cy="36576"/>
+            <a:off x="0" y="1188720"/>
+            <a:ext cx="91440" cy="5029200"/>
           </a:xfrm>
           <a:prstGeom prst="rect">
             <a:avLst/>
@@ -16841,14 +16298,127 @@
       </p:sp>
       <p:sp>
         <p:nvSpPr>
-          <p:cNvPr id="4" name="TextBox 3"/>
+          <p:cNvPr id="3" name="TextBox 2"/>
           <p:cNvSpPr txBox="1"/>
           <p:nvPr/>
         </p:nvSpPr>
         <p:spPr>
           <a:xfrm>
-            <a:off x="457200" y="1463040"/>
-            <a:ext cx="11277295" cy="4572000"/>
+            <a:off x="457200" y="365760"/>
+            <a:ext cx="11277295" cy="822960"/>
+          </a:xfrm>
+          <a:prstGeom prst="rect">
+            <a:avLst/>
+          </a:prstGeom>
+          <a:noFill/>
+        </p:spPr>
+        <p:txBody>
+          <a:bodyPr wrap="none">
+            <a:spAutoFit/>
+          </a:bodyPr>
+          <a:lstStyle/>
+          <a:p>
+            <a:pPr>
+              <a:defRPr sz="4000" b="1">
+                <a:solidFill>
+                  <a:srgbClr val="FFFFFF"/>
+                </a:solidFill>
+              </a:defRPr>
+            </a:pPr>
+            <a:r>
+              <a:t>Day 3 Key Takeaways</a:t>
+            </a:r>
+          </a:p>
+        </p:txBody>
+      </p:sp>
+      <p:sp>
+        <p:nvSpPr>
+          <p:cNvPr id="4" name="Oval 3"/>
+          <p:cNvSpPr/>
+          <p:nvPr/>
+        </p:nvSpPr>
+        <p:spPr>
+          <a:xfrm>
+            <a:off x="457200" y="1371600"/>
+            <a:ext cx="411480" cy="411480"/>
+          </a:xfrm>
+          <a:prstGeom prst="ellipse">
+            <a:avLst/>
+          </a:prstGeom>
+          <a:solidFill>
+            <a:srgbClr val="00D4AA"/>
+          </a:solidFill>
+          <a:ln>
+            <a:noFill/>
+          </a:ln>
+        </p:spPr>
+        <p:style>
+          <a:lnRef idx="1">
+            <a:schemeClr val="accent1"/>
+          </a:lnRef>
+          <a:fillRef idx="3">
+            <a:schemeClr val="accent1"/>
+          </a:fillRef>
+          <a:effectRef idx="2">
+            <a:schemeClr val="accent1"/>
+          </a:effectRef>
+          <a:fontRef idx="minor">
+            <a:schemeClr val="lt1"/>
+          </a:fontRef>
+        </p:style>
+        <p:txBody>
+          <a:bodyPr rtlCol="0" anchor="ctr"/>
+          <a:lstStyle/>
+          <a:p>
+            <a:pPr algn="ctr"/>
+          </a:p>
+        </p:txBody>
+      </p:sp>
+      <p:sp>
+        <p:nvSpPr>
+          <p:cNvPr id="5" name="TextBox 4"/>
+          <p:cNvSpPr txBox="1"/>
+          <p:nvPr/>
+        </p:nvSpPr>
+        <p:spPr>
+          <a:xfrm>
+            <a:off x="457200" y="1371600"/>
+            <a:ext cx="411480" cy="411480"/>
+          </a:xfrm>
+          <a:prstGeom prst="rect">
+            <a:avLst/>
+          </a:prstGeom>
+          <a:noFill/>
+        </p:spPr>
+        <p:txBody>
+          <a:bodyPr wrap="none" anchor="ctr">
+            <a:spAutoFit/>
+          </a:bodyPr>
+          <a:lstStyle/>
+          <a:p>
+            <a:pPr algn="ctr">
+              <a:defRPr sz="2000" b="1">
+                <a:solidFill>
+                  <a:srgbClr val="0B0F1A"/>
+                </a:solidFill>
+              </a:defRPr>
+            </a:pPr>
+            <a:r>
+              <a:t>v</a:t>
+            </a:r>
+          </a:p>
+        </p:txBody>
+      </p:sp>
+      <p:sp>
+        <p:nvSpPr>
+          <p:cNvPr id="6" name="TextBox 5"/>
+          <p:cNvSpPr txBox="1"/>
+          <p:nvPr/>
+        </p:nvSpPr>
+        <p:spPr>
+          <a:xfrm>
+            <a:off x="1005840" y="1417320"/>
+            <a:ext cx="10728655" cy="731520"/>
           </a:xfrm>
           <a:prstGeom prst="rect">
             <a:avLst/>
@@ -16862,12 +16432,6 @@
           <a:lstStyle/>
           <a:p>
             <a:pPr>
-              <a:spcBef>
-                <a:spcPts val="800"/>
-              </a:spcBef>
-              <a:spcAft>
-                <a:spcPts val="800"/>
-              </a:spcAft>
               <a:defRPr sz="2200">
                 <a:solidFill>
                   <a:srgbClr val="FFFFFF"/>
@@ -16875,17 +16439,112 @@
               </a:defRPr>
             </a:pPr>
             <a:r>
-              <a:t>  Week 1: Create 2-3 custom commands for your daily workflows</a:t>
-            </a:r>
-          </a:p>
+              <a:t>Custom commands: Reusable workflows in .claude/commands/</a:t>
+            </a:r>
+          </a:p>
+        </p:txBody>
+      </p:sp>
+      <p:sp>
+        <p:nvSpPr>
+          <p:cNvPr id="7" name="Oval 6"/>
+          <p:cNvSpPr/>
+          <p:nvPr/>
+        </p:nvSpPr>
+        <p:spPr>
+          <a:xfrm>
+            <a:off x="457200" y="2194560"/>
+            <a:ext cx="411480" cy="411480"/>
+          </a:xfrm>
+          <a:prstGeom prst="ellipse">
+            <a:avLst/>
+          </a:prstGeom>
+          <a:solidFill>
+            <a:srgbClr val="00D4AA"/>
+          </a:solidFill>
+          <a:ln>
+            <a:noFill/>
+          </a:ln>
+        </p:spPr>
+        <p:style>
+          <a:lnRef idx="1">
+            <a:schemeClr val="accent1"/>
+          </a:lnRef>
+          <a:fillRef idx="3">
+            <a:schemeClr val="accent1"/>
+          </a:fillRef>
+          <a:effectRef idx="2">
+            <a:schemeClr val="accent1"/>
+          </a:effectRef>
+          <a:fontRef idx="minor">
+            <a:schemeClr val="lt1"/>
+          </a:fontRef>
+        </p:style>
+        <p:txBody>
+          <a:bodyPr rtlCol="0" anchor="ctr"/>
+          <a:lstStyle/>
+          <a:p>
+            <a:pPr algn="ctr"/>
+          </a:p>
+        </p:txBody>
+      </p:sp>
+      <p:sp>
+        <p:nvSpPr>
+          <p:cNvPr id="8" name="TextBox 7"/>
+          <p:cNvSpPr txBox="1"/>
+          <p:nvPr/>
+        </p:nvSpPr>
+        <p:spPr>
+          <a:xfrm>
+            <a:off x="457200" y="2194560"/>
+            <a:ext cx="411480" cy="411480"/>
+          </a:xfrm>
+          <a:prstGeom prst="rect">
+            <a:avLst/>
+          </a:prstGeom>
+          <a:noFill/>
+        </p:spPr>
+        <p:txBody>
+          <a:bodyPr wrap="none" anchor="ctr">
+            <a:spAutoFit/>
+          </a:bodyPr>
+          <a:lstStyle/>
+          <a:p>
+            <a:pPr algn="ctr">
+              <a:defRPr sz="2000" b="1">
+                <a:solidFill>
+                  <a:srgbClr val="0B0F1A"/>
+                </a:solidFill>
+              </a:defRPr>
+            </a:pPr>
+            <a:r>
+              <a:t>v</a:t>
+            </a:r>
+          </a:p>
+        </p:txBody>
+      </p:sp>
+      <p:sp>
+        <p:nvSpPr>
+          <p:cNvPr id="9" name="TextBox 8"/>
+          <p:cNvSpPr txBox="1"/>
+          <p:nvPr/>
+        </p:nvSpPr>
+        <p:spPr>
+          <a:xfrm>
+            <a:off x="1005840" y="2240280"/>
+            <a:ext cx="10728655" cy="731520"/>
+          </a:xfrm>
+          <a:prstGeom prst="rect">
+            <a:avLst/>
+          </a:prstGeom>
+          <a:noFill/>
+        </p:spPr>
+        <p:txBody>
+          <a:bodyPr wrap="square">
+            <a:spAutoFit/>
+          </a:bodyPr>
+          <a:lstStyle/>
           <a:p>
             <a:pPr>
-              <a:spcBef>
-                <a:spcPts val="800"/>
-              </a:spcBef>
-              <a:spcAft>
-                <a:spcPts val="800"/>
-              </a:spcAft>
               <a:defRPr sz="2200">
                 <a:solidFill>
                   <a:srgbClr val="FFFFFF"/>
@@ -16893,17 +16552,112 @@
               </a:defRPr>
             </a:pPr>
             <a:r>
-              <a:t>  Week 2: Implement pre-tool hook for security (no secrets)</a:t>
-            </a:r>
-          </a:p>
+              <a:t>Subagents: Specialized AI workers for focused tasks</a:t>
+            </a:r>
+          </a:p>
+        </p:txBody>
+      </p:sp>
+      <p:sp>
+        <p:nvSpPr>
+          <p:cNvPr id="10" name="Oval 9"/>
+          <p:cNvSpPr/>
+          <p:nvPr/>
+        </p:nvSpPr>
+        <p:spPr>
+          <a:xfrm>
+            <a:off x="457200" y="3017520"/>
+            <a:ext cx="411480" cy="411480"/>
+          </a:xfrm>
+          <a:prstGeom prst="ellipse">
+            <a:avLst/>
+          </a:prstGeom>
+          <a:solidFill>
+            <a:srgbClr val="00D4AA"/>
+          </a:solidFill>
+          <a:ln>
+            <a:noFill/>
+          </a:ln>
+        </p:spPr>
+        <p:style>
+          <a:lnRef idx="1">
+            <a:schemeClr val="accent1"/>
+          </a:lnRef>
+          <a:fillRef idx="3">
+            <a:schemeClr val="accent1"/>
+          </a:fillRef>
+          <a:effectRef idx="2">
+            <a:schemeClr val="accent1"/>
+          </a:effectRef>
+          <a:fontRef idx="minor">
+            <a:schemeClr val="lt1"/>
+          </a:fontRef>
+        </p:style>
+        <p:txBody>
+          <a:bodyPr rtlCol="0" anchor="ctr"/>
+          <a:lstStyle/>
+          <a:p>
+            <a:pPr algn="ctr"/>
+          </a:p>
+        </p:txBody>
+      </p:sp>
+      <p:sp>
+        <p:nvSpPr>
+          <p:cNvPr id="11" name="TextBox 10"/>
+          <p:cNvSpPr txBox="1"/>
+          <p:nvPr/>
+        </p:nvSpPr>
+        <p:spPr>
+          <a:xfrm>
+            <a:off x="457200" y="3017520"/>
+            <a:ext cx="411480" cy="411480"/>
+          </a:xfrm>
+          <a:prstGeom prst="rect">
+            <a:avLst/>
+          </a:prstGeom>
+          <a:noFill/>
+        </p:spPr>
+        <p:txBody>
+          <a:bodyPr wrap="none" anchor="ctr">
+            <a:spAutoFit/>
+          </a:bodyPr>
+          <a:lstStyle/>
+          <a:p>
+            <a:pPr algn="ctr">
+              <a:defRPr sz="2000" b="1">
+                <a:solidFill>
+                  <a:srgbClr val="0B0F1A"/>
+                </a:solidFill>
+              </a:defRPr>
+            </a:pPr>
+            <a:r>
+              <a:t>v</a:t>
+            </a:r>
+          </a:p>
+        </p:txBody>
+      </p:sp>
+      <p:sp>
+        <p:nvSpPr>
+          <p:cNvPr id="12" name="TextBox 11"/>
+          <p:cNvSpPr txBox="1"/>
+          <p:nvPr/>
+        </p:nvSpPr>
+        <p:spPr>
+          <a:xfrm>
+            <a:off x="1005840" y="3063240"/>
+            <a:ext cx="10728655" cy="731520"/>
+          </a:xfrm>
+          <a:prstGeom prst="rect">
+            <a:avLst/>
+          </a:prstGeom>
+          <a:noFill/>
+        </p:spPr>
+        <p:txBody>
+          <a:bodyPr wrap="square">
+            <a:spAutoFit/>
+          </a:bodyPr>
+          <a:lstStyle/>
           <a:p>
             <a:pPr>
-              <a:spcBef>
-                <a:spcPts val="800"/>
-              </a:spcBef>
-              <a:spcAft>
-                <a:spcPts val="800"/>
-              </a:spcAft>
               <a:defRPr sz="2200">
                 <a:solidFill>
                   <a:srgbClr val="FFFFFF"/>
@@ -16911,17 +16665,112 @@
               </a:defRPr>
             </a:pPr>
             <a:r>
-              <a:t>  Week 3: Install 1 MCP server (GitHub or your most-used tool)</a:t>
-            </a:r>
-          </a:p>
+              <a:t>Hooks: Safety guardrails and audit logging</a:t>
+            </a:r>
+          </a:p>
+        </p:txBody>
+      </p:sp>
+      <p:sp>
+        <p:nvSpPr>
+          <p:cNvPr id="13" name="Oval 12"/>
+          <p:cNvSpPr/>
+          <p:nvPr/>
+        </p:nvSpPr>
+        <p:spPr>
+          <a:xfrm>
+            <a:off x="457200" y="3840480"/>
+            <a:ext cx="411480" cy="411480"/>
+          </a:xfrm>
+          <a:prstGeom prst="ellipse">
+            <a:avLst/>
+          </a:prstGeom>
+          <a:solidFill>
+            <a:srgbClr val="00D4AA"/>
+          </a:solidFill>
+          <a:ln>
+            <a:noFill/>
+          </a:ln>
+        </p:spPr>
+        <p:style>
+          <a:lnRef idx="1">
+            <a:schemeClr val="accent1"/>
+          </a:lnRef>
+          <a:fillRef idx="3">
+            <a:schemeClr val="accent1"/>
+          </a:fillRef>
+          <a:effectRef idx="2">
+            <a:schemeClr val="accent1"/>
+          </a:effectRef>
+          <a:fontRef idx="minor">
+            <a:schemeClr val="lt1"/>
+          </a:fontRef>
+        </p:style>
+        <p:txBody>
+          <a:bodyPr rtlCol="0" anchor="ctr"/>
+          <a:lstStyle/>
+          <a:p>
+            <a:pPr algn="ctr"/>
+          </a:p>
+        </p:txBody>
+      </p:sp>
+      <p:sp>
+        <p:nvSpPr>
+          <p:cNvPr id="14" name="TextBox 13"/>
+          <p:cNvSpPr txBox="1"/>
+          <p:nvPr/>
+        </p:nvSpPr>
+        <p:spPr>
+          <a:xfrm>
+            <a:off x="457200" y="3840480"/>
+            <a:ext cx="411480" cy="411480"/>
+          </a:xfrm>
+          <a:prstGeom prst="rect">
+            <a:avLst/>
+          </a:prstGeom>
+          <a:noFill/>
+        </p:spPr>
+        <p:txBody>
+          <a:bodyPr wrap="none" anchor="ctr">
+            <a:spAutoFit/>
+          </a:bodyPr>
+          <a:lstStyle/>
+          <a:p>
+            <a:pPr algn="ctr">
+              <a:defRPr sz="2000" b="1">
+                <a:solidFill>
+                  <a:srgbClr val="0B0F1A"/>
+                </a:solidFill>
+              </a:defRPr>
+            </a:pPr>
+            <a:r>
+              <a:t>v</a:t>
+            </a:r>
+          </a:p>
+        </p:txBody>
+      </p:sp>
+      <p:sp>
+        <p:nvSpPr>
+          <p:cNvPr id="15" name="TextBox 14"/>
+          <p:cNvSpPr txBox="1"/>
+          <p:nvPr/>
+        </p:nvSpPr>
+        <p:spPr>
+          <a:xfrm>
+            <a:off x="1005840" y="3886200"/>
+            <a:ext cx="10728655" cy="731520"/>
+          </a:xfrm>
+          <a:prstGeom prst="rect">
+            <a:avLst/>
+          </a:prstGeom>
+          <a:noFill/>
+        </p:spPr>
+        <p:txBody>
+          <a:bodyPr wrap="square">
+            <a:spAutoFit/>
+          </a:bodyPr>
+          <a:lstStyle/>
           <a:p>
             <a:pPr>
-              <a:spcBef>
-                <a:spcPts val="800"/>
-              </a:spcBef>
-              <a:spcAft>
-                <a:spcPts val="800"/>
-              </a:spcAft>
               <a:defRPr sz="2200">
                 <a:solidFill>
                   <a:srgbClr val="FFFFFF"/>
@@ -16929,17 +16778,112 @@
               </a:defRPr>
             </a:pPr>
             <a:r>
-              <a:t>  Week 4: Create custom subagent for your domain</a:t>
-            </a:r>
-          </a:p>
+              <a:t>Plan mode + thinking levels: Control quality/speed/cost tradeoffs</a:t>
+            </a:r>
+          </a:p>
+        </p:txBody>
+      </p:sp>
+      <p:sp>
+        <p:nvSpPr>
+          <p:cNvPr id="16" name="Oval 15"/>
+          <p:cNvSpPr/>
+          <p:nvPr/>
+        </p:nvSpPr>
+        <p:spPr>
+          <a:xfrm>
+            <a:off x="457200" y="4663440"/>
+            <a:ext cx="411480" cy="411480"/>
+          </a:xfrm>
+          <a:prstGeom prst="ellipse">
+            <a:avLst/>
+          </a:prstGeom>
+          <a:solidFill>
+            <a:srgbClr val="00D4AA"/>
+          </a:solidFill>
+          <a:ln>
+            <a:noFill/>
+          </a:ln>
+        </p:spPr>
+        <p:style>
+          <a:lnRef idx="1">
+            <a:schemeClr val="accent1"/>
+          </a:lnRef>
+          <a:fillRef idx="3">
+            <a:schemeClr val="accent1"/>
+          </a:fillRef>
+          <a:effectRef idx="2">
+            <a:schemeClr val="accent1"/>
+          </a:effectRef>
+          <a:fontRef idx="minor">
+            <a:schemeClr val="lt1"/>
+          </a:fontRef>
+        </p:style>
+        <p:txBody>
+          <a:bodyPr rtlCol="0" anchor="ctr"/>
+          <a:lstStyle/>
+          <a:p>
+            <a:pPr algn="ctr"/>
+          </a:p>
+        </p:txBody>
+      </p:sp>
+      <p:sp>
+        <p:nvSpPr>
+          <p:cNvPr id="17" name="TextBox 16"/>
+          <p:cNvSpPr txBox="1"/>
+          <p:nvPr/>
+        </p:nvSpPr>
+        <p:spPr>
+          <a:xfrm>
+            <a:off x="457200" y="4663440"/>
+            <a:ext cx="411480" cy="411480"/>
+          </a:xfrm>
+          <a:prstGeom prst="rect">
+            <a:avLst/>
+          </a:prstGeom>
+          <a:noFill/>
+        </p:spPr>
+        <p:txBody>
+          <a:bodyPr wrap="none" anchor="ctr">
+            <a:spAutoFit/>
+          </a:bodyPr>
+          <a:lstStyle/>
+          <a:p>
+            <a:pPr algn="ctr">
+              <a:defRPr sz="2000" b="1">
+                <a:solidFill>
+                  <a:srgbClr val="0B0F1A"/>
+                </a:solidFill>
+              </a:defRPr>
+            </a:pPr>
+            <a:r>
+              <a:t>v</a:t>
+            </a:r>
+          </a:p>
+        </p:txBody>
+      </p:sp>
+      <p:sp>
+        <p:nvSpPr>
+          <p:cNvPr id="18" name="TextBox 17"/>
+          <p:cNvSpPr txBox="1"/>
+          <p:nvPr/>
+        </p:nvSpPr>
+        <p:spPr>
+          <a:xfrm>
+            <a:off x="1005840" y="4709160"/>
+            <a:ext cx="10728655" cy="731520"/>
+          </a:xfrm>
+          <a:prstGeom prst="rect">
+            <a:avLst/>
+          </a:prstGeom>
+          <a:noFill/>
+        </p:spPr>
+        <p:txBody>
+          <a:bodyPr wrap="square">
+            <a:spAutoFit/>
+          </a:bodyPr>
+          <a:lstStyle/>
           <a:p>
             <a:pPr>
-              <a:spcBef>
-                <a:spcPts val="800"/>
-              </a:spcBef>
-              <a:spcAft>
-                <a:spcPts val="800"/>
-              </a:spcAft>
               <a:defRPr sz="2200">
                 <a:solidFill>
                   <a:srgbClr val="FFFFFF"/>
@@ -16947,17 +16891,112 @@
               </a:defRPr>
             </a:pPr>
             <a:r>
-              <a:t>  Month 2: Optimize CLAUDE.md with team conventions</a:t>
-            </a:r>
-          </a:p>
+              <a:t>MCP: Connect Claude to any external system</a:t>
+            </a:r>
+          </a:p>
+        </p:txBody>
+      </p:sp>
+      <p:sp>
+        <p:nvSpPr>
+          <p:cNvPr id="19" name="Oval 18"/>
+          <p:cNvSpPr/>
+          <p:nvPr/>
+        </p:nvSpPr>
+        <p:spPr>
+          <a:xfrm>
+            <a:off x="457200" y="5486400"/>
+            <a:ext cx="411480" cy="411480"/>
+          </a:xfrm>
+          <a:prstGeom prst="ellipse">
+            <a:avLst/>
+          </a:prstGeom>
+          <a:solidFill>
+            <a:srgbClr val="00D4AA"/>
+          </a:solidFill>
+          <a:ln>
+            <a:noFill/>
+          </a:ln>
+        </p:spPr>
+        <p:style>
+          <a:lnRef idx="1">
+            <a:schemeClr val="accent1"/>
+          </a:lnRef>
+          <a:fillRef idx="3">
+            <a:schemeClr val="accent1"/>
+          </a:fillRef>
+          <a:effectRef idx="2">
+            <a:schemeClr val="accent1"/>
+          </a:effectRef>
+          <a:fontRef idx="minor">
+            <a:schemeClr val="lt1"/>
+          </a:fontRef>
+        </p:style>
+        <p:txBody>
+          <a:bodyPr rtlCol="0" anchor="ctr"/>
+          <a:lstStyle/>
+          <a:p>
+            <a:pPr algn="ctr"/>
+          </a:p>
+        </p:txBody>
+      </p:sp>
+      <p:sp>
+        <p:nvSpPr>
+          <p:cNvPr id="20" name="TextBox 19"/>
+          <p:cNvSpPr txBox="1"/>
+          <p:nvPr/>
+        </p:nvSpPr>
+        <p:spPr>
+          <a:xfrm>
+            <a:off x="457200" y="5486400"/>
+            <a:ext cx="411480" cy="411480"/>
+          </a:xfrm>
+          <a:prstGeom prst="rect">
+            <a:avLst/>
+          </a:prstGeom>
+          <a:noFill/>
+        </p:spPr>
+        <p:txBody>
+          <a:bodyPr wrap="none" anchor="ctr">
+            <a:spAutoFit/>
+          </a:bodyPr>
+          <a:lstStyle/>
+          <a:p>
+            <a:pPr algn="ctr">
+              <a:defRPr sz="2000" b="1">
+                <a:solidFill>
+                  <a:srgbClr val="0B0F1A"/>
+                </a:solidFill>
+              </a:defRPr>
+            </a:pPr>
+            <a:r>
+              <a:t>v</a:t>
+            </a:r>
+          </a:p>
+        </p:txBody>
+      </p:sp>
+      <p:sp>
+        <p:nvSpPr>
+          <p:cNvPr id="21" name="TextBox 20"/>
+          <p:cNvSpPr txBox="1"/>
+          <p:nvPr/>
+        </p:nvSpPr>
+        <p:spPr>
+          <a:xfrm>
+            <a:off x="1005840" y="5532120"/>
+            <a:ext cx="10728655" cy="731520"/>
+          </a:xfrm>
+          <a:prstGeom prst="rect">
+            <a:avLst/>
+          </a:prstGeom>
+          <a:noFill/>
+        </p:spPr>
+        <p:txBody>
+          <a:bodyPr wrap="square">
+            <a:spAutoFit/>
+          </a:bodyPr>
+          <a:lstStyle/>
           <a:p>
             <a:pPr>
-              <a:spcBef>
-                <a:spcPts val="800"/>
-              </a:spcBef>
-              <a:spcAft>
-                <a:spcPts val="800"/>
-              </a:spcAft>
               <a:defRPr sz="2200">
                 <a:solidFill>
                   <a:srgbClr val="FFFFFF"/>
@@ -16965,7 +17004,7 @@
               </a:defRPr>
             </a:pPr>
             <a:r>
-              <a:t>  Month 3: Pilot Agent Teams on complex project</a:t>
+              <a:t>Agent Teams: Parallel coordination for complex work</a:t>
             </a:r>
           </a:p>
         </p:txBody>
@@ -17026,7 +17065,7 @@
               </a:defRPr>
             </a:pPr>
             <a:r>
-              <a:t>Resources</a:t>
+              <a:t>Getting Started Roadmap</a:t>
             </a:r>
           </a:p>
         </p:txBody>
@@ -17110,7 +17149,7 @@
               </a:defRPr>
             </a:pPr>
             <a:r>
-              <a:t>  Claude Code Docs: docs.anthropic.com/claude-code</a:t>
+              <a:t>  Week 1: Create 2-3 custom commands for your daily workflows</a:t>
             </a:r>
           </a:p>
           <a:p>
@@ -17128,7 +17167,7 @@
               </a:defRPr>
             </a:pPr>
             <a:r>
-              <a:t>  MCP Protocol: modelcontextprotocol.io</a:t>
+              <a:t>  Week 2: Implement pre-tool hook for security (no secrets)</a:t>
             </a:r>
           </a:p>
           <a:p>
@@ -17146,7 +17185,7 @@
               </a:defRPr>
             </a:pPr>
             <a:r>
-              <a:t>  MCP Servers: github.com/modelcontextprotocol/servers</a:t>
+              <a:t>  Week 3: Install 1 MCP server (GitHub or your most-used tool)</a:t>
             </a:r>
           </a:p>
           <a:p>
@@ -17164,7 +17203,7 @@
               </a:defRPr>
             </a:pPr>
             <a:r>
-              <a:t>  Community Commands: github.com/hesreallyhim/awesome-claude-code</a:t>
+              <a:t>  Week 4: Create custom subagent for your domain</a:t>
             </a:r>
           </a:p>
           <a:p>
@@ -17182,7 +17221,7 @@
               </a:defRPr>
             </a:pPr>
             <a:r>
-              <a:t>  Agent Teams Examples: github.com/ColeMedin/AgentTeamsExamples</a:t>
+              <a:t>  Month 2: Optimize CLAUDE.md with team conventions</a:t>
             </a:r>
           </a:p>
           <a:p>
@@ -17200,25 +17239,7 @@
               </a:defRPr>
             </a:pPr>
             <a:r>
-              <a:t>  Discord: discord.gg/anthropic-community</a:t>
-            </a:r>
-          </a:p>
-          <a:p>
-            <a:pPr>
-              <a:spcBef>
-                <a:spcPts val="800"/>
-              </a:spcBef>
-              <a:spcAft>
-                <a:spcPts val="800"/>
-              </a:spcAft>
-              <a:defRPr sz="2200">
-                <a:solidFill>
-                  <a:srgbClr val="FFFFFF"/>
-                </a:solidFill>
-              </a:defRPr>
-            </a:pPr>
-            <a:r>
-              <a:t>  Your team: Schedule follow-up in 2 weeks to share learnings</a:t>
+              <a:t>  Month 3: Pilot Agent Teams on complex project</a:t>
             </a:r>
           </a:p>
         </p:txBody>
@@ -17257,6 +17278,259 @@
         </p:nvSpPr>
         <p:spPr>
           <a:xfrm>
+            <a:off x="457200" y="365760"/>
+            <a:ext cx="11277295" cy="822960"/>
+          </a:xfrm>
+          <a:prstGeom prst="rect">
+            <a:avLst/>
+          </a:prstGeom>
+          <a:noFill/>
+        </p:spPr>
+        <p:txBody>
+          <a:bodyPr wrap="none">
+            <a:spAutoFit/>
+          </a:bodyPr>
+          <a:lstStyle/>
+          <a:p>
+            <a:pPr>
+              <a:defRPr sz="4000" b="1">
+                <a:solidFill>
+                  <a:srgbClr val="FFFFFF"/>
+                </a:solidFill>
+              </a:defRPr>
+            </a:pPr>
+            <a:r>
+              <a:t>Resources</a:t>
+            </a:r>
+          </a:p>
+        </p:txBody>
+      </p:sp>
+      <p:sp>
+        <p:nvSpPr>
+          <p:cNvPr id="3" name="Rectangle 2"/>
+          <p:cNvSpPr/>
+          <p:nvPr/>
+        </p:nvSpPr>
+        <p:spPr>
+          <a:xfrm>
+            <a:off x="457200" y="1234440"/>
+            <a:ext cx="1828800" cy="36576"/>
+          </a:xfrm>
+          <a:prstGeom prst="rect">
+            <a:avLst/>
+          </a:prstGeom>
+          <a:solidFill>
+            <a:srgbClr val="00D4AA"/>
+          </a:solidFill>
+          <a:ln>
+            <a:noFill/>
+          </a:ln>
+        </p:spPr>
+        <p:style>
+          <a:lnRef idx="1">
+            <a:schemeClr val="accent1"/>
+          </a:lnRef>
+          <a:fillRef idx="3">
+            <a:schemeClr val="accent1"/>
+          </a:fillRef>
+          <a:effectRef idx="2">
+            <a:schemeClr val="accent1"/>
+          </a:effectRef>
+          <a:fontRef idx="minor">
+            <a:schemeClr val="lt1"/>
+          </a:fontRef>
+        </p:style>
+        <p:txBody>
+          <a:bodyPr rtlCol="0" anchor="ctr"/>
+          <a:lstStyle/>
+          <a:p>
+            <a:pPr algn="ctr"/>
+          </a:p>
+        </p:txBody>
+      </p:sp>
+      <p:sp>
+        <p:nvSpPr>
+          <p:cNvPr id="4" name="TextBox 3"/>
+          <p:cNvSpPr txBox="1"/>
+          <p:nvPr/>
+        </p:nvSpPr>
+        <p:spPr>
+          <a:xfrm>
+            <a:off x="457200" y="1463040"/>
+            <a:ext cx="11277295" cy="4572000"/>
+          </a:xfrm>
+          <a:prstGeom prst="rect">
+            <a:avLst/>
+          </a:prstGeom>
+          <a:noFill/>
+        </p:spPr>
+        <p:txBody>
+          <a:bodyPr wrap="square">
+            <a:spAutoFit/>
+          </a:bodyPr>
+          <a:lstStyle/>
+          <a:p>
+            <a:pPr>
+              <a:spcBef>
+                <a:spcPts val="800"/>
+              </a:spcBef>
+              <a:spcAft>
+                <a:spcPts val="800"/>
+              </a:spcAft>
+              <a:defRPr sz="2200">
+                <a:solidFill>
+                  <a:srgbClr val="FFFFFF"/>
+                </a:solidFill>
+              </a:defRPr>
+            </a:pPr>
+            <a:r>
+              <a:t>  Claude Code Docs: docs.anthropic.com/claude-code</a:t>
+            </a:r>
+          </a:p>
+          <a:p>
+            <a:pPr>
+              <a:spcBef>
+                <a:spcPts val="800"/>
+              </a:spcBef>
+              <a:spcAft>
+                <a:spcPts val="800"/>
+              </a:spcAft>
+              <a:defRPr sz="2200">
+                <a:solidFill>
+                  <a:srgbClr val="FFFFFF"/>
+                </a:solidFill>
+              </a:defRPr>
+            </a:pPr>
+            <a:r>
+              <a:t>  MCP Protocol: modelcontextprotocol.io</a:t>
+            </a:r>
+          </a:p>
+          <a:p>
+            <a:pPr>
+              <a:spcBef>
+                <a:spcPts val="800"/>
+              </a:spcBef>
+              <a:spcAft>
+                <a:spcPts val="800"/>
+              </a:spcAft>
+              <a:defRPr sz="2200">
+                <a:solidFill>
+                  <a:srgbClr val="FFFFFF"/>
+                </a:solidFill>
+              </a:defRPr>
+            </a:pPr>
+            <a:r>
+              <a:t>  MCP Servers: github.com/modelcontextprotocol/servers</a:t>
+            </a:r>
+          </a:p>
+          <a:p>
+            <a:pPr>
+              <a:spcBef>
+                <a:spcPts val="800"/>
+              </a:spcBef>
+              <a:spcAft>
+                <a:spcPts val="800"/>
+              </a:spcAft>
+              <a:defRPr sz="2200">
+                <a:solidFill>
+                  <a:srgbClr val="FFFFFF"/>
+                </a:solidFill>
+              </a:defRPr>
+            </a:pPr>
+            <a:r>
+              <a:t>  Community Commands: github.com/hesreallyhim/awesome-claude-code</a:t>
+            </a:r>
+          </a:p>
+          <a:p>
+            <a:pPr>
+              <a:spcBef>
+                <a:spcPts val="800"/>
+              </a:spcBef>
+              <a:spcAft>
+                <a:spcPts val="800"/>
+              </a:spcAft>
+              <a:defRPr sz="2200">
+                <a:solidFill>
+                  <a:srgbClr val="FFFFFF"/>
+                </a:solidFill>
+              </a:defRPr>
+            </a:pPr>
+            <a:r>
+              <a:t>  Agent Teams Examples: github.com/ColeMedin/AgentTeamsExamples</a:t>
+            </a:r>
+          </a:p>
+          <a:p>
+            <a:pPr>
+              <a:spcBef>
+                <a:spcPts val="800"/>
+              </a:spcBef>
+              <a:spcAft>
+                <a:spcPts val="800"/>
+              </a:spcAft>
+              <a:defRPr sz="2200">
+                <a:solidFill>
+                  <a:srgbClr val="FFFFFF"/>
+                </a:solidFill>
+              </a:defRPr>
+            </a:pPr>
+            <a:r>
+              <a:t>  Discord: discord.gg/anthropic-community</a:t>
+            </a:r>
+          </a:p>
+          <a:p>
+            <a:pPr>
+              <a:spcBef>
+                <a:spcPts val="800"/>
+              </a:spcBef>
+              <a:spcAft>
+                <a:spcPts val="800"/>
+              </a:spcAft>
+              <a:defRPr sz="2200">
+                <a:solidFill>
+                  <a:srgbClr val="FFFFFF"/>
+                </a:solidFill>
+              </a:defRPr>
+            </a:pPr>
+            <a:r>
+              <a:t>  Your team: Schedule follow-up in 2 weeks to share learnings</a:t>
+            </a:r>
+          </a:p>
+        </p:txBody>
+      </p:sp>
+    </p:spTree>
+  </p:cSld>
+  <p:clrMapOvr>
+    <a:masterClrMapping/>
+  </p:clrMapOvr>
+</p:sld>
+</file>
+
+<file path=ppt/slides/slide105.xml><?xml version="1.0" encoding="utf-8"?>
+<p:sld xmlns:a="http://schemas.openxmlformats.org/drawingml/2006/main" xmlns:p="http://schemas.openxmlformats.org/presentationml/2006/main" xmlns:r="http://schemas.openxmlformats.org/officeDocument/2006/relationships">
+  <p:cSld>
+    <p:bg>
+      <p:bgPr>
+        <a:solidFill>
+          <a:srgbClr val="0B0F1A"/>
+        </a:solidFill>
+        <a:effectLst/>
+      </p:bgPr>
+    </p:bg>
+    <p:spTree>
+      <p:nvGrpSpPr>
+        <p:cNvPr id="1" name=""/>
+        <p:cNvGrpSpPr/>
+        <p:nvPr/>
+      </p:nvGrpSpPr>
+      <p:grpSpPr/>
+      <p:sp>
+        <p:nvSpPr>
+          <p:cNvPr id="2" name="TextBox 1"/>
+          <p:cNvSpPr txBox="1"/>
+          <p:nvPr/>
+        </p:nvSpPr>
+        <p:spPr>
+          <a:xfrm>
             <a:off x="457200" y="2286000"/>
             <a:ext cx="11277295" cy="2286000"/>
           </a:xfrm>
@@ -44775,8 +45049,8 @@
         </p:nvSpPr>
         <p:spPr>
           <a:xfrm>
-            <a:off x="457200" y="365760"/>
-            <a:ext cx="11277295" cy="822960"/>
+            <a:off x="457200" y="457200"/>
+            <a:ext cx="11277295" cy="731520"/>
           </a:xfrm>
           <a:prstGeom prst="rect">
             <a:avLst/>
@@ -44789,15 +45063,15 @@
           </a:bodyPr>
           <a:lstStyle/>
           <a:p>
-            <a:pPr>
-              <a:defRPr sz="4000" b="1">
+            <a:pPr algn="ctr">
+              <a:defRPr sz="3600" b="1">
                 <a:solidFill>
                   <a:srgbClr val="FFFFFF"/>
                 </a:solidFill>
               </a:defRPr>
             </a:pPr>
             <a:r>
-              <a:t>Cost Management &amp; Optimization</a:t>
+              <a:t>Remote Control: Claude Code from Your Phone</a:t>
             </a:r>
           </a:p>
         </p:txBody>
@@ -44810,8 +45084,8 @@
         </p:nvSpPr>
         <p:spPr>
           <a:xfrm>
-            <a:off x="457200" y="1234440"/>
-            <a:ext cx="1828800" cy="36576"/>
+            <a:off x="6077559" y="1371600"/>
+            <a:ext cx="36576" cy="4572000"/>
           </a:xfrm>
           <a:prstGeom prst="rect">
             <a:avLst/>
@@ -44854,7 +45128,7 @@
         <p:spPr>
           <a:xfrm>
             <a:off x="457200" y="1463040"/>
-            <a:ext cx="11277295" cy="4572000"/>
+            <a:ext cx="5364327" cy="731520"/>
           </a:xfrm>
           <a:prstGeom prst="rect">
             <a:avLst/>
@@ -44862,116 +45136,55 @@
           <a:noFill/>
         </p:spPr>
         <p:txBody>
-          <a:bodyPr wrap="square">
+          <a:bodyPr wrap="none">
             <a:spAutoFit/>
           </a:bodyPr>
           <a:lstStyle/>
           <a:p>
-            <a:pPr>
-              <a:spcBef>
-                <a:spcPts val="800"/>
-              </a:spcBef>
-              <a:spcAft>
-                <a:spcPts val="800"/>
-              </a:spcAft>
-              <a:defRPr sz="2200">
-                <a:solidFill>
-                  <a:srgbClr val="FFFFFF"/>
-                </a:solidFill>
-              </a:defRPr>
-            </a:pPr>
-            <a:r>
-              <a:t>  Model selection: Haiku for simple tasks, Sonnet default, Opus for critical</a:t>
-            </a:r>
-          </a:p>
-          <a:p>
-            <a:pPr>
-              <a:spcBef>
-                <a:spcPts val="800"/>
-              </a:spcBef>
-              <a:spcAft>
-                <a:spcPts val="800"/>
-              </a:spcAft>
-              <a:defRPr sz="2200">
-                <a:solidFill>
-                  <a:srgbClr val="FFFFFF"/>
-                </a:solidFill>
-              </a:defRPr>
-            </a:pPr>
-            <a:r>
-              <a:t>  Thinking levels: Low for routine, High for complex (3-5× cost difference)</a:t>
-            </a:r>
-          </a:p>
-          <a:p>
-            <a:pPr>
-              <a:spcBef>
-                <a:spcPts val="800"/>
-              </a:spcBef>
-              <a:spcAft>
-                <a:spcPts val="800"/>
-              </a:spcAft>
-              <a:defRPr sz="2200">
-                <a:solidFill>
-                  <a:srgbClr val="FFFFFF"/>
-                </a:solidFill>
-              </a:defRPr>
-            </a:pPr>
-            <a:r>
-              <a:t>  Subagents: Use Haiku subagents for research (10× cheaper)</a:t>
-            </a:r>
-          </a:p>
-          <a:p>
-            <a:pPr>
-              <a:spcBef>
-                <a:spcPts val="800"/>
-              </a:spcBef>
-              <a:spcAft>
-                <a:spcPts val="800"/>
-              </a:spcAft>
-              <a:defRPr sz="2200">
-                <a:solidFill>
-                  <a:srgbClr val="FFFFFF"/>
-                </a:solidFill>
-              </a:defRPr>
-            </a:pPr>
-            <a:r>
-              <a:t>  Context management: .claudeignore reduces unnecessary tokens</a:t>
-            </a:r>
-          </a:p>
-          <a:p>
-            <a:pPr>
-              <a:spcBef>
-                <a:spcPts val="800"/>
-              </a:spcBef>
-              <a:spcAft>
-                <a:spcPts val="800"/>
-              </a:spcAft>
-              <a:defRPr sz="2200">
-                <a:solidFill>
-                  <a:srgbClr val="FFFFFF"/>
-                </a:solidFill>
-              </a:defRPr>
-            </a:pPr>
-            <a:r>
-              <a:t>  Batch work: Multiple small changes in one session vs many sessions</a:t>
-            </a:r>
-          </a:p>
-          <a:p>
-            <a:pPr>
-              <a:spcBef>
-                <a:spcPts val="800"/>
-              </a:spcBef>
-              <a:spcAft>
-                <a:spcPts val="800"/>
-              </a:spcAft>
-              <a:defRPr sz="2200">
-                <a:solidFill>
-                  <a:srgbClr val="FFFFFF"/>
-                </a:solidFill>
-              </a:defRPr>
-            </a:pPr>
-            <a:r>
-              <a:t>  Monitor usage: Track tokens per task type, optimize high-volume patterns</a:t>
+            <a:pPr algn="ctr">
+              <a:defRPr sz="2800" b="1">
+                <a:solidFill>
+                  <a:srgbClr val="E86B4A"/>
+                </a:solidFill>
+              </a:defRPr>
+            </a:pPr>
+            <a:r>
+              <a:t>How It Works</a:t>
+            </a:r>
+          </a:p>
+        </p:txBody>
+      </p:sp>
+      <p:sp>
+        <p:nvSpPr>
+          <p:cNvPr id="5" name="TextBox 4"/>
+          <p:cNvSpPr txBox="1"/>
+          <p:nvPr/>
+        </p:nvSpPr>
+        <p:spPr>
+          <a:xfrm>
+            <a:off x="6370167" y="1463040"/>
+            <a:ext cx="5364327" cy="731520"/>
+          </a:xfrm>
+          <a:prstGeom prst="rect">
+            <a:avLst/>
+          </a:prstGeom>
+          <a:noFill/>
+        </p:spPr>
+        <p:txBody>
+          <a:bodyPr wrap="none">
+            <a:spAutoFit/>
+          </a:bodyPr>
+          <a:lstStyle/>
+          <a:p>
+            <a:pPr algn="ctr">
+              <a:defRPr sz="2800" b="1">
+                <a:solidFill>
+                  <a:srgbClr val="00D4AA"/>
+                </a:solidFill>
+              </a:defRPr>
+            </a:pPr>
+            <a:r>
+              <a:t>Why This Matters</a:t>
             </a:r>
           </a:p>
         </p:txBody>
@@ -45032,7 +45245,7 @@
               </a:defRPr>
             </a:pPr>
             <a:r>
-              <a:t>Token Efficiency Techniques</a:t>
+              <a:t>Cost Management &amp; Optimization</a:t>
             </a:r>
           </a:p>
         </p:txBody>
@@ -45116,7 +45329,7 @@
               </a:defRPr>
             </a:pPr>
             <a:r>
-              <a:t>  Use /compact to compress context mid-conversation</a:t>
+              <a:t>  Model selection: Haiku for simple tasks, Sonnet default, Opus for critical</a:t>
             </a:r>
           </a:p>
           <a:p>
@@ -45134,7 +45347,7 @@
               </a:defRPr>
             </a:pPr>
             <a:r>
-              <a:t>  Start fresh conversation for unrelated tasks (don't bloat context)</a:t>
+              <a:t>  Thinking levels: Low for routine, High for complex (3-5× cost difference)</a:t>
             </a:r>
           </a:p>
           <a:p>
@@ -45152,7 +45365,7 @@
               </a:defRPr>
             </a:pPr>
             <a:r>
-              <a:t>  .claudeignore aggressively: build/, dist/, node_modules/, .git/</a:t>
+              <a:t>  Subagents: Use Haiku subagents for research (10× cheaper)</a:t>
             </a:r>
           </a:p>
           <a:p>
@@ -45170,7 +45383,7 @@
               </a:defRPr>
             </a:pPr>
             <a:r>
-              <a:t>  Summarize long discussions: 'Summarize what we've accomplished'</a:t>
+              <a:t>  Context management: .claudeignore reduces unnecessary tokens</a:t>
             </a:r>
           </a:p>
           <a:p>
@@ -45188,7 +45401,7 @@
               </a:defRPr>
             </a:pPr>
             <a:r>
-              <a:t>  Avoid unnecessary file attachments (@mention only what's needed)</a:t>
+              <a:t>  Batch work: Multiple small changes in one session vs many sessions</a:t>
             </a:r>
           </a:p>
           <a:p>
@@ -45206,7 +45419,7 @@
               </a:defRPr>
             </a:pPr>
             <a:r>
-              <a:t>  Plan mode research uses @plan subagent (saves main context)</a:t>
+              <a:t>  Monitor usage: Track tokens per task type, optimize high-volume patterns</a:t>
             </a:r>
           </a:p>
         </p:txBody>
@@ -45245,8 +45458,86 @@
         </p:nvSpPr>
         <p:spPr>
           <a:xfrm>
-            <a:off x="731520" y="2286000"/>
-            <a:ext cx="10728655" cy="1371600"/>
+            <a:off x="457200" y="365760"/>
+            <a:ext cx="11277295" cy="822960"/>
+          </a:xfrm>
+          <a:prstGeom prst="rect">
+            <a:avLst/>
+          </a:prstGeom>
+          <a:noFill/>
+        </p:spPr>
+        <p:txBody>
+          <a:bodyPr wrap="none">
+            <a:spAutoFit/>
+          </a:bodyPr>
+          <a:lstStyle/>
+          <a:p>
+            <a:pPr>
+              <a:defRPr sz="4000" b="1">
+                <a:solidFill>
+                  <a:srgbClr val="FFFFFF"/>
+                </a:solidFill>
+              </a:defRPr>
+            </a:pPr>
+            <a:r>
+              <a:t>Token Efficiency Techniques</a:t>
+            </a:r>
+          </a:p>
+        </p:txBody>
+      </p:sp>
+      <p:sp>
+        <p:nvSpPr>
+          <p:cNvPr id="3" name="Rectangle 2"/>
+          <p:cNvSpPr/>
+          <p:nvPr/>
+        </p:nvSpPr>
+        <p:spPr>
+          <a:xfrm>
+            <a:off x="457200" y="1234440"/>
+            <a:ext cx="1828800" cy="36576"/>
+          </a:xfrm>
+          <a:prstGeom prst="rect">
+            <a:avLst/>
+          </a:prstGeom>
+          <a:solidFill>
+            <a:srgbClr val="00D4AA"/>
+          </a:solidFill>
+          <a:ln>
+            <a:noFill/>
+          </a:ln>
+        </p:spPr>
+        <p:style>
+          <a:lnRef idx="1">
+            <a:schemeClr val="accent1"/>
+          </a:lnRef>
+          <a:fillRef idx="3">
+            <a:schemeClr val="accent1"/>
+          </a:fillRef>
+          <a:effectRef idx="2">
+            <a:schemeClr val="accent1"/>
+          </a:effectRef>
+          <a:fontRef idx="minor">
+            <a:schemeClr val="lt1"/>
+          </a:fontRef>
+        </p:style>
+        <p:txBody>
+          <a:bodyPr rtlCol="0" anchor="ctr"/>
+          <a:lstStyle/>
+          <a:p>
+            <a:pPr algn="ctr"/>
+          </a:p>
+        </p:txBody>
+      </p:sp>
+      <p:sp>
+        <p:nvSpPr>
+          <p:cNvPr id="4" name="TextBox 3"/>
+          <p:cNvSpPr txBox="1"/>
+          <p:nvPr/>
+        </p:nvSpPr>
+        <p:spPr>
+          <a:xfrm>
+            <a:off x="457200" y="1463040"/>
+            <a:ext cx="11277295" cy="4572000"/>
           </a:xfrm>
           <a:prstGeom prst="rect">
             <a:avLst/>
@@ -45259,50 +45550,111 @@
           </a:bodyPr>
           <a:lstStyle/>
           <a:p>
-            <a:pPr algn="ctr">
-              <a:defRPr sz="5200" b="1">
+            <a:pPr>
+              <a:spcBef>
+                <a:spcPts val="800"/>
+              </a:spcBef>
+              <a:spcAft>
+                <a:spcPts val="800"/>
+              </a:spcAft>
+              <a:defRPr sz="2200">
                 <a:solidFill>
                   <a:srgbClr val="FFFFFF"/>
                 </a:solidFill>
               </a:defRPr>
             </a:pPr>
             <a:r>
-              <a:t>Engineering Principle: Optimize for Maintainability Over Cleverness</a:t>
-            </a:r>
-          </a:p>
-        </p:txBody>
-      </p:sp>
-      <p:sp>
-        <p:nvSpPr>
-          <p:cNvPr id="3" name="TextBox 2"/>
-          <p:cNvSpPr txBox="1"/>
-          <p:nvPr/>
-        </p:nvSpPr>
-        <p:spPr>
-          <a:xfrm>
-            <a:off x="914400" y="3840480"/>
-            <a:ext cx="10362895" cy="914400"/>
-          </a:xfrm>
-          <a:prstGeom prst="rect">
-            <a:avLst/>
-          </a:prstGeom>
-          <a:noFill/>
-        </p:spPr>
-        <p:txBody>
-          <a:bodyPr wrap="square">
-            <a:spAutoFit/>
-          </a:bodyPr>
-          <a:lstStyle/>
-          <a:p>
-            <a:pPr algn="ctr">
-              <a:defRPr sz="2400">
-                <a:solidFill>
-                  <a:srgbClr val="8B95A5"/>
-                </a:solidFill>
-              </a:defRPr>
-            </a:pPr>
-            <a:r>
-              <a:t>Source: Nate B Jones, 'Second Brain' video</a:t>
+              <a:t>  Use /compact to compress context mid-conversation</a:t>
+            </a:r>
+          </a:p>
+          <a:p>
+            <a:pPr>
+              <a:spcBef>
+                <a:spcPts val="800"/>
+              </a:spcBef>
+              <a:spcAft>
+                <a:spcPts val="800"/>
+              </a:spcAft>
+              <a:defRPr sz="2200">
+                <a:solidFill>
+                  <a:srgbClr val="FFFFFF"/>
+                </a:solidFill>
+              </a:defRPr>
+            </a:pPr>
+            <a:r>
+              <a:t>  Start fresh conversation for unrelated tasks (don't bloat context)</a:t>
+            </a:r>
+          </a:p>
+          <a:p>
+            <a:pPr>
+              <a:spcBef>
+                <a:spcPts val="800"/>
+              </a:spcBef>
+              <a:spcAft>
+                <a:spcPts val="800"/>
+              </a:spcAft>
+              <a:defRPr sz="2200">
+                <a:solidFill>
+                  <a:srgbClr val="FFFFFF"/>
+                </a:solidFill>
+              </a:defRPr>
+            </a:pPr>
+            <a:r>
+              <a:t>  .claudeignore aggressively: build/, dist/, node_modules/, .git/</a:t>
+            </a:r>
+          </a:p>
+          <a:p>
+            <a:pPr>
+              <a:spcBef>
+                <a:spcPts val="800"/>
+              </a:spcBef>
+              <a:spcAft>
+                <a:spcPts val="800"/>
+              </a:spcAft>
+              <a:defRPr sz="2200">
+                <a:solidFill>
+                  <a:srgbClr val="FFFFFF"/>
+                </a:solidFill>
+              </a:defRPr>
+            </a:pPr>
+            <a:r>
+              <a:t>  Summarize long discussions: 'Summarize what we've accomplished'</a:t>
+            </a:r>
+          </a:p>
+          <a:p>
+            <a:pPr>
+              <a:spcBef>
+                <a:spcPts val="800"/>
+              </a:spcBef>
+              <a:spcAft>
+                <a:spcPts val="800"/>
+              </a:spcAft>
+              <a:defRPr sz="2200">
+                <a:solidFill>
+                  <a:srgbClr val="FFFFFF"/>
+                </a:solidFill>
+              </a:defRPr>
+            </a:pPr>
+            <a:r>
+              <a:t>  Avoid unnecessary file attachments (@mention only what's needed)</a:t>
+            </a:r>
+          </a:p>
+          <a:p>
+            <a:pPr>
+              <a:spcBef>
+                <a:spcPts val="800"/>
+              </a:spcBef>
+              <a:spcAft>
+                <a:spcPts val="800"/>
+              </a:spcAft>
+              <a:defRPr sz="2200">
+                <a:solidFill>
+                  <a:srgbClr val="FFFFFF"/>
+                </a:solidFill>
+              </a:defRPr>
+            </a:pPr>
+            <a:r>
+              <a:t>  Plan mode research uses @plan subagent (saves main context)</a:t>
             </a:r>
           </a:p>
         </p:txBody>
@@ -45341,86 +45693,8 @@
         </p:nvSpPr>
         <p:spPr>
           <a:xfrm>
-            <a:off x="457200" y="365760"/>
-            <a:ext cx="11277295" cy="822960"/>
-          </a:xfrm>
-          <a:prstGeom prst="rect">
-            <a:avLst/>
-          </a:prstGeom>
-          <a:noFill/>
-        </p:spPr>
-        <p:txBody>
-          <a:bodyPr wrap="none">
-            <a:spAutoFit/>
-          </a:bodyPr>
-          <a:lstStyle/>
-          <a:p>
-            <a:pPr>
-              <a:defRPr sz="4000" b="1">
-                <a:solidFill>
-                  <a:srgbClr val="FFFFFF"/>
-                </a:solidFill>
-              </a:defRPr>
-            </a:pPr>
-            <a:r>
-              <a:t>Production Deployment Checklist</a:t>
-            </a:r>
-          </a:p>
-        </p:txBody>
-      </p:sp>
-      <p:sp>
-        <p:nvSpPr>
-          <p:cNvPr id="3" name="Rectangle 2"/>
-          <p:cNvSpPr/>
-          <p:nvPr/>
-        </p:nvSpPr>
-        <p:spPr>
-          <a:xfrm>
-            <a:off x="457200" y="1234440"/>
-            <a:ext cx="1828800" cy="36576"/>
-          </a:xfrm>
-          <a:prstGeom prst="rect">
-            <a:avLst/>
-          </a:prstGeom>
-          <a:solidFill>
-            <a:srgbClr val="00D4AA"/>
-          </a:solidFill>
-          <a:ln>
-            <a:noFill/>
-          </a:ln>
-        </p:spPr>
-        <p:style>
-          <a:lnRef idx="1">
-            <a:schemeClr val="accent1"/>
-          </a:lnRef>
-          <a:fillRef idx="3">
-            <a:schemeClr val="accent1"/>
-          </a:fillRef>
-          <a:effectRef idx="2">
-            <a:schemeClr val="accent1"/>
-          </a:effectRef>
-          <a:fontRef idx="minor">
-            <a:schemeClr val="lt1"/>
-          </a:fontRef>
-        </p:style>
-        <p:txBody>
-          <a:bodyPr rtlCol="0" anchor="ctr"/>
-          <a:lstStyle/>
-          <a:p>
-            <a:pPr algn="ctr"/>
-          </a:p>
-        </p:txBody>
-      </p:sp>
-      <p:sp>
-        <p:nvSpPr>
-          <p:cNvPr id="4" name="TextBox 3"/>
-          <p:cNvSpPr txBox="1"/>
-          <p:nvPr/>
-        </p:nvSpPr>
-        <p:spPr>
-          <a:xfrm>
-            <a:off x="457200" y="1463040"/>
-            <a:ext cx="11277295" cy="4572000"/>
+            <a:off x="731520" y="2286000"/>
+            <a:ext cx="10728655" cy="1371600"/>
           </a:xfrm>
           <a:prstGeom prst="rect">
             <a:avLst/>
@@ -45433,147 +45707,50 @@
           </a:bodyPr>
           <a:lstStyle/>
           <a:p>
-            <a:pPr>
-              <a:spcBef>
-                <a:spcPts val="800"/>
-              </a:spcBef>
-              <a:spcAft>
-                <a:spcPts val="800"/>
-              </a:spcAft>
-              <a:defRPr sz="2200">
+            <a:pPr algn="ctr">
+              <a:defRPr sz="5200" b="1">
                 <a:solidFill>
                   <a:srgbClr val="FFFFFF"/>
                 </a:solidFill>
               </a:defRPr>
             </a:pPr>
             <a:r>
-              <a:t>  ✅ CLAUDE.md configured with team standards</a:t>
-            </a:r>
-          </a:p>
-          <a:p>
-            <a:pPr>
-              <a:spcBef>
-                <a:spcPts val="800"/>
-              </a:spcBef>
-              <a:spcAft>
-                <a:spcPts val="800"/>
-              </a:spcAft>
-              <a:defRPr sz="2200">
-                <a:solidFill>
-                  <a:srgbClr val="FFFFFF"/>
-                </a:solidFill>
-              </a:defRPr>
-            </a:pPr>
-            <a:r>
-              <a:t>  ✅ Custom commands in .claude/commands/ (versioned in git)</a:t>
-            </a:r>
-          </a:p>
-          <a:p>
-            <a:pPr>
-              <a:spcBef>
-                <a:spcPts val="800"/>
-              </a:spcBef>
-              <a:spcAft>
-                <a:spcPts val="800"/>
-              </a:spcAft>
-              <a:defRPr sz="2200">
-                <a:solidFill>
-                  <a:srgbClr val="FFFFFF"/>
-                </a:solidFill>
-              </a:defRPr>
-            </a:pPr>
-            <a:r>
-              <a:t>  ✅ Pre-tool hooks for security (no secrets, safe commands)</a:t>
-            </a:r>
-          </a:p>
-          <a:p>
-            <a:pPr>
-              <a:spcBef>
-                <a:spcPts val="800"/>
-              </a:spcBef>
-              <a:spcAft>
-                <a:spcPts val="800"/>
-              </a:spcAft>
-              <a:defRPr sz="2200">
-                <a:solidFill>
-                  <a:srgbClr val="FFFFFF"/>
-                </a:solidFill>
-              </a:defRPr>
-            </a:pPr>
-            <a:r>
-              <a:t>  ✅ Post-tool hooks for audit logging</a:t>
-            </a:r>
-          </a:p>
-          <a:p>
-            <a:pPr>
-              <a:spcBef>
-                <a:spcPts val="800"/>
-              </a:spcBef>
-              <a:spcAft>
-                <a:spcPts val="800"/>
-              </a:spcAft>
-              <a:defRPr sz="2200">
-                <a:solidFill>
-                  <a:srgbClr val="FFFFFF"/>
-                </a:solidFill>
-              </a:defRPr>
-            </a:pPr>
-            <a:r>
-              <a:t>  ✅ .claudeignore optimized for project</a:t>
-            </a:r>
-          </a:p>
-          <a:p>
-            <a:pPr>
-              <a:spcBef>
-                <a:spcPts val="800"/>
-              </a:spcBef>
-              <a:spcAft>
-                <a:spcPts val="800"/>
-              </a:spcAft>
-              <a:defRPr sz="2200">
-                <a:solidFill>
-                  <a:srgbClr val="FFFFFF"/>
-                </a:solidFill>
-              </a:defRPr>
-            </a:pPr>
-            <a:r>
-              <a:t>  ✅ MCP servers approved and configured</a:t>
-            </a:r>
-          </a:p>
-          <a:p>
-            <a:pPr>
-              <a:spcBef>
-                <a:spcPts val="800"/>
-              </a:spcBef>
-              <a:spcAft>
-                <a:spcPts val="800"/>
-              </a:spcAft>
-              <a:defRPr sz="2200">
-                <a:solidFill>
-                  <a:srgbClr val="FFFFFF"/>
-                </a:solidFill>
-              </a:defRPr>
-            </a:pPr>
-            <a:r>
-              <a:t>  ✅ Team training on custom commands and workflows</a:t>
-            </a:r>
-          </a:p>
-          <a:p>
-            <a:pPr>
-              <a:spcBef>
-                <a:spcPts val="800"/>
-              </a:spcBef>
-              <a:spcAft>
-                <a:spcPts val="800"/>
-              </a:spcAft>
-              <a:defRPr sz="2200">
-                <a:solidFill>
-                  <a:srgbClr val="FFFFFF"/>
-                </a:solidFill>
-              </a:defRPr>
-            </a:pPr>
-            <a:r>
-              <a:t>  ✅ Cost monitoring and budgets in place</a:t>
+              <a:t>Engineering Principle: Optimize for Maintainability Over Cleverness</a:t>
+            </a:r>
+          </a:p>
+        </p:txBody>
+      </p:sp>
+      <p:sp>
+        <p:nvSpPr>
+          <p:cNvPr id="3" name="TextBox 2"/>
+          <p:cNvSpPr txBox="1"/>
+          <p:nvPr/>
+        </p:nvSpPr>
+        <p:spPr>
+          <a:xfrm>
+            <a:off x="914400" y="3840480"/>
+            <a:ext cx="10362895" cy="914400"/>
+          </a:xfrm>
+          <a:prstGeom prst="rect">
+            <a:avLst/>
+          </a:prstGeom>
+          <a:noFill/>
+        </p:spPr>
+        <p:txBody>
+          <a:bodyPr wrap="square">
+            <a:spAutoFit/>
+          </a:bodyPr>
+          <a:lstStyle/>
+          <a:p>
+            <a:pPr algn="ctr">
+              <a:defRPr sz="2400">
+                <a:solidFill>
+                  <a:srgbClr val="8B95A5"/>
+                </a:solidFill>
+              </a:defRPr>
+            </a:pPr>
+            <a:r>
+              <a:t>Source: Nate B Jones, 'Second Brain' video</a:t>
             </a:r>
           </a:p>
         </p:txBody>
@@ -45606,14 +45783,49 @@
       <p:grpSpPr/>
       <p:sp>
         <p:nvSpPr>
-          <p:cNvPr id="2" name="Rectangle 1"/>
+          <p:cNvPr id="2" name="TextBox 1"/>
+          <p:cNvSpPr txBox="1"/>
+          <p:nvPr/>
+        </p:nvSpPr>
+        <p:spPr>
+          <a:xfrm>
+            <a:off x="457200" y="365760"/>
+            <a:ext cx="11277295" cy="822960"/>
+          </a:xfrm>
+          <a:prstGeom prst="rect">
+            <a:avLst/>
+          </a:prstGeom>
+          <a:noFill/>
+        </p:spPr>
+        <p:txBody>
+          <a:bodyPr wrap="none">
+            <a:spAutoFit/>
+          </a:bodyPr>
+          <a:lstStyle/>
+          <a:p>
+            <a:pPr>
+              <a:defRPr sz="4000" b="1">
+                <a:solidFill>
+                  <a:srgbClr val="FFFFFF"/>
+                </a:solidFill>
+              </a:defRPr>
+            </a:pPr>
+            <a:r>
+              <a:t>Production Deployment Checklist</a:t>
+            </a:r>
+          </a:p>
+        </p:txBody>
+      </p:sp>
+      <p:sp>
+        <p:nvSpPr>
+          <p:cNvPr id="3" name="Rectangle 2"/>
           <p:cNvSpPr/>
           <p:nvPr/>
         </p:nvSpPr>
         <p:spPr>
           <a:xfrm>
-            <a:off x="0" y="1828800"/>
-            <a:ext cx="137160" cy="3200400"/>
+            <a:off x="457200" y="1234440"/>
+            <a:ext cx="1828800" cy="36576"/>
           </a:xfrm>
           <a:prstGeom prst="rect">
             <a:avLst/>
@@ -45649,14 +45861,14 @@
       </p:sp>
       <p:sp>
         <p:nvSpPr>
-          <p:cNvPr id="3" name="TextBox 2"/>
+          <p:cNvPr id="4" name="TextBox 3"/>
           <p:cNvSpPr txBox="1"/>
           <p:nvPr/>
         </p:nvSpPr>
         <p:spPr>
           <a:xfrm>
-            <a:off x="457200" y="2286000"/>
-            <a:ext cx="11277295" cy="1371600"/>
+            <a:off x="457200" y="1463040"/>
+            <a:ext cx="11277295" cy="4572000"/>
           </a:xfrm>
           <a:prstGeom prst="rect">
             <a:avLst/>
@@ -45670,49 +45882,146 @@
           <a:lstStyle/>
           <a:p>
             <a:pPr>
-              <a:defRPr sz="5600" b="1">
+              <a:spcBef>
+                <a:spcPts val="800"/>
+              </a:spcBef>
+              <a:spcAft>
+                <a:spcPts val="800"/>
+              </a:spcAft>
+              <a:defRPr sz="2200">
                 <a:solidFill>
                   <a:srgbClr val="FFFFFF"/>
                 </a:solidFill>
               </a:defRPr>
             </a:pPr>
             <a:r>
-              <a:t>Wrap-up</a:t>
-            </a:r>
-          </a:p>
-        </p:txBody>
-      </p:sp>
-      <p:sp>
-        <p:nvSpPr>
-          <p:cNvPr id="4" name="TextBox 3"/>
-          <p:cNvSpPr txBox="1"/>
-          <p:nvPr/>
-        </p:nvSpPr>
-        <p:spPr>
-          <a:xfrm>
-            <a:off x="457200" y="3840480"/>
-            <a:ext cx="11277295" cy="914400"/>
-          </a:xfrm>
-          <a:prstGeom prst="rect">
-            <a:avLst/>
-          </a:prstGeom>
-          <a:noFill/>
-        </p:spPr>
-        <p:txBody>
-          <a:bodyPr wrap="square">
-            <a:spAutoFit/>
-          </a:bodyPr>
-          <a:lstStyle/>
+              <a:t>  ✅ CLAUDE.md configured with team standards</a:t>
+            </a:r>
+          </a:p>
           <a:p>
             <a:pPr>
-              <a:defRPr sz="2400">
-                <a:solidFill>
-                  <a:srgbClr val="8B95A5"/>
-                </a:solidFill>
-              </a:defRPr>
-            </a:pPr>
-            <a:r>
-              <a:t>Key takeaways and next steps</a:t>
+              <a:spcBef>
+                <a:spcPts val="800"/>
+              </a:spcBef>
+              <a:spcAft>
+                <a:spcPts val="800"/>
+              </a:spcAft>
+              <a:defRPr sz="2200">
+                <a:solidFill>
+                  <a:srgbClr val="FFFFFF"/>
+                </a:solidFill>
+              </a:defRPr>
+            </a:pPr>
+            <a:r>
+              <a:t>  ✅ Custom commands in .claude/commands/ (versioned in git)</a:t>
+            </a:r>
+          </a:p>
+          <a:p>
+            <a:pPr>
+              <a:spcBef>
+                <a:spcPts val="800"/>
+              </a:spcBef>
+              <a:spcAft>
+                <a:spcPts val="800"/>
+              </a:spcAft>
+              <a:defRPr sz="2200">
+                <a:solidFill>
+                  <a:srgbClr val="FFFFFF"/>
+                </a:solidFill>
+              </a:defRPr>
+            </a:pPr>
+            <a:r>
+              <a:t>  ✅ Pre-tool hooks for security (no secrets, safe commands)</a:t>
+            </a:r>
+          </a:p>
+          <a:p>
+            <a:pPr>
+              <a:spcBef>
+                <a:spcPts val="800"/>
+              </a:spcBef>
+              <a:spcAft>
+                <a:spcPts val="800"/>
+              </a:spcAft>
+              <a:defRPr sz="2200">
+                <a:solidFill>
+                  <a:srgbClr val="FFFFFF"/>
+                </a:solidFill>
+              </a:defRPr>
+            </a:pPr>
+            <a:r>
+              <a:t>  ✅ Post-tool hooks for audit logging</a:t>
+            </a:r>
+          </a:p>
+          <a:p>
+            <a:pPr>
+              <a:spcBef>
+                <a:spcPts val="800"/>
+              </a:spcBef>
+              <a:spcAft>
+                <a:spcPts val="800"/>
+              </a:spcAft>
+              <a:defRPr sz="2200">
+                <a:solidFill>
+                  <a:srgbClr val="FFFFFF"/>
+                </a:solidFill>
+              </a:defRPr>
+            </a:pPr>
+            <a:r>
+              <a:t>  ✅ .claudeignore optimized for project</a:t>
+            </a:r>
+          </a:p>
+          <a:p>
+            <a:pPr>
+              <a:spcBef>
+                <a:spcPts val="800"/>
+              </a:spcBef>
+              <a:spcAft>
+                <a:spcPts val="800"/>
+              </a:spcAft>
+              <a:defRPr sz="2200">
+                <a:solidFill>
+                  <a:srgbClr val="FFFFFF"/>
+                </a:solidFill>
+              </a:defRPr>
+            </a:pPr>
+            <a:r>
+              <a:t>  ✅ MCP servers approved and configured</a:t>
+            </a:r>
+          </a:p>
+          <a:p>
+            <a:pPr>
+              <a:spcBef>
+                <a:spcPts val="800"/>
+              </a:spcBef>
+              <a:spcAft>
+                <a:spcPts val="800"/>
+              </a:spcAft>
+              <a:defRPr sz="2200">
+                <a:solidFill>
+                  <a:srgbClr val="FFFFFF"/>
+                </a:solidFill>
+              </a:defRPr>
+            </a:pPr>
+            <a:r>
+              <a:t>  ✅ Team training on custom commands and workflows</a:t>
+            </a:r>
+          </a:p>
+          <a:p>
+            <a:pPr>
+              <a:spcBef>
+                <a:spcPts val="800"/>
+              </a:spcBef>
+              <a:spcAft>
+                <a:spcPts val="800"/>
+              </a:spcAft>
+              <a:defRPr sz="2200">
+                <a:solidFill>
+                  <a:srgbClr val="FFFFFF"/>
+                </a:solidFill>
+              </a:defRPr>
+            </a:pPr>
+            <a:r>
+              <a:t>  ✅ Cost monitoring and budgets in place</a:t>
             </a:r>
           </a:p>
         </p:txBody>

</xml_diff>

<commit_message>
Add spec-writing as core theme across Days 2-3 + ebook
Day 2 (+4 slides, now 113):
- 'The Skill That Separates AI Power Users' (statement)
- 'Spec Quality = Output Quality' (vague vs precise comparison)
- 'The Spec Template: 6 Questions' (problem/users/requirements/boundaries/acceptance/constraints)
- 'Demo: Spec-Driven Development' (health check endpoint, vague vs spec)

Day 3 (+2 slides, now 107):
- 'Spec-Driven AI Development: The 4-Phase Process' (specify/plan/tasks/implement)
- 'Real Spec Structure: Feature Folder Pattern' (with CLAUDE.md integration)

Ebook: Added 'The Meta-Skill: Intent Specification' section in Chapter 5
with 6-question framework and team scaling process.
Source: Nate B Jones, AIA-Template SPEC-TEMPLATE.md + SPEC-DRIVEN-PROCESS.md
</commit_message>
<xml_diff>
--- a/slides/Day3_Claude_Code_Advanced.pptx
+++ b/slides/Day3_Claude_Code_Advanced.pptx
@@ -110,6 +110,8 @@
     <p:sldId id="358" r:id="rId110"/>
     <p:sldId id="359" r:id="rId111"/>
     <p:sldId id="360" r:id="rId112"/>
+    <p:sldId id="361" r:id="rId113"/>
+    <p:sldId id="362" r:id="rId114"/>
   </p:sldIdLst>
   <p:sldSz cx="12191695" cy="6858000" type="screen4x3"/>
   <p:notesSz cx="6858000" cy="9144000"/>
@@ -11714,53 +11716,49 @@
           <a:lstStyle/>
           <a:p>
             <a:r>
-              <a:t>TIME: 3 min</a:t>
+              <a:t>TIME: 4 min</a:t>
             </a:r>
           </a:p>
           <a:p/>
           <a:p>
             <a:r>
+              <a:t>OPEN WITH:</a:t>
+            </a:r>
+          </a:p>
+          <a:p>
+            <a:r>
+              <a:t>   Yesterday we talked about spec quality being the differentiator. Today I want to show you what a full spec-driven process looks like when you're running Claude Code in production.</a:t>
+            </a:r>
+          </a:p>
+          <a:p/>
+          <a:p>
+            <a:r>
               <a:t>KEY POINTS:</a:t>
             </a:r>
           </a:p>
           <a:p>
             <a:r>
-              <a:t>   * CLAUDE.md: Team source of truth for Claude behavior</a:t>
-            </a:r>
-          </a:p>
-          <a:p>
-            <a:r>
-              <a:t>   * Commands: Shared via git, documented in README</a:t>
-            </a:r>
-          </a:p>
-          <a:p>
-            <a:r>
-              <a:t>   * Hooks: Safety and compliance from day 1</a:t>
-            </a:r>
-          </a:p>
-          <a:p>
-            <a:r>
-              <a:t>   * Audit logs: Required for enterprise compliance</a:t>
-            </a:r>
-          </a:p>
-          <a:p>
-            <a:r>
-              <a:t>   * .claudeignore: Performance and cost optimization</a:t>
-            </a:r>
-          </a:p>
-          <a:p>
-            <a:r>
-              <a:t>   * MCP: Security review before deployment</a:t>
-            </a:r>
-          </a:p>
-          <a:p>
-            <a:r>
-              <a:t>   * Training: Team knows how to use custom workflows</a:t>
-            </a:r>
-          </a:p>
-          <a:p>
-            <a:r>
-              <a:t>   * Budget: Monitor and optimize based on usage</a:t>
+              <a:t>   * This is a 4-phase process we use in real client work. Phase 1 is pure intent — WHAT you want and WHY, with no technical decisions. User scenarios written as stories, acceptance criteria in Given/When/Then format. This is the phase most teams skip, and it's why most AI-assisted development produces mediocre results.</a:t>
+            </a:r>
+          </a:p>
+          <a:p>
+            <a:r>
+              <a:t>   * Phase 2 translates intent into architecture. NOW you make technical decisions — stack, API contracts, data models. But these decisions are constrained by the spec. You're not guessing what to build; you're deciding how to build what's already defined.</a:t>
+            </a:r>
+          </a:p>
+          <a:p>
+            <a:r>
+              <a:t>   * Phase 3 is where it gets powerful for AI. You break the plan into small, independently testable tasks. And critically — you write test cases BEFORE any code. This means Claude Code has acceptance criteria to build against AND tests to validate its output. Shift-left testing isn't just for humans.</a:t>
+            </a:r>
+          </a:p>
+          <a:p>
+            <a:r>
+              <a:t>   * Phase 4 is where Claude Code shines. Give it a task with a spec, a plan, and pre-written test cases. It builds to spec, runs the tests, fixes failures. The spec is the source of truth, not Claude's interpretation of a vague prompt.</a:t>
+            </a:r>
+          </a:p>
+          <a:p>
+            <a:r>
+              <a:t>   * The numbers: teams using this process report near-zero rework. Teams without specs? Average 3 rounds of revision per feature. At 2 hours per round, specs save 4 to 6 hours per feature — and they take 30 minutes to write.</a:t>
             </a:r>
           </a:p>
           <a:p/>
@@ -11771,7 +11769,7 @@
           </a:p>
           <a:p>
             <a:r>
-              <a:t>   Final section: Wrap-up and resources</a:t>
+              <a:t>   Let's look at how you structure spec files in a real project.</a:t>
             </a:r>
           </a:p>
         </p:txBody>
@@ -11841,7 +11839,7 @@
           <a:lstStyle/>
           <a:p>
             <a:r>
-              <a:t>TIME: 4 min</a:t>
+              <a:t>TIME: 3 min</a:t>
             </a:r>
           </a:p>
           <a:p/>
@@ -11852,7 +11850,7 @@
           </a:p>
           <a:p>
             <a:r>
-              <a:t>   I want to end with honesty about where Claude Code still struggles. This isn't pessimism — it's professionalism. Knowing the boundaries makes you more effective, not less. Reza Rezvani's quote: 'Vibecoding without metacognition is quite dangerous.' Meaning: if you're just accepting Claude's output without understanding it, you're building on sand.</a:t>
+              <a:t>   Here's the file structure. Every feature gets its own folder under specs with four files that map to the four phases.</a:t>
             </a:r>
           </a:p>
           <a:p/>
@@ -11863,69 +11861,38 @@
           </a:p>
           <a:p>
             <a:r>
-              <a:t>   * Large changes (&gt;15 files): Context degrades, errors compound across files, Claude loses track of dependencies</a:t>
-            </a:r>
-          </a:p>
-          <a:p>
-            <a:r>
-              <a:t>   * Architecture decisions: Claude optimizes locally — it makes each function great but may miss system-level design issues</a:t>
-            </a:r>
-          </a:p>
-          <a:p>
-            <a:r>
-              <a:t>   * Verification boundary: If you can't review and understand the code, you shouldn't ship it. Period.</a:t>
-            </a:r>
-          </a:p>
-          <a:p>
-            <a:r>
-              <a:t>   * Novel work: Claude recombines known patterns brilliantly but doesn't truly invent new algorithms</a:t>
-            </a:r>
-          </a:p>
-          <a:p>
-            <a:r>
-              <a:t>   * The 3 AM test: Could you debug this code at 3 AM without Claude? If not, you need to understand it better before shipping.</a:t>
-            </a:r>
-          </a:p>
-          <a:p>
-            <a:r>
-              <a:t>   * This is why Plan Mode, decomposition, and verification matter — they keep you in control</a:t>
-            </a:r>
-          </a:p>
-          <a:p>
-            <a:r>
-              <a:t>   * Community feedback highlights real gaps: no team collaboration features, pricing confusion, and developer isolation. Each person's Claude Code session is independent — there's no shared workspace or context.</a:t>
-            </a:r>
-          </a:p>
-          <a:p>
-            <a:r>
-              <a:t>   * The practical fix today: shared CLAUDE.md committed to git, team conventions documented as custom commands, and skills versioned alongside your codebase. This creates de facto team collaboration until native features arrive.</a:t>
+              <a:t>   * The spec file is pure intent — problem statement, user scenarios, acceptance criteria, what's out of scope. No code, no architecture. Just what and why.</a:t>
+            </a:r>
+          </a:p>
+          <a:p>
+            <a:r>
+              <a:t>   * The plan file is the technical translation — architecture decisions, API contracts, data models, constraints. This is where you make stack choices.</a:t>
+            </a:r>
+          </a:p>
+          <a:p>
+            <a:r>
+              <a:t>   * Tasks break the plan into small, independently testable chunks. Each task references specific acceptance criteria from the spec. And tests are written against those criteria BEFORE code starts.</a:t>
+            </a:r>
+          </a:p>
+          <a:p>
+            <a:r>
+              <a:t>   * The CLAUDE.md integration is critical. You add a rule: for any feature work, always read the spec first, build to the acceptance criteria, and run the tests after every change. This means every Claude Code session starts grounded in intent, not guessing.</a:t>
+            </a:r>
+          </a:p>
+          <a:p>
+            <a:r>
+              <a:t>   * This pattern scales. One feature? One folder. Twenty features? Twenty folders. New team member joins? They read the spec and understand what was built and why. The spec is documentation that actually stays current because it's the source of truth.</a:t>
             </a:r>
           </a:p>
           <a:p/>
           <a:p>
             <a:r>
-              <a:t>ASK THE CLASS:</a:t>
-            </a:r>
-          </a:p>
-          <a:p>
-            <a:r>
-              <a:t>   "What's the most complex task you've delegated to AI without fully understanding the output? What happened?"</a:t>
-            </a:r>
-          </a:p>
-          <a:p>
-            <a:r>
-              <a:t>   [PAUSE for 30-60 seconds]</a:t>
-            </a:r>
-          </a:p>
-          <a:p/>
-          <a:p>
-            <a:r>
               <a:t>TRANSITION:</a:t>
             </a:r>
           </a:p>
           <a:p>
             <a:r>
-              <a:t>   With those boundaries clear, let's recap what you've learned and preview tomorrow.</a:t>
+              <a:t>   Now let's put this into practice with the production deployment checklist.</a:t>
             </a:r>
           </a:p>
         </p:txBody>
@@ -11995,7 +11962,7 @@
           <a:lstStyle/>
           <a:p>
             <a:r>
-              <a:t>TIME: 4 min</a:t>
+              <a:t>TIME: 3 min</a:t>
             </a:r>
           </a:p>
           <a:p/>
@@ -12006,37 +11973,42 @@
           </a:p>
           <a:p>
             <a:r>
-              <a:t>   * You now have advanced patterns for production Claude Code use</a:t>
-            </a:r>
-          </a:p>
-          <a:p>
-            <a:r>
-              <a:t>   * Custom commands save hours daily on repetitive tasks</a:t>
-            </a:r>
-          </a:p>
-          <a:p>
-            <a:r>
-              <a:t>   * Hooks provide safety and compliance</a:t>
-            </a:r>
-          </a:p>
-          <a:p>
-            <a:r>
-              <a:t>   * MCP unlocks integration with any tool or database</a:t>
-            </a:r>
-          </a:p>
-          <a:p>
-            <a:r>
-              <a:t>   * Agent Teams enable work that would take days to complete in hours</a:t>
-            </a:r>
-          </a:p>
-          <a:p>
-            <a:r>
-              <a:t>   * These patterns scale from 1 developer to enterprise teams</a:t>
-            </a:r>
-          </a:p>
-          <a:p>
-            <a:r>
-              <a:t>   * Remember: Claude Code's current limitation is team isolation — but shared CLAUDE.md via git, versioned custom commands, and team conventions bridge that gap until native collaboration features arrive.</a:t>
+              <a:t>   * CLAUDE.md: Team source of truth for Claude behavior</a:t>
+            </a:r>
+          </a:p>
+          <a:p>
+            <a:r>
+              <a:t>   * Commands: Shared via git, documented in README</a:t>
+            </a:r>
+          </a:p>
+          <a:p>
+            <a:r>
+              <a:t>   * Hooks: Safety and compliance from day 1</a:t>
+            </a:r>
+          </a:p>
+          <a:p>
+            <a:r>
+              <a:t>   * Audit logs: Required for enterprise compliance</a:t>
+            </a:r>
+          </a:p>
+          <a:p>
+            <a:r>
+              <a:t>   * .claudeignore: Performance and cost optimization</a:t>
+            </a:r>
+          </a:p>
+          <a:p>
+            <a:r>
+              <a:t>   * MCP: Security review before deployment</a:t>
+            </a:r>
+          </a:p>
+          <a:p>
+            <a:r>
+              <a:t>   * Training: Team knows how to use custom workflows</a:t>
+            </a:r>
+          </a:p>
+          <a:p>
+            <a:r>
+              <a:t>   * Budget: Monitor and optimize based on usage</a:t>
             </a:r>
           </a:p>
           <a:p/>
@@ -12047,7 +12019,7 @@
           </a:p>
           <a:p>
             <a:r>
-              <a:t>   Getting started roadmap</a:t>
+              <a:t>   Final section: Wrap-up and resources</a:t>
             </a:r>
           </a:p>
         </p:txBody>
@@ -12246,48 +12218,74 @@
           <a:p/>
           <a:p>
             <a:r>
+              <a:t>OPEN WITH:</a:t>
+            </a:r>
+          </a:p>
+          <a:p>
+            <a:r>
+              <a:t>   I want to end with honesty about where Claude Code still struggles. This isn't pessimism — it's professionalism. Knowing the boundaries makes you more effective, not less. Reza Rezvani's quote: 'Vibecoding without metacognition is quite dangerous.' Meaning: if you're just accepting Claude's output without understanding it, you're building on sand.</a:t>
+            </a:r>
+          </a:p>
+          <a:p/>
+          <a:p>
+            <a:r>
               <a:t>KEY POINTS:</a:t>
             </a:r>
           </a:p>
           <a:p>
             <a:r>
-              <a:t>   * Don't try everything at once</a:t>
-            </a:r>
-          </a:p>
-          <a:p>
-            <a:r>
-              <a:t>   * Start with custom commands (easiest, high value)</a:t>
-            </a:r>
-          </a:p>
-          <a:p>
-            <a:r>
-              <a:t>   * Add security hooks early (build good habits)</a:t>
-            </a:r>
-          </a:p>
-          <a:p>
-            <a:r>
-              <a:t>   * MCP integration provides immediate workflow improvement</a:t>
-            </a:r>
-          </a:p>
-          <a:p>
-            <a:r>
-              <a:t>   * Advanced patterns (Agent Teams) after basics are solid</a:t>
-            </a:r>
-          </a:p>
-          <a:p>
-            <a:r>
-              <a:t>   * Measure value at each stage, celebrate wins</a:t>
+              <a:t>   * Large changes (&gt;15 files): Context degrades, errors compound across files, Claude loses track of dependencies</a:t>
+            </a:r>
+          </a:p>
+          <a:p>
+            <a:r>
+              <a:t>   * Architecture decisions: Claude optimizes locally — it makes each function great but may miss system-level design issues</a:t>
+            </a:r>
+          </a:p>
+          <a:p>
+            <a:r>
+              <a:t>   * Verification boundary: If you can't review and understand the code, you shouldn't ship it. Period.</a:t>
+            </a:r>
+          </a:p>
+          <a:p>
+            <a:r>
+              <a:t>   * Novel work: Claude recombines known patterns brilliantly but doesn't truly invent new algorithms</a:t>
+            </a:r>
+          </a:p>
+          <a:p>
+            <a:r>
+              <a:t>   * The 3 AM test: Could you debug this code at 3 AM without Claude? If not, you need to understand it better before shipping.</a:t>
+            </a:r>
+          </a:p>
+          <a:p>
+            <a:r>
+              <a:t>   * This is why Plan Mode, decomposition, and verification matter — they keep you in control</a:t>
+            </a:r>
+          </a:p>
+          <a:p>
+            <a:r>
+              <a:t>   * Community feedback highlights real gaps: no team collaboration features, pricing confusion, and developer isolation. Each person's Claude Code session is independent — there's no shared workspace or context.</a:t>
+            </a:r>
+          </a:p>
+          <a:p>
+            <a:r>
+              <a:t>   * The practical fix today: shared CLAUDE.md committed to git, team conventions documented as custom commands, and skills versioned alongside your codebase. This creates de facto team collaboration until native features arrive.</a:t>
             </a:r>
           </a:p>
           <a:p/>
           <a:p>
             <a:r>
-              <a:t>REAL-WORLD EXAMPLE:</a:t>
-            </a:r>
-          </a:p>
-          <a:p>
-            <a:r>
-              <a:t>   Team followed this roadmap. After month 1: saving 5 hours/week with commands and hooks. After month 3: Agent Teams cutting complex feature time in half.</a:t>
+              <a:t>ASK THE CLASS:</a:t>
+            </a:r>
+          </a:p>
+          <a:p>
+            <a:r>
+              <a:t>   "What's the most complex task you've delegated to AI without fully understanding the output? What happened?"</a:t>
+            </a:r>
+          </a:p>
+          <a:p>
+            <a:r>
+              <a:t>   [PAUSE for 30-60 seconds]</a:t>
             </a:r>
           </a:p>
           <a:p/>
@@ -12298,7 +12296,7 @@
           </a:p>
           <a:p>
             <a:r>
-              <a:t>   Resources and community</a:t>
+              <a:t>   With those boundaries clear, let's recap what you've learned and preview tomorrow.</a:t>
             </a:r>
           </a:p>
         </p:txBody>
@@ -12368,7 +12366,7 @@
           <a:lstStyle/>
           <a:p>
             <a:r>
-              <a:t>TIME: 3 min</a:t>
+              <a:t>TIME: 4 min</a:t>
             </a:r>
           </a:p>
           <a:p/>
@@ -12379,32 +12377,37 @@
           </a:p>
           <a:p>
             <a:r>
-              <a:t>   * Official docs are comprehensive and up-to-date</a:t>
-            </a:r>
-          </a:p>
-          <a:p>
-            <a:r>
-              <a:t>   * MCP ecosystem growing rapidly</a:t>
-            </a:r>
-          </a:p>
-          <a:p>
-            <a:r>
-              <a:t>   * Community shares custom commands and patterns</a:t>
-            </a:r>
-          </a:p>
-          <a:p>
-            <a:r>
-              <a:t>   * Discord active for questions and troubleshooting</a:t>
-            </a:r>
-          </a:p>
-          <a:p>
-            <a:r>
-              <a:t>   * Learn from others' Agent Teams examples</a:t>
-            </a:r>
-          </a:p>
-          <a:p>
-            <a:r>
-              <a:t>   * Internal team knowledge sharing multiplies value</a:t>
+              <a:t>   * You now have advanced patterns for production Claude Code use</a:t>
+            </a:r>
+          </a:p>
+          <a:p>
+            <a:r>
+              <a:t>   * Custom commands save hours daily on repetitive tasks</a:t>
+            </a:r>
+          </a:p>
+          <a:p>
+            <a:r>
+              <a:t>   * Hooks provide safety and compliance</a:t>
+            </a:r>
+          </a:p>
+          <a:p>
+            <a:r>
+              <a:t>   * MCP unlocks integration with any tool or database</a:t>
+            </a:r>
+          </a:p>
+          <a:p>
+            <a:r>
+              <a:t>   * Agent Teams enable work that would take days to complete in hours</a:t>
+            </a:r>
+          </a:p>
+          <a:p>
+            <a:r>
+              <a:t>   * These patterns scale from 1 developer to enterprise teams</a:t>
+            </a:r>
+          </a:p>
+          <a:p>
+            <a:r>
+              <a:t>   * Remember: Claude Code's current limitation is team isolation — but shared CLAUDE.md via git, versioned custom commands, and team conventions bridge that gap until native collaboration features arrive.</a:t>
             </a:r>
           </a:p>
           <a:p/>
@@ -12415,7 +12418,7 @@
           </a:p>
           <a:p>
             <a:r>
-              <a:t>   Thank you and Q&amp;A</a:t>
+              <a:t>   Getting started roadmap</a:t>
             </a:r>
           </a:p>
         </p:txBody>
@@ -12441,6 +12444,251 @@
 </file>
 
 <file path=ppt/notesSlides/notesSlide92.xml><?xml version="1.0" encoding="utf-8"?>
+<p:notes xmlns:a="http://schemas.openxmlformats.org/drawingml/2006/main" xmlns:p="http://schemas.openxmlformats.org/presentationml/2006/main" xmlns:r="http://schemas.openxmlformats.org/officeDocument/2006/relationships">
+  <p:cSld>
+    <p:spTree>
+      <p:nvGrpSpPr>
+        <p:cNvPr id="1" name=""/>
+        <p:cNvGrpSpPr/>
+        <p:nvPr/>
+      </p:nvGrpSpPr>
+      <p:grpSpPr>
+        <a:xfrm>
+          <a:off x="0" y="0"/>
+          <a:ext cx="0" cy="0"/>
+          <a:chOff x="0" y="0"/>
+          <a:chExt cx="0" cy="0"/>
+        </a:xfrm>
+      </p:grpSpPr>
+      <p:sp>
+        <p:nvSpPr>
+          <p:cNvPr id="2" name="Slide Image Placeholder 1"/>
+          <p:cNvSpPr>
+            <a:spLocks noGrp="1"/>
+          </p:cNvSpPr>
+          <p:nvPr>
+            <p:ph type="sldImg" idx="2"/>
+          </p:nvPr>
+        </p:nvSpPr>
+        <p:spPr/>
+      </p:sp>
+      <p:sp>
+        <p:nvSpPr>
+          <p:cNvPr id="3" name="Notes Placeholder 2"/>
+          <p:cNvSpPr>
+            <a:spLocks noGrp="1"/>
+          </p:cNvSpPr>
+          <p:nvPr>
+            <p:ph type="body" idx="3" sz="quarter"/>
+          </p:nvPr>
+        </p:nvSpPr>
+        <p:spPr/>
+        <p:txBody>
+          <a:bodyPr/>
+          <a:lstStyle/>
+          <a:p>
+            <a:r>
+              <a:t>TIME: 4 min</a:t>
+            </a:r>
+          </a:p>
+          <a:p/>
+          <a:p>
+            <a:r>
+              <a:t>KEY POINTS:</a:t>
+            </a:r>
+          </a:p>
+          <a:p>
+            <a:r>
+              <a:t>   * Don't try everything at once</a:t>
+            </a:r>
+          </a:p>
+          <a:p>
+            <a:r>
+              <a:t>   * Start with custom commands (easiest, high value)</a:t>
+            </a:r>
+          </a:p>
+          <a:p>
+            <a:r>
+              <a:t>   * Add security hooks early (build good habits)</a:t>
+            </a:r>
+          </a:p>
+          <a:p>
+            <a:r>
+              <a:t>   * MCP integration provides immediate workflow improvement</a:t>
+            </a:r>
+          </a:p>
+          <a:p>
+            <a:r>
+              <a:t>   * Advanced patterns (Agent Teams) after basics are solid</a:t>
+            </a:r>
+          </a:p>
+          <a:p>
+            <a:r>
+              <a:t>   * Measure value at each stage, celebrate wins</a:t>
+            </a:r>
+          </a:p>
+          <a:p/>
+          <a:p>
+            <a:r>
+              <a:t>REAL-WORLD EXAMPLE:</a:t>
+            </a:r>
+          </a:p>
+          <a:p>
+            <a:r>
+              <a:t>   Team followed this roadmap. After month 1: saving 5 hours/week with commands and hooks. After month 3: Agent Teams cutting complex feature time in half.</a:t>
+            </a:r>
+          </a:p>
+          <a:p/>
+          <a:p>
+            <a:r>
+              <a:t>TRANSITION:</a:t>
+            </a:r>
+          </a:p>
+          <a:p>
+            <a:r>
+              <a:t>   Resources and community</a:t>
+            </a:r>
+          </a:p>
+        </p:txBody>
+      </p:sp>
+      <p:sp>
+        <p:nvSpPr>
+          <p:cNvPr id="4" name="Slide Number Placeholder 3"/>
+          <p:cNvSpPr>
+            <a:spLocks noGrp="1"/>
+          </p:cNvSpPr>
+          <p:nvPr>
+            <p:ph type="sldNum" idx="5" sz="quarter"/>
+          </p:nvPr>
+        </p:nvSpPr>
+        <p:spPr/>
+      </p:sp>
+    </p:spTree>
+  </p:cSld>
+  <p:clrMapOvr>
+    <a:masterClrMapping/>
+  </p:clrMapOvr>
+</p:notes>
+</file>
+
+<file path=ppt/notesSlides/notesSlide93.xml><?xml version="1.0" encoding="utf-8"?>
+<p:notes xmlns:a="http://schemas.openxmlformats.org/drawingml/2006/main" xmlns:p="http://schemas.openxmlformats.org/presentationml/2006/main" xmlns:r="http://schemas.openxmlformats.org/officeDocument/2006/relationships">
+  <p:cSld>
+    <p:spTree>
+      <p:nvGrpSpPr>
+        <p:cNvPr id="1" name=""/>
+        <p:cNvGrpSpPr/>
+        <p:nvPr/>
+      </p:nvGrpSpPr>
+      <p:grpSpPr>
+        <a:xfrm>
+          <a:off x="0" y="0"/>
+          <a:ext cx="0" cy="0"/>
+          <a:chOff x="0" y="0"/>
+          <a:chExt cx="0" cy="0"/>
+        </a:xfrm>
+      </p:grpSpPr>
+      <p:sp>
+        <p:nvSpPr>
+          <p:cNvPr id="2" name="Slide Image Placeholder 1"/>
+          <p:cNvSpPr>
+            <a:spLocks noGrp="1"/>
+          </p:cNvSpPr>
+          <p:nvPr>
+            <p:ph type="sldImg" idx="2"/>
+          </p:nvPr>
+        </p:nvSpPr>
+        <p:spPr/>
+      </p:sp>
+      <p:sp>
+        <p:nvSpPr>
+          <p:cNvPr id="3" name="Notes Placeholder 2"/>
+          <p:cNvSpPr>
+            <a:spLocks noGrp="1"/>
+          </p:cNvSpPr>
+          <p:nvPr>
+            <p:ph type="body" idx="3" sz="quarter"/>
+          </p:nvPr>
+        </p:nvSpPr>
+        <p:spPr/>
+        <p:txBody>
+          <a:bodyPr/>
+          <a:lstStyle/>
+          <a:p>
+            <a:r>
+              <a:t>TIME: 3 min</a:t>
+            </a:r>
+          </a:p>
+          <a:p/>
+          <a:p>
+            <a:r>
+              <a:t>KEY POINTS:</a:t>
+            </a:r>
+          </a:p>
+          <a:p>
+            <a:r>
+              <a:t>   * Official docs are comprehensive and up-to-date</a:t>
+            </a:r>
+          </a:p>
+          <a:p>
+            <a:r>
+              <a:t>   * MCP ecosystem growing rapidly</a:t>
+            </a:r>
+          </a:p>
+          <a:p>
+            <a:r>
+              <a:t>   * Community shares custom commands and patterns</a:t>
+            </a:r>
+          </a:p>
+          <a:p>
+            <a:r>
+              <a:t>   * Discord active for questions and troubleshooting</a:t>
+            </a:r>
+          </a:p>
+          <a:p>
+            <a:r>
+              <a:t>   * Learn from others' Agent Teams examples</a:t>
+            </a:r>
+          </a:p>
+          <a:p>
+            <a:r>
+              <a:t>   * Internal team knowledge sharing multiplies value</a:t>
+            </a:r>
+          </a:p>
+          <a:p/>
+          <a:p>
+            <a:r>
+              <a:t>TRANSITION:</a:t>
+            </a:r>
+          </a:p>
+          <a:p>
+            <a:r>
+              <a:t>   Thank you and Q&amp;A</a:t>
+            </a:r>
+          </a:p>
+        </p:txBody>
+      </p:sp>
+      <p:sp>
+        <p:nvSpPr>
+          <p:cNvPr id="4" name="Slide Number Placeholder 3"/>
+          <p:cNvSpPr>
+            <a:spLocks noGrp="1"/>
+          </p:cNvSpPr>
+          <p:nvPr>
+            <p:ph type="sldNum" idx="5" sz="quarter"/>
+          </p:nvPr>
+        </p:nvSpPr>
+        <p:spPr/>
+      </p:sp>
+    </p:spTree>
+  </p:cSld>
+  <p:clrMapOvr>
+    <a:masterClrMapping/>
+  </p:clrMapOvr>
+</p:notes>
+</file>
+
+<file path=ppt/notesSlides/notesSlide94.xml><?xml version="1.0" encoding="utf-8"?>
 <p:notes xmlns:a="http://schemas.openxmlformats.org/drawingml/2006/main" xmlns:p="http://schemas.openxmlformats.org/presentationml/2006/main" xmlns:r="http://schemas.openxmlformats.org/officeDocument/2006/relationships">
   <p:cSld>
     <p:spTree>
@@ -15881,20 +16129,55 @@
       <p:grpSpPr/>
       <p:sp>
         <p:nvSpPr>
-          <p:cNvPr id="2" name="Rectangle 1"/>
+          <p:cNvPr id="2" name="TextBox 1"/>
+          <p:cNvSpPr txBox="1"/>
+          <p:nvPr/>
+        </p:nvSpPr>
+        <p:spPr>
+          <a:xfrm>
+            <a:off x="457200" y="457200"/>
+            <a:ext cx="11277295" cy="731520"/>
+          </a:xfrm>
+          <a:prstGeom prst="rect">
+            <a:avLst/>
+          </a:prstGeom>
+          <a:noFill/>
+        </p:spPr>
+        <p:txBody>
+          <a:bodyPr wrap="none">
+            <a:spAutoFit/>
+          </a:bodyPr>
+          <a:lstStyle/>
+          <a:p>
+            <a:pPr algn="ctr">
+              <a:defRPr sz="3600" b="1">
+                <a:solidFill>
+                  <a:srgbClr val="FFFFFF"/>
+                </a:solidFill>
+              </a:defRPr>
+            </a:pPr>
+            <a:r>
+              <a:t>Real Spec Structure: Feature Folder Pattern</a:t>
+            </a:r>
+          </a:p>
+        </p:txBody>
+      </p:sp>
+      <p:sp>
+        <p:nvSpPr>
+          <p:cNvPr id="3" name="Rounded Rectangle 2"/>
           <p:cNvSpPr/>
           <p:nvPr/>
         </p:nvSpPr>
         <p:spPr>
           <a:xfrm>
-            <a:off x="0" y="1828800"/>
-            <a:ext cx="137160" cy="3200400"/>
-          </a:xfrm>
-          <a:prstGeom prst="rect">
+            <a:off x="914400" y="1645920"/>
+            <a:ext cx="10362895" cy="4114800"/>
+          </a:xfrm>
+          <a:prstGeom prst="roundRect">
             <a:avLst/>
           </a:prstGeom>
           <a:solidFill>
-            <a:srgbClr val="00D4AA"/>
+            <a:srgbClr val="1E1E2E"/>
           </a:solidFill>
           <a:ln>
             <a:noFill/>
@@ -15924,14 +16207,14 @@
       </p:sp>
       <p:sp>
         <p:nvSpPr>
-          <p:cNvPr id="3" name="TextBox 2"/>
+          <p:cNvPr id="4" name="TextBox 3"/>
           <p:cNvSpPr txBox="1"/>
           <p:nvPr/>
         </p:nvSpPr>
         <p:spPr>
           <a:xfrm>
-            <a:off x="457200" y="2286000"/>
-            <a:ext cx="11277295" cy="1371600"/>
+            <a:off x="1097280" y="1783080"/>
+            <a:ext cx="1828800" cy="365760"/>
           </a:xfrm>
           <a:prstGeom prst="rect">
             <a:avLst/>
@@ -15939,34 +16222,34 @@
           <a:noFill/>
         </p:spPr>
         <p:txBody>
-          <a:bodyPr wrap="square">
+          <a:bodyPr wrap="none">
             <a:spAutoFit/>
           </a:bodyPr>
           <a:lstStyle/>
           <a:p>
             <a:pPr>
-              <a:defRPr sz="5600" b="1">
-                <a:solidFill>
-                  <a:srgbClr val="FFFFFF"/>
-                </a:solidFill>
-              </a:defRPr>
-            </a:pPr>
-            <a:r>
-              <a:t>Wrap-up</a:t>
-            </a:r>
-          </a:p>
-        </p:txBody>
-      </p:sp>
-      <p:sp>
-        <p:nvSpPr>
-          <p:cNvPr id="4" name="TextBox 3"/>
+              <a:defRPr sz="1200" b="1">
+                <a:solidFill>
+                  <a:srgbClr val="00D4AA"/>
+                </a:solidFill>
+              </a:defRPr>
+            </a:pPr>
+            <a:r>
+              <a:t>TEXT</a:t>
+            </a:r>
+          </a:p>
+        </p:txBody>
+      </p:sp>
+      <p:sp>
+        <p:nvSpPr>
+          <p:cNvPr id="5" name="TextBox 4"/>
           <p:cNvSpPr txBox="1"/>
           <p:nvPr/>
         </p:nvSpPr>
         <p:spPr>
           <a:xfrm>
-            <a:off x="457200" y="3840480"/>
-            <a:ext cx="11277295" cy="914400"/>
+            <a:off x="1097280" y="2194560"/>
+            <a:ext cx="9997135" cy="3291840"/>
           </a:xfrm>
           <a:prstGeom prst="rect">
             <a:avLst/>
@@ -15974,20 +16257,49 @@
           <a:noFill/>
         </p:spPr>
         <p:txBody>
-          <a:bodyPr wrap="square">
+          <a:bodyPr wrap="none">
             <a:spAutoFit/>
           </a:bodyPr>
           <a:lstStyle/>
           <a:p>
             <a:pPr>
-              <a:defRPr sz="2400">
-                <a:solidFill>
-                  <a:srgbClr val="8B95A5"/>
-                </a:solidFill>
-              </a:defRPr>
-            </a:pPr>
-            <a:r>
-              <a:t>Key takeaways and next steps</a:t>
+              <a:defRPr sz="1800">
+                <a:solidFill>
+                  <a:srgbClr val="FFFFFF"/>
+                </a:solidFill>
+                <a:latin typeface="Consolas"/>
+              </a:defRPr>
+            </a:pPr>
+            <a:r>
+              <a:t>specs/</a:t>
+            </a:r>
+            <a:br/>
+            <a:r>
+              <a:t>├── PRODUCT.md              # Overall product spec</a:t>
+            </a:r>
+            <a:br/>
+            <a:r>
+              <a:t>└── features/</a:t>
+            </a:r>
+            <a:br/>
+            <a:r>
+              <a:t>    └── 042-user-dashboard/</a:t>
+            </a:r>
+            <a:br/>
+            <a:r>
+              <a:t>        ├── spec.md           # Phase 1: What &amp; Why</a:t>
+            </a:r>
+            <a:br/>
+            <a:r>
+              <a:t>        ├── plan.md           # Phase 2: Architecture</a:t>
+            </a:r>
+            <a:br/>
+            <a:r>
+              <a:t>        ├── tasks.md          # Phase 3: Work breakdown</a:t>
+            </a:r>
+            <a:br/>
+            <a:r>
+              <a:t>        └── tests.md          # Phase 3: Test cases</a:t>
             </a:r>
           </a:p>
         </p:txBody>
@@ -16048,7 +16360,7 @@
               </a:defRPr>
             </a:pPr>
             <a:r>
-              <a:t>Where Claude Code Still Struggles</a:t>
+              <a:t>Production Deployment Checklist</a:t>
             </a:r>
           </a:p>
         </p:txBody>
@@ -16132,7 +16444,7 @@
               </a:defRPr>
             </a:pPr>
             <a:r>
-              <a:t>  Large changes (&gt;15 files): Context degrades, errors compound across files, Claude loses track of dependencies.</a:t>
+              <a:t>  ✅ CLAUDE.md configured with team standards</a:t>
             </a:r>
           </a:p>
           <a:p>
@@ -16150,7 +16462,7 @@
               </a:defRPr>
             </a:pPr>
             <a:r>
-              <a:t>  Architecture decisions: Claude optimizes locally — it makes each function great but may miss system-level design issues.</a:t>
+              <a:t>  ✅ Custom commands in .claude/commands/ (versioned in git)</a:t>
             </a:r>
           </a:p>
           <a:p>
@@ -16168,7 +16480,7 @@
               </a:defRPr>
             </a:pPr>
             <a:r>
-              <a:t>  Verification boundary: If you can't review and understand the code, you shouldn't ship it.</a:t>
+              <a:t>  ✅ Pre-tool hooks for security (no secrets, safe commands)</a:t>
             </a:r>
           </a:p>
           <a:p>
@@ -16186,7 +16498,7 @@
               </a:defRPr>
             </a:pPr>
             <a:r>
-              <a:t>  Novel work: Claude recombines known patterns brilliantly but doesn't truly invent new algorithms.</a:t>
+              <a:t>  ✅ Post-tool hooks for audit logging</a:t>
             </a:r>
           </a:p>
           <a:p>
@@ -16204,7 +16516,7 @@
               </a:defRPr>
             </a:pPr>
             <a:r>
-              <a:t>  The 3 AM test: Could you debug this code at 3 AM without Claude? If not, you need to understand it better before ship...</a:t>
+              <a:t>  ✅ .claudeignore optimized for project</a:t>
             </a:r>
           </a:p>
           <a:p>
@@ -16222,7 +16534,43 @@
               </a:defRPr>
             </a:pPr>
             <a:r>
-              <a:t>  This is why Plan Mode, decomposition, and verification matter — they keep you in control.</a:t>
+              <a:t>  ✅ MCP servers approved and configured</a:t>
+            </a:r>
+          </a:p>
+          <a:p>
+            <a:pPr>
+              <a:spcBef>
+                <a:spcPts val="800"/>
+              </a:spcBef>
+              <a:spcAft>
+                <a:spcPts val="800"/>
+              </a:spcAft>
+              <a:defRPr sz="2200">
+                <a:solidFill>
+                  <a:srgbClr val="FFFFFF"/>
+                </a:solidFill>
+              </a:defRPr>
+            </a:pPr>
+            <a:r>
+              <a:t>  ✅ Team training on custom commands and workflows</a:t>
+            </a:r>
+          </a:p>
+          <a:p>
+            <a:pPr>
+              <a:spcBef>
+                <a:spcPts val="800"/>
+              </a:spcBef>
+              <a:spcAft>
+                <a:spcPts val="800"/>
+              </a:spcAft>
+              <a:defRPr sz="2200">
+                <a:solidFill>
+                  <a:srgbClr val="FFFFFF"/>
+                </a:solidFill>
+              </a:defRPr>
+            </a:pPr>
+            <a:r>
+              <a:t>  ✅ Cost monitoring and budgets in place</a:t>
             </a:r>
           </a:p>
         </p:txBody>
@@ -16261,8 +16609,8 @@
         </p:nvSpPr>
         <p:spPr>
           <a:xfrm>
-            <a:off x="0" y="1188720"/>
-            <a:ext cx="91440" cy="5029200"/>
+            <a:off x="0" y="1828800"/>
+            <a:ext cx="137160" cy="3200400"/>
           </a:xfrm>
           <a:prstGeom prst="rect">
             <a:avLst/>
@@ -16304,121 +16652,8 @@
         </p:nvSpPr>
         <p:spPr>
           <a:xfrm>
-            <a:off x="457200" y="365760"/>
-            <a:ext cx="11277295" cy="822960"/>
-          </a:xfrm>
-          <a:prstGeom prst="rect">
-            <a:avLst/>
-          </a:prstGeom>
-          <a:noFill/>
-        </p:spPr>
-        <p:txBody>
-          <a:bodyPr wrap="none">
-            <a:spAutoFit/>
-          </a:bodyPr>
-          <a:lstStyle/>
-          <a:p>
-            <a:pPr>
-              <a:defRPr sz="4000" b="1">
-                <a:solidFill>
-                  <a:srgbClr val="FFFFFF"/>
-                </a:solidFill>
-              </a:defRPr>
-            </a:pPr>
-            <a:r>
-              <a:t>Day 3 Key Takeaways</a:t>
-            </a:r>
-          </a:p>
-        </p:txBody>
-      </p:sp>
-      <p:sp>
-        <p:nvSpPr>
-          <p:cNvPr id="4" name="Oval 3"/>
-          <p:cNvSpPr/>
-          <p:nvPr/>
-        </p:nvSpPr>
-        <p:spPr>
-          <a:xfrm>
-            <a:off x="457200" y="1371600"/>
-            <a:ext cx="411480" cy="411480"/>
-          </a:xfrm>
-          <a:prstGeom prst="ellipse">
-            <a:avLst/>
-          </a:prstGeom>
-          <a:solidFill>
-            <a:srgbClr val="00D4AA"/>
-          </a:solidFill>
-          <a:ln>
-            <a:noFill/>
-          </a:ln>
-        </p:spPr>
-        <p:style>
-          <a:lnRef idx="1">
-            <a:schemeClr val="accent1"/>
-          </a:lnRef>
-          <a:fillRef idx="3">
-            <a:schemeClr val="accent1"/>
-          </a:fillRef>
-          <a:effectRef idx="2">
-            <a:schemeClr val="accent1"/>
-          </a:effectRef>
-          <a:fontRef idx="minor">
-            <a:schemeClr val="lt1"/>
-          </a:fontRef>
-        </p:style>
-        <p:txBody>
-          <a:bodyPr rtlCol="0" anchor="ctr"/>
-          <a:lstStyle/>
-          <a:p>
-            <a:pPr algn="ctr"/>
-          </a:p>
-        </p:txBody>
-      </p:sp>
-      <p:sp>
-        <p:nvSpPr>
-          <p:cNvPr id="5" name="TextBox 4"/>
-          <p:cNvSpPr txBox="1"/>
-          <p:nvPr/>
-        </p:nvSpPr>
-        <p:spPr>
-          <a:xfrm>
-            <a:off x="457200" y="1371600"/>
-            <a:ext cx="411480" cy="411480"/>
-          </a:xfrm>
-          <a:prstGeom prst="rect">
-            <a:avLst/>
-          </a:prstGeom>
-          <a:noFill/>
-        </p:spPr>
-        <p:txBody>
-          <a:bodyPr wrap="none" anchor="ctr">
-            <a:spAutoFit/>
-          </a:bodyPr>
-          <a:lstStyle/>
-          <a:p>
-            <a:pPr algn="ctr">
-              <a:defRPr sz="2000" b="1">
-                <a:solidFill>
-                  <a:srgbClr val="0B0F1A"/>
-                </a:solidFill>
-              </a:defRPr>
-            </a:pPr>
-            <a:r>
-              <a:t>v</a:t>
-            </a:r>
-          </a:p>
-        </p:txBody>
-      </p:sp>
-      <p:sp>
-        <p:nvSpPr>
-          <p:cNvPr id="6" name="TextBox 5"/>
-          <p:cNvSpPr txBox="1"/>
-          <p:nvPr/>
-        </p:nvSpPr>
-        <p:spPr>
-          <a:xfrm>
-            <a:off x="1005840" y="1417320"/>
-            <a:ext cx="10728655" cy="731520"/>
+            <a:off x="457200" y="2286000"/>
+            <a:ext cx="11277295" cy="1371600"/>
           </a:xfrm>
           <a:prstGeom prst="rect">
             <a:avLst/>
@@ -16432,106 +16667,28 @@
           <a:lstStyle/>
           <a:p>
             <a:pPr>
-              <a:defRPr sz="2200">
+              <a:defRPr sz="5600" b="1">
                 <a:solidFill>
                   <a:srgbClr val="FFFFFF"/>
                 </a:solidFill>
               </a:defRPr>
             </a:pPr>
             <a:r>
-              <a:t>Custom commands: Reusable workflows in .claude/commands/</a:t>
-            </a:r>
-          </a:p>
-        </p:txBody>
-      </p:sp>
-      <p:sp>
-        <p:nvSpPr>
-          <p:cNvPr id="7" name="Oval 6"/>
-          <p:cNvSpPr/>
-          <p:nvPr/>
-        </p:nvSpPr>
-        <p:spPr>
-          <a:xfrm>
-            <a:off x="457200" y="2194560"/>
-            <a:ext cx="411480" cy="411480"/>
-          </a:xfrm>
-          <a:prstGeom prst="ellipse">
-            <a:avLst/>
-          </a:prstGeom>
-          <a:solidFill>
-            <a:srgbClr val="00D4AA"/>
-          </a:solidFill>
-          <a:ln>
-            <a:noFill/>
-          </a:ln>
-        </p:spPr>
-        <p:style>
-          <a:lnRef idx="1">
-            <a:schemeClr val="accent1"/>
-          </a:lnRef>
-          <a:fillRef idx="3">
-            <a:schemeClr val="accent1"/>
-          </a:fillRef>
-          <a:effectRef idx="2">
-            <a:schemeClr val="accent1"/>
-          </a:effectRef>
-          <a:fontRef idx="minor">
-            <a:schemeClr val="lt1"/>
-          </a:fontRef>
-        </p:style>
-        <p:txBody>
-          <a:bodyPr rtlCol="0" anchor="ctr"/>
-          <a:lstStyle/>
-          <a:p>
-            <a:pPr algn="ctr"/>
-          </a:p>
-        </p:txBody>
-      </p:sp>
-      <p:sp>
-        <p:nvSpPr>
-          <p:cNvPr id="8" name="TextBox 7"/>
+              <a:t>Wrap-up</a:t>
+            </a:r>
+          </a:p>
+        </p:txBody>
+      </p:sp>
+      <p:sp>
+        <p:nvSpPr>
+          <p:cNvPr id="4" name="TextBox 3"/>
           <p:cNvSpPr txBox="1"/>
           <p:nvPr/>
         </p:nvSpPr>
         <p:spPr>
           <a:xfrm>
-            <a:off x="457200" y="2194560"/>
-            <a:ext cx="411480" cy="411480"/>
-          </a:xfrm>
-          <a:prstGeom prst="rect">
-            <a:avLst/>
-          </a:prstGeom>
-          <a:noFill/>
-        </p:spPr>
-        <p:txBody>
-          <a:bodyPr wrap="none" anchor="ctr">
-            <a:spAutoFit/>
-          </a:bodyPr>
-          <a:lstStyle/>
-          <a:p>
-            <a:pPr algn="ctr">
-              <a:defRPr sz="2000" b="1">
-                <a:solidFill>
-                  <a:srgbClr val="0B0F1A"/>
-                </a:solidFill>
-              </a:defRPr>
-            </a:pPr>
-            <a:r>
-              <a:t>v</a:t>
-            </a:r>
-          </a:p>
-        </p:txBody>
-      </p:sp>
-      <p:sp>
-        <p:nvSpPr>
-          <p:cNvPr id="9" name="TextBox 8"/>
-          <p:cNvSpPr txBox="1"/>
-          <p:nvPr/>
-        </p:nvSpPr>
-        <p:spPr>
-          <a:xfrm>
-            <a:off x="1005840" y="2240280"/>
-            <a:ext cx="10728655" cy="731520"/>
+            <a:off x="457200" y="3840480"/>
+            <a:ext cx="11277295" cy="914400"/>
           </a:xfrm>
           <a:prstGeom prst="rect">
             <a:avLst/>
@@ -16545,466 +16702,14 @@
           <a:lstStyle/>
           <a:p>
             <a:pPr>
-              <a:defRPr sz="2200">
-                <a:solidFill>
-                  <a:srgbClr val="FFFFFF"/>
-                </a:solidFill>
-              </a:defRPr>
-            </a:pPr>
-            <a:r>
-              <a:t>Subagents: Specialized AI workers for focused tasks</a:t>
-            </a:r>
-          </a:p>
-        </p:txBody>
-      </p:sp>
-      <p:sp>
-        <p:nvSpPr>
-          <p:cNvPr id="10" name="Oval 9"/>
-          <p:cNvSpPr/>
-          <p:nvPr/>
-        </p:nvSpPr>
-        <p:spPr>
-          <a:xfrm>
-            <a:off x="457200" y="3017520"/>
-            <a:ext cx="411480" cy="411480"/>
-          </a:xfrm>
-          <a:prstGeom prst="ellipse">
-            <a:avLst/>
-          </a:prstGeom>
-          <a:solidFill>
-            <a:srgbClr val="00D4AA"/>
-          </a:solidFill>
-          <a:ln>
-            <a:noFill/>
-          </a:ln>
-        </p:spPr>
-        <p:style>
-          <a:lnRef idx="1">
-            <a:schemeClr val="accent1"/>
-          </a:lnRef>
-          <a:fillRef idx="3">
-            <a:schemeClr val="accent1"/>
-          </a:fillRef>
-          <a:effectRef idx="2">
-            <a:schemeClr val="accent1"/>
-          </a:effectRef>
-          <a:fontRef idx="minor">
-            <a:schemeClr val="lt1"/>
-          </a:fontRef>
-        </p:style>
-        <p:txBody>
-          <a:bodyPr rtlCol="0" anchor="ctr"/>
-          <a:lstStyle/>
-          <a:p>
-            <a:pPr algn="ctr"/>
-          </a:p>
-        </p:txBody>
-      </p:sp>
-      <p:sp>
-        <p:nvSpPr>
-          <p:cNvPr id="11" name="TextBox 10"/>
-          <p:cNvSpPr txBox="1"/>
-          <p:nvPr/>
-        </p:nvSpPr>
-        <p:spPr>
-          <a:xfrm>
-            <a:off x="457200" y="3017520"/>
-            <a:ext cx="411480" cy="411480"/>
-          </a:xfrm>
-          <a:prstGeom prst="rect">
-            <a:avLst/>
-          </a:prstGeom>
-          <a:noFill/>
-        </p:spPr>
-        <p:txBody>
-          <a:bodyPr wrap="none" anchor="ctr">
-            <a:spAutoFit/>
-          </a:bodyPr>
-          <a:lstStyle/>
-          <a:p>
-            <a:pPr algn="ctr">
-              <a:defRPr sz="2000" b="1">
-                <a:solidFill>
-                  <a:srgbClr val="0B0F1A"/>
-                </a:solidFill>
-              </a:defRPr>
-            </a:pPr>
-            <a:r>
-              <a:t>v</a:t>
-            </a:r>
-          </a:p>
-        </p:txBody>
-      </p:sp>
-      <p:sp>
-        <p:nvSpPr>
-          <p:cNvPr id="12" name="TextBox 11"/>
-          <p:cNvSpPr txBox="1"/>
-          <p:nvPr/>
-        </p:nvSpPr>
-        <p:spPr>
-          <a:xfrm>
-            <a:off x="1005840" y="3063240"/>
-            <a:ext cx="10728655" cy="731520"/>
-          </a:xfrm>
-          <a:prstGeom prst="rect">
-            <a:avLst/>
-          </a:prstGeom>
-          <a:noFill/>
-        </p:spPr>
-        <p:txBody>
-          <a:bodyPr wrap="square">
-            <a:spAutoFit/>
-          </a:bodyPr>
-          <a:lstStyle/>
-          <a:p>
-            <a:pPr>
-              <a:defRPr sz="2200">
-                <a:solidFill>
-                  <a:srgbClr val="FFFFFF"/>
-                </a:solidFill>
-              </a:defRPr>
-            </a:pPr>
-            <a:r>
-              <a:t>Hooks: Safety guardrails and audit logging</a:t>
-            </a:r>
-          </a:p>
-        </p:txBody>
-      </p:sp>
-      <p:sp>
-        <p:nvSpPr>
-          <p:cNvPr id="13" name="Oval 12"/>
-          <p:cNvSpPr/>
-          <p:nvPr/>
-        </p:nvSpPr>
-        <p:spPr>
-          <a:xfrm>
-            <a:off x="457200" y="3840480"/>
-            <a:ext cx="411480" cy="411480"/>
-          </a:xfrm>
-          <a:prstGeom prst="ellipse">
-            <a:avLst/>
-          </a:prstGeom>
-          <a:solidFill>
-            <a:srgbClr val="00D4AA"/>
-          </a:solidFill>
-          <a:ln>
-            <a:noFill/>
-          </a:ln>
-        </p:spPr>
-        <p:style>
-          <a:lnRef idx="1">
-            <a:schemeClr val="accent1"/>
-          </a:lnRef>
-          <a:fillRef idx="3">
-            <a:schemeClr val="accent1"/>
-          </a:fillRef>
-          <a:effectRef idx="2">
-            <a:schemeClr val="accent1"/>
-          </a:effectRef>
-          <a:fontRef idx="minor">
-            <a:schemeClr val="lt1"/>
-          </a:fontRef>
-        </p:style>
-        <p:txBody>
-          <a:bodyPr rtlCol="0" anchor="ctr"/>
-          <a:lstStyle/>
-          <a:p>
-            <a:pPr algn="ctr"/>
-          </a:p>
-        </p:txBody>
-      </p:sp>
-      <p:sp>
-        <p:nvSpPr>
-          <p:cNvPr id="14" name="TextBox 13"/>
-          <p:cNvSpPr txBox="1"/>
-          <p:nvPr/>
-        </p:nvSpPr>
-        <p:spPr>
-          <a:xfrm>
-            <a:off x="457200" y="3840480"/>
-            <a:ext cx="411480" cy="411480"/>
-          </a:xfrm>
-          <a:prstGeom prst="rect">
-            <a:avLst/>
-          </a:prstGeom>
-          <a:noFill/>
-        </p:spPr>
-        <p:txBody>
-          <a:bodyPr wrap="none" anchor="ctr">
-            <a:spAutoFit/>
-          </a:bodyPr>
-          <a:lstStyle/>
-          <a:p>
-            <a:pPr algn="ctr">
-              <a:defRPr sz="2000" b="1">
-                <a:solidFill>
-                  <a:srgbClr val="0B0F1A"/>
-                </a:solidFill>
-              </a:defRPr>
-            </a:pPr>
-            <a:r>
-              <a:t>v</a:t>
-            </a:r>
-          </a:p>
-        </p:txBody>
-      </p:sp>
-      <p:sp>
-        <p:nvSpPr>
-          <p:cNvPr id="15" name="TextBox 14"/>
-          <p:cNvSpPr txBox="1"/>
-          <p:nvPr/>
-        </p:nvSpPr>
-        <p:spPr>
-          <a:xfrm>
-            <a:off x="1005840" y="3886200"/>
-            <a:ext cx="10728655" cy="731520"/>
-          </a:xfrm>
-          <a:prstGeom prst="rect">
-            <a:avLst/>
-          </a:prstGeom>
-          <a:noFill/>
-        </p:spPr>
-        <p:txBody>
-          <a:bodyPr wrap="square">
-            <a:spAutoFit/>
-          </a:bodyPr>
-          <a:lstStyle/>
-          <a:p>
-            <a:pPr>
-              <a:defRPr sz="2200">
-                <a:solidFill>
-                  <a:srgbClr val="FFFFFF"/>
-                </a:solidFill>
-              </a:defRPr>
-            </a:pPr>
-            <a:r>
-              <a:t>Plan mode + thinking levels: Control quality/speed/cost tradeoffs</a:t>
-            </a:r>
-          </a:p>
-        </p:txBody>
-      </p:sp>
-      <p:sp>
-        <p:nvSpPr>
-          <p:cNvPr id="16" name="Oval 15"/>
-          <p:cNvSpPr/>
-          <p:nvPr/>
-        </p:nvSpPr>
-        <p:spPr>
-          <a:xfrm>
-            <a:off x="457200" y="4663440"/>
-            <a:ext cx="411480" cy="411480"/>
-          </a:xfrm>
-          <a:prstGeom prst="ellipse">
-            <a:avLst/>
-          </a:prstGeom>
-          <a:solidFill>
-            <a:srgbClr val="00D4AA"/>
-          </a:solidFill>
-          <a:ln>
-            <a:noFill/>
-          </a:ln>
-        </p:spPr>
-        <p:style>
-          <a:lnRef idx="1">
-            <a:schemeClr val="accent1"/>
-          </a:lnRef>
-          <a:fillRef idx="3">
-            <a:schemeClr val="accent1"/>
-          </a:fillRef>
-          <a:effectRef idx="2">
-            <a:schemeClr val="accent1"/>
-          </a:effectRef>
-          <a:fontRef idx="minor">
-            <a:schemeClr val="lt1"/>
-          </a:fontRef>
-        </p:style>
-        <p:txBody>
-          <a:bodyPr rtlCol="0" anchor="ctr"/>
-          <a:lstStyle/>
-          <a:p>
-            <a:pPr algn="ctr"/>
-          </a:p>
-        </p:txBody>
-      </p:sp>
-      <p:sp>
-        <p:nvSpPr>
-          <p:cNvPr id="17" name="TextBox 16"/>
-          <p:cNvSpPr txBox="1"/>
-          <p:nvPr/>
-        </p:nvSpPr>
-        <p:spPr>
-          <a:xfrm>
-            <a:off x="457200" y="4663440"/>
-            <a:ext cx="411480" cy="411480"/>
-          </a:xfrm>
-          <a:prstGeom prst="rect">
-            <a:avLst/>
-          </a:prstGeom>
-          <a:noFill/>
-        </p:spPr>
-        <p:txBody>
-          <a:bodyPr wrap="none" anchor="ctr">
-            <a:spAutoFit/>
-          </a:bodyPr>
-          <a:lstStyle/>
-          <a:p>
-            <a:pPr algn="ctr">
-              <a:defRPr sz="2000" b="1">
-                <a:solidFill>
-                  <a:srgbClr val="0B0F1A"/>
-                </a:solidFill>
-              </a:defRPr>
-            </a:pPr>
-            <a:r>
-              <a:t>v</a:t>
-            </a:r>
-          </a:p>
-        </p:txBody>
-      </p:sp>
-      <p:sp>
-        <p:nvSpPr>
-          <p:cNvPr id="18" name="TextBox 17"/>
-          <p:cNvSpPr txBox="1"/>
-          <p:nvPr/>
-        </p:nvSpPr>
-        <p:spPr>
-          <a:xfrm>
-            <a:off x="1005840" y="4709160"/>
-            <a:ext cx="10728655" cy="731520"/>
-          </a:xfrm>
-          <a:prstGeom prst="rect">
-            <a:avLst/>
-          </a:prstGeom>
-          <a:noFill/>
-        </p:spPr>
-        <p:txBody>
-          <a:bodyPr wrap="square">
-            <a:spAutoFit/>
-          </a:bodyPr>
-          <a:lstStyle/>
-          <a:p>
-            <a:pPr>
-              <a:defRPr sz="2200">
-                <a:solidFill>
-                  <a:srgbClr val="FFFFFF"/>
-                </a:solidFill>
-              </a:defRPr>
-            </a:pPr>
-            <a:r>
-              <a:t>MCP: Connect Claude to any external system</a:t>
-            </a:r>
-          </a:p>
-        </p:txBody>
-      </p:sp>
-      <p:sp>
-        <p:nvSpPr>
-          <p:cNvPr id="19" name="Oval 18"/>
-          <p:cNvSpPr/>
-          <p:nvPr/>
-        </p:nvSpPr>
-        <p:spPr>
-          <a:xfrm>
-            <a:off x="457200" y="5486400"/>
-            <a:ext cx="411480" cy="411480"/>
-          </a:xfrm>
-          <a:prstGeom prst="ellipse">
-            <a:avLst/>
-          </a:prstGeom>
-          <a:solidFill>
-            <a:srgbClr val="00D4AA"/>
-          </a:solidFill>
-          <a:ln>
-            <a:noFill/>
-          </a:ln>
-        </p:spPr>
-        <p:style>
-          <a:lnRef idx="1">
-            <a:schemeClr val="accent1"/>
-          </a:lnRef>
-          <a:fillRef idx="3">
-            <a:schemeClr val="accent1"/>
-          </a:fillRef>
-          <a:effectRef idx="2">
-            <a:schemeClr val="accent1"/>
-          </a:effectRef>
-          <a:fontRef idx="minor">
-            <a:schemeClr val="lt1"/>
-          </a:fontRef>
-        </p:style>
-        <p:txBody>
-          <a:bodyPr rtlCol="0" anchor="ctr"/>
-          <a:lstStyle/>
-          <a:p>
-            <a:pPr algn="ctr"/>
-          </a:p>
-        </p:txBody>
-      </p:sp>
-      <p:sp>
-        <p:nvSpPr>
-          <p:cNvPr id="20" name="TextBox 19"/>
-          <p:cNvSpPr txBox="1"/>
-          <p:nvPr/>
-        </p:nvSpPr>
-        <p:spPr>
-          <a:xfrm>
-            <a:off x="457200" y="5486400"/>
-            <a:ext cx="411480" cy="411480"/>
-          </a:xfrm>
-          <a:prstGeom prst="rect">
-            <a:avLst/>
-          </a:prstGeom>
-          <a:noFill/>
-        </p:spPr>
-        <p:txBody>
-          <a:bodyPr wrap="none" anchor="ctr">
-            <a:spAutoFit/>
-          </a:bodyPr>
-          <a:lstStyle/>
-          <a:p>
-            <a:pPr algn="ctr">
-              <a:defRPr sz="2000" b="1">
-                <a:solidFill>
-                  <a:srgbClr val="0B0F1A"/>
-                </a:solidFill>
-              </a:defRPr>
-            </a:pPr>
-            <a:r>
-              <a:t>v</a:t>
-            </a:r>
-          </a:p>
-        </p:txBody>
-      </p:sp>
-      <p:sp>
-        <p:nvSpPr>
-          <p:cNvPr id="21" name="TextBox 20"/>
-          <p:cNvSpPr txBox="1"/>
-          <p:nvPr/>
-        </p:nvSpPr>
-        <p:spPr>
-          <a:xfrm>
-            <a:off x="1005840" y="5532120"/>
-            <a:ext cx="10728655" cy="731520"/>
-          </a:xfrm>
-          <a:prstGeom prst="rect">
-            <a:avLst/>
-          </a:prstGeom>
-          <a:noFill/>
-        </p:spPr>
-        <p:txBody>
-          <a:bodyPr wrap="square">
-            <a:spAutoFit/>
-          </a:bodyPr>
-          <a:lstStyle/>
-          <a:p>
-            <a:pPr>
-              <a:defRPr sz="2200">
-                <a:solidFill>
-                  <a:srgbClr val="FFFFFF"/>
-                </a:solidFill>
-              </a:defRPr>
-            </a:pPr>
-            <a:r>
-              <a:t>Agent Teams: Parallel coordination for complex work</a:t>
+              <a:defRPr sz="2400">
+                <a:solidFill>
+                  <a:srgbClr val="8B95A5"/>
+                </a:solidFill>
+              </a:defRPr>
+            </a:pPr>
+            <a:r>
+              <a:t>Key takeaways and next steps</a:t>
             </a:r>
           </a:p>
         </p:txBody>
@@ -17065,7 +16770,7 @@
               </a:defRPr>
             </a:pPr>
             <a:r>
-              <a:t>Getting Started Roadmap</a:t>
+              <a:t>Where Claude Code Still Struggles</a:t>
             </a:r>
           </a:p>
         </p:txBody>
@@ -17149,7 +16854,7 @@
               </a:defRPr>
             </a:pPr>
             <a:r>
-              <a:t>  Week 1: Create 2-3 custom commands for your daily workflows</a:t>
+              <a:t>  Large changes (&gt;15 files): Context degrades, errors compound across files, Claude loses track of dependencies.</a:t>
             </a:r>
           </a:p>
           <a:p>
@@ -17167,7 +16872,7 @@
               </a:defRPr>
             </a:pPr>
             <a:r>
-              <a:t>  Week 2: Implement pre-tool hook for security (no secrets)</a:t>
+              <a:t>  Architecture decisions: Claude optimizes locally — it makes each function great but may miss system-level design issues.</a:t>
             </a:r>
           </a:p>
           <a:p>
@@ -17185,7 +16890,7 @@
               </a:defRPr>
             </a:pPr>
             <a:r>
-              <a:t>  Week 3: Install 1 MCP server (GitHub or your most-used tool)</a:t>
+              <a:t>  Verification boundary: If you can't review and understand the code, you shouldn't ship it.</a:t>
             </a:r>
           </a:p>
           <a:p>
@@ -17203,7 +16908,7 @@
               </a:defRPr>
             </a:pPr>
             <a:r>
-              <a:t>  Week 4: Create custom subagent for your domain</a:t>
+              <a:t>  Novel work: Claude recombines known patterns brilliantly but doesn't truly invent new algorithms.</a:t>
             </a:r>
           </a:p>
           <a:p>
@@ -17221,7 +16926,7 @@
               </a:defRPr>
             </a:pPr>
             <a:r>
-              <a:t>  Month 2: Optimize CLAUDE.md with team conventions</a:t>
+              <a:t>  The 3 AM test: Could you debug this code at 3 AM without Claude? If not, you need to understand it better before ship...</a:t>
             </a:r>
           </a:p>
           <a:p>
@@ -17239,7 +16944,7 @@
               </a:defRPr>
             </a:pPr>
             <a:r>
-              <a:t>  Month 3: Pilot Agent Teams on complex project</a:t>
+              <a:t>  This is why Plan Mode, decomposition, and verification matter — they keep you in control.</a:t>
             </a:r>
           </a:p>
         </p:txBody>
@@ -17272,49 +16977,14 @@
       <p:grpSpPr/>
       <p:sp>
         <p:nvSpPr>
-          <p:cNvPr id="2" name="TextBox 1"/>
-          <p:cNvSpPr txBox="1"/>
-          <p:nvPr/>
-        </p:nvSpPr>
-        <p:spPr>
-          <a:xfrm>
-            <a:off x="457200" y="365760"/>
-            <a:ext cx="11277295" cy="822960"/>
-          </a:xfrm>
-          <a:prstGeom prst="rect">
-            <a:avLst/>
-          </a:prstGeom>
-          <a:noFill/>
-        </p:spPr>
-        <p:txBody>
-          <a:bodyPr wrap="none">
-            <a:spAutoFit/>
-          </a:bodyPr>
-          <a:lstStyle/>
-          <a:p>
-            <a:pPr>
-              <a:defRPr sz="4000" b="1">
-                <a:solidFill>
-                  <a:srgbClr val="FFFFFF"/>
-                </a:solidFill>
-              </a:defRPr>
-            </a:pPr>
-            <a:r>
-              <a:t>Resources</a:t>
-            </a:r>
-          </a:p>
-        </p:txBody>
-      </p:sp>
-      <p:sp>
-        <p:nvSpPr>
-          <p:cNvPr id="3" name="Rectangle 2"/>
+          <p:cNvPr id="2" name="Rectangle 1"/>
           <p:cNvSpPr/>
           <p:nvPr/>
         </p:nvSpPr>
         <p:spPr>
           <a:xfrm>
-            <a:off x="457200" y="1234440"/>
-            <a:ext cx="1828800" cy="36576"/>
+            <a:off x="0" y="1188720"/>
+            <a:ext cx="91440" cy="5029200"/>
           </a:xfrm>
           <a:prstGeom prst="rect">
             <a:avLst/>
@@ -17350,14 +17020,127 @@
       </p:sp>
       <p:sp>
         <p:nvSpPr>
-          <p:cNvPr id="4" name="TextBox 3"/>
+          <p:cNvPr id="3" name="TextBox 2"/>
           <p:cNvSpPr txBox="1"/>
           <p:nvPr/>
         </p:nvSpPr>
         <p:spPr>
           <a:xfrm>
-            <a:off x="457200" y="1463040"/>
-            <a:ext cx="11277295" cy="4572000"/>
+            <a:off x="457200" y="365760"/>
+            <a:ext cx="11277295" cy="822960"/>
+          </a:xfrm>
+          <a:prstGeom prst="rect">
+            <a:avLst/>
+          </a:prstGeom>
+          <a:noFill/>
+        </p:spPr>
+        <p:txBody>
+          <a:bodyPr wrap="none">
+            <a:spAutoFit/>
+          </a:bodyPr>
+          <a:lstStyle/>
+          <a:p>
+            <a:pPr>
+              <a:defRPr sz="4000" b="1">
+                <a:solidFill>
+                  <a:srgbClr val="FFFFFF"/>
+                </a:solidFill>
+              </a:defRPr>
+            </a:pPr>
+            <a:r>
+              <a:t>Day 3 Key Takeaways</a:t>
+            </a:r>
+          </a:p>
+        </p:txBody>
+      </p:sp>
+      <p:sp>
+        <p:nvSpPr>
+          <p:cNvPr id="4" name="Oval 3"/>
+          <p:cNvSpPr/>
+          <p:nvPr/>
+        </p:nvSpPr>
+        <p:spPr>
+          <a:xfrm>
+            <a:off x="457200" y="1371600"/>
+            <a:ext cx="411480" cy="411480"/>
+          </a:xfrm>
+          <a:prstGeom prst="ellipse">
+            <a:avLst/>
+          </a:prstGeom>
+          <a:solidFill>
+            <a:srgbClr val="00D4AA"/>
+          </a:solidFill>
+          <a:ln>
+            <a:noFill/>
+          </a:ln>
+        </p:spPr>
+        <p:style>
+          <a:lnRef idx="1">
+            <a:schemeClr val="accent1"/>
+          </a:lnRef>
+          <a:fillRef idx="3">
+            <a:schemeClr val="accent1"/>
+          </a:fillRef>
+          <a:effectRef idx="2">
+            <a:schemeClr val="accent1"/>
+          </a:effectRef>
+          <a:fontRef idx="minor">
+            <a:schemeClr val="lt1"/>
+          </a:fontRef>
+        </p:style>
+        <p:txBody>
+          <a:bodyPr rtlCol="0" anchor="ctr"/>
+          <a:lstStyle/>
+          <a:p>
+            <a:pPr algn="ctr"/>
+          </a:p>
+        </p:txBody>
+      </p:sp>
+      <p:sp>
+        <p:nvSpPr>
+          <p:cNvPr id="5" name="TextBox 4"/>
+          <p:cNvSpPr txBox="1"/>
+          <p:nvPr/>
+        </p:nvSpPr>
+        <p:spPr>
+          <a:xfrm>
+            <a:off x="457200" y="1371600"/>
+            <a:ext cx="411480" cy="411480"/>
+          </a:xfrm>
+          <a:prstGeom prst="rect">
+            <a:avLst/>
+          </a:prstGeom>
+          <a:noFill/>
+        </p:spPr>
+        <p:txBody>
+          <a:bodyPr wrap="none" anchor="ctr">
+            <a:spAutoFit/>
+          </a:bodyPr>
+          <a:lstStyle/>
+          <a:p>
+            <a:pPr algn="ctr">
+              <a:defRPr sz="2000" b="1">
+                <a:solidFill>
+                  <a:srgbClr val="0B0F1A"/>
+                </a:solidFill>
+              </a:defRPr>
+            </a:pPr>
+            <a:r>
+              <a:t>v</a:t>
+            </a:r>
+          </a:p>
+        </p:txBody>
+      </p:sp>
+      <p:sp>
+        <p:nvSpPr>
+          <p:cNvPr id="6" name="TextBox 5"/>
+          <p:cNvSpPr txBox="1"/>
+          <p:nvPr/>
+        </p:nvSpPr>
+        <p:spPr>
+          <a:xfrm>
+            <a:off x="1005840" y="1417320"/>
+            <a:ext cx="10728655" cy="731520"/>
           </a:xfrm>
           <a:prstGeom prst="rect">
             <a:avLst/>
@@ -17371,12 +17154,6 @@
           <a:lstStyle/>
           <a:p>
             <a:pPr>
-              <a:spcBef>
-                <a:spcPts val="800"/>
-              </a:spcBef>
-              <a:spcAft>
-                <a:spcPts val="800"/>
-              </a:spcAft>
               <a:defRPr sz="2200">
                 <a:solidFill>
                   <a:srgbClr val="FFFFFF"/>
@@ -17384,17 +17161,112 @@
               </a:defRPr>
             </a:pPr>
             <a:r>
-              <a:t>  Claude Code Docs: docs.anthropic.com/claude-code</a:t>
-            </a:r>
-          </a:p>
+              <a:t>Custom commands: Reusable workflows in .claude/commands/</a:t>
+            </a:r>
+          </a:p>
+        </p:txBody>
+      </p:sp>
+      <p:sp>
+        <p:nvSpPr>
+          <p:cNvPr id="7" name="Oval 6"/>
+          <p:cNvSpPr/>
+          <p:nvPr/>
+        </p:nvSpPr>
+        <p:spPr>
+          <a:xfrm>
+            <a:off x="457200" y="2194560"/>
+            <a:ext cx="411480" cy="411480"/>
+          </a:xfrm>
+          <a:prstGeom prst="ellipse">
+            <a:avLst/>
+          </a:prstGeom>
+          <a:solidFill>
+            <a:srgbClr val="00D4AA"/>
+          </a:solidFill>
+          <a:ln>
+            <a:noFill/>
+          </a:ln>
+        </p:spPr>
+        <p:style>
+          <a:lnRef idx="1">
+            <a:schemeClr val="accent1"/>
+          </a:lnRef>
+          <a:fillRef idx="3">
+            <a:schemeClr val="accent1"/>
+          </a:fillRef>
+          <a:effectRef idx="2">
+            <a:schemeClr val="accent1"/>
+          </a:effectRef>
+          <a:fontRef idx="minor">
+            <a:schemeClr val="lt1"/>
+          </a:fontRef>
+        </p:style>
+        <p:txBody>
+          <a:bodyPr rtlCol="0" anchor="ctr"/>
+          <a:lstStyle/>
+          <a:p>
+            <a:pPr algn="ctr"/>
+          </a:p>
+        </p:txBody>
+      </p:sp>
+      <p:sp>
+        <p:nvSpPr>
+          <p:cNvPr id="8" name="TextBox 7"/>
+          <p:cNvSpPr txBox="1"/>
+          <p:nvPr/>
+        </p:nvSpPr>
+        <p:spPr>
+          <a:xfrm>
+            <a:off x="457200" y="2194560"/>
+            <a:ext cx="411480" cy="411480"/>
+          </a:xfrm>
+          <a:prstGeom prst="rect">
+            <a:avLst/>
+          </a:prstGeom>
+          <a:noFill/>
+        </p:spPr>
+        <p:txBody>
+          <a:bodyPr wrap="none" anchor="ctr">
+            <a:spAutoFit/>
+          </a:bodyPr>
+          <a:lstStyle/>
+          <a:p>
+            <a:pPr algn="ctr">
+              <a:defRPr sz="2000" b="1">
+                <a:solidFill>
+                  <a:srgbClr val="0B0F1A"/>
+                </a:solidFill>
+              </a:defRPr>
+            </a:pPr>
+            <a:r>
+              <a:t>v</a:t>
+            </a:r>
+          </a:p>
+        </p:txBody>
+      </p:sp>
+      <p:sp>
+        <p:nvSpPr>
+          <p:cNvPr id="9" name="TextBox 8"/>
+          <p:cNvSpPr txBox="1"/>
+          <p:nvPr/>
+        </p:nvSpPr>
+        <p:spPr>
+          <a:xfrm>
+            <a:off x="1005840" y="2240280"/>
+            <a:ext cx="10728655" cy="731520"/>
+          </a:xfrm>
+          <a:prstGeom prst="rect">
+            <a:avLst/>
+          </a:prstGeom>
+          <a:noFill/>
+        </p:spPr>
+        <p:txBody>
+          <a:bodyPr wrap="square">
+            <a:spAutoFit/>
+          </a:bodyPr>
+          <a:lstStyle/>
           <a:p>
             <a:pPr>
-              <a:spcBef>
-                <a:spcPts val="800"/>
-              </a:spcBef>
-              <a:spcAft>
-                <a:spcPts val="800"/>
-              </a:spcAft>
               <a:defRPr sz="2200">
                 <a:solidFill>
                   <a:srgbClr val="FFFFFF"/>
@@ -17402,17 +17274,112 @@
               </a:defRPr>
             </a:pPr>
             <a:r>
-              <a:t>  MCP Protocol: modelcontextprotocol.io</a:t>
-            </a:r>
-          </a:p>
+              <a:t>Subagents: Specialized AI workers for focused tasks</a:t>
+            </a:r>
+          </a:p>
+        </p:txBody>
+      </p:sp>
+      <p:sp>
+        <p:nvSpPr>
+          <p:cNvPr id="10" name="Oval 9"/>
+          <p:cNvSpPr/>
+          <p:nvPr/>
+        </p:nvSpPr>
+        <p:spPr>
+          <a:xfrm>
+            <a:off x="457200" y="3017520"/>
+            <a:ext cx="411480" cy="411480"/>
+          </a:xfrm>
+          <a:prstGeom prst="ellipse">
+            <a:avLst/>
+          </a:prstGeom>
+          <a:solidFill>
+            <a:srgbClr val="00D4AA"/>
+          </a:solidFill>
+          <a:ln>
+            <a:noFill/>
+          </a:ln>
+        </p:spPr>
+        <p:style>
+          <a:lnRef idx="1">
+            <a:schemeClr val="accent1"/>
+          </a:lnRef>
+          <a:fillRef idx="3">
+            <a:schemeClr val="accent1"/>
+          </a:fillRef>
+          <a:effectRef idx="2">
+            <a:schemeClr val="accent1"/>
+          </a:effectRef>
+          <a:fontRef idx="minor">
+            <a:schemeClr val="lt1"/>
+          </a:fontRef>
+        </p:style>
+        <p:txBody>
+          <a:bodyPr rtlCol="0" anchor="ctr"/>
+          <a:lstStyle/>
+          <a:p>
+            <a:pPr algn="ctr"/>
+          </a:p>
+        </p:txBody>
+      </p:sp>
+      <p:sp>
+        <p:nvSpPr>
+          <p:cNvPr id="11" name="TextBox 10"/>
+          <p:cNvSpPr txBox="1"/>
+          <p:nvPr/>
+        </p:nvSpPr>
+        <p:spPr>
+          <a:xfrm>
+            <a:off x="457200" y="3017520"/>
+            <a:ext cx="411480" cy="411480"/>
+          </a:xfrm>
+          <a:prstGeom prst="rect">
+            <a:avLst/>
+          </a:prstGeom>
+          <a:noFill/>
+        </p:spPr>
+        <p:txBody>
+          <a:bodyPr wrap="none" anchor="ctr">
+            <a:spAutoFit/>
+          </a:bodyPr>
+          <a:lstStyle/>
+          <a:p>
+            <a:pPr algn="ctr">
+              <a:defRPr sz="2000" b="1">
+                <a:solidFill>
+                  <a:srgbClr val="0B0F1A"/>
+                </a:solidFill>
+              </a:defRPr>
+            </a:pPr>
+            <a:r>
+              <a:t>v</a:t>
+            </a:r>
+          </a:p>
+        </p:txBody>
+      </p:sp>
+      <p:sp>
+        <p:nvSpPr>
+          <p:cNvPr id="12" name="TextBox 11"/>
+          <p:cNvSpPr txBox="1"/>
+          <p:nvPr/>
+        </p:nvSpPr>
+        <p:spPr>
+          <a:xfrm>
+            <a:off x="1005840" y="3063240"/>
+            <a:ext cx="10728655" cy="731520"/>
+          </a:xfrm>
+          <a:prstGeom prst="rect">
+            <a:avLst/>
+          </a:prstGeom>
+          <a:noFill/>
+        </p:spPr>
+        <p:txBody>
+          <a:bodyPr wrap="square">
+            <a:spAutoFit/>
+          </a:bodyPr>
+          <a:lstStyle/>
           <a:p>
             <a:pPr>
-              <a:spcBef>
-                <a:spcPts val="800"/>
-              </a:spcBef>
-              <a:spcAft>
-                <a:spcPts val="800"/>
-              </a:spcAft>
               <a:defRPr sz="2200">
                 <a:solidFill>
                   <a:srgbClr val="FFFFFF"/>
@@ -17420,17 +17387,112 @@
               </a:defRPr>
             </a:pPr>
             <a:r>
-              <a:t>  MCP Servers: github.com/modelcontextprotocol/servers</a:t>
-            </a:r>
-          </a:p>
+              <a:t>Hooks: Safety guardrails and audit logging</a:t>
+            </a:r>
+          </a:p>
+        </p:txBody>
+      </p:sp>
+      <p:sp>
+        <p:nvSpPr>
+          <p:cNvPr id="13" name="Oval 12"/>
+          <p:cNvSpPr/>
+          <p:nvPr/>
+        </p:nvSpPr>
+        <p:spPr>
+          <a:xfrm>
+            <a:off x="457200" y="3840480"/>
+            <a:ext cx="411480" cy="411480"/>
+          </a:xfrm>
+          <a:prstGeom prst="ellipse">
+            <a:avLst/>
+          </a:prstGeom>
+          <a:solidFill>
+            <a:srgbClr val="00D4AA"/>
+          </a:solidFill>
+          <a:ln>
+            <a:noFill/>
+          </a:ln>
+        </p:spPr>
+        <p:style>
+          <a:lnRef idx="1">
+            <a:schemeClr val="accent1"/>
+          </a:lnRef>
+          <a:fillRef idx="3">
+            <a:schemeClr val="accent1"/>
+          </a:fillRef>
+          <a:effectRef idx="2">
+            <a:schemeClr val="accent1"/>
+          </a:effectRef>
+          <a:fontRef idx="minor">
+            <a:schemeClr val="lt1"/>
+          </a:fontRef>
+        </p:style>
+        <p:txBody>
+          <a:bodyPr rtlCol="0" anchor="ctr"/>
+          <a:lstStyle/>
+          <a:p>
+            <a:pPr algn="ctr"/>
+          </a:p>
+        </p:txBody>
+      </p:sp>
+      <p:sp>
+        <p:nvSpPr>
+          <p:cNvPr id="14" name="TextBox 13"/>
+          <p:cNvSpPr txBox="1"/>
+          <p:nvPr/>
+        </p:nvSpPr>
+        <p:spPr>
+          <a:xfrm>
+            <a:off x="457200" y="3840480"/>
+            <a:ext cx="411480" cy="411480"/>
+          </a:xfrm>
+          <a:prstGeom prst="rect">
+            <a:avLst/>
+          </a:prstGeom>
+          <a:noFill/>
+        </p:spPr>
+        <p:txBody>
+          <a:bodyPr wrap="none" anchor="ctr">
+            <a:spAutoFit/>
+          </a:bodyPr>
+          <a:lstStyle/>
+          <a:p>
+            <a:pPr algn="ctr">
+              <a:defRPr sz="2000" b="1">
+                <a:solidFill>
+                  <a:srgbClr val="0B0F1A"/>
+                </a:solidFill>
+              </a:defRPr>
+            </a:pPr>
+            <a:r>
+              <a:t>v</a:t>
+            </a:r>
+          </a:p>
+        </p:txBody>
+      </p:sp>
+      <p:sp>
+        <p:nvSpPr>
+          <p:cNvPr id="15" name="TextBox 14"/>
+          <p:cNvSpPr txBox="1"/>
+          <p:nvPr/>
+        </p:nvSpPr>
+        <p:spPr>
+          <a:xfrm>
+            <a:off x="1005840" y="3886200"/>
+            <a:ext cx="10728655" cy="731520"/>
+          </a:xfrm>
+          <a:prstGeom prst="rect">
+            <a:avLst/>
+          </a:prstGeom>
+          <a:noFill/>
+        </p:spPr>
+        <p:txBody>
+          <a:bodyPr wrap="square">
+            <a:spAutoFit/>
+          </a:bodyPr>
+          <a:lstStyle/>
           <a:p>
             <a:pPr>
-              <a:spcBef>
-                <a:spcPts val="800"/>
-              </a:spcBef>
-              <a:spcAft>
-                <a:spcPts val="800"/>
-              </a:spcAft>
               <a:defRPr sz="2200">
                 <a:solidFill>
                   <a:srgbClr val="FFFFFF"/>
@@ -17438,17 +17500,112 @@
               </a:defRPr>
             </a:pPr>
             <a:r>
-              <a:t>  Community Commands: github.com/hesreallyhim/awesome-claude-code</a:t>
-            </a:r>
-          </a:p>
+              <a:t>Plan mode + thinking levels: Control quality/speed/cost tradeoffs</a:t>
+            </a:r>
+          </a:p>
+        </p:txBody>
+      </p:sp>
+      <p:sp>
+        <p:nvSpPr>
+          <p:cNvPr id="16" name="Oval 15"/>
+          <p:cNvSpPr/>
+          <p:nvPr/>
+        </p:nvSpPr>
+        <p:spPr>
+          <a:xfrm>
+            <a:off x="457200" y="4663440"/>
+            <a:ext cx="411480" cy="411480"/>
+          </a:xfrm>
+          <a:prstGeom prst="ellipse">
+            <a:avLst/>
+          </a:prstGeom>
+          <a:solidFill>
+            <a:srgbClr val="00D4AA"/>
+          </a:solidFill>
+          <a:ln>
+            <a:noFill/>
+          </a:ln>
+        </p:spPr>
+        <p:style>
+          <a:lnRef idx="1">
+            <a:schemeClr val="accent1"/>
+          </a:lnRef>
+          <a:fillRef idx="3">
+            <a:schemeClr val="accent1"/>
+          </a:fillRef>
+          <a:effectRef idx="2">
+            <a:schemeClr val="accent1"/>
+          </a:effectRef>
+          <a:fontRef idx="minor">
+            <a:schemeClr val="lt1"/>
+          </a:fontRef>
+        </p:style>
+        <p:txBody>
+          <a:bodyPr rtlCol="0" anchor="ctr"/>
+          <a:lstStyle/>
+          <a:p>
+            <a:pPr algn="ctr"/>
+          </a:p>
+        </p:txBody>
+      </p:sp>
+      <p:sp>
+        <p:nvSpPr>
+          <p:cNvPr id="17" name="TextBox 16"/>
+          <p:cNvSpPr txBox="1"/>
+          <p:nvPr/>
+        </p:nvSpPr>
+        <p:spPr>
+          <a:xfrm>
+            <a:off x="457200" y="4663440"/>
+            <a:ext cx="411480" cy="411480"/>
+          </a:xfrm>
+          <a:prstGeom prst="rect">
+            <a:avLst/>
+          </a:prstGeom>
+          <a:noFill/>
+        </p:spPr>
+        <p:txBody>
+          <a:bodyPr wrap="none" anchor="ctr">
+            <a:spAutoFit/>
+          </a:bodyPr>
+          <a:lstStyle/>
+          <a:p>
+            <a:pPr algn="ctr">
+              <a:defRPr sz="2000" b="1">
+                <a:solidFill>
+                  <a:srgbClr val="0B0F1A"/>
+                </a:solidFill>
+              </a:defRPr>
+            </a:pPr>
+            <a:r>
+              <a:t>v</a:t>
+            </a:r>
+          </a:p>
+        </p:txBody>
+      </p:sp>
+      <p:sp>
+        <p:nvSpPr>
+          <p:cNvPr id="18" name="TextBox 17"/>
+          <p:cNvSpPr txBox="1"/>
+          <p:nvPr/>
+        </p:nvSpPr>
+        <p:spPr>
+          <a:xfrm>
+            <a:off x="1005840" y="4709160"/>
+            <a:ext cx="10728655" cy="731520"/>
+          </a:xfrm>
+          <a:prstGeom prst="rect">
+            <a:avLst/>
+          </a:prstGeom>
+          <a:noFill/>
+        </p:spPr>
+        <p:txBody>
+          <a:bodyPr wrap="square">
+            <a:spAutoFit/>
+          </a:bodyPr>
+          <a:lstStyle/>
           <a:p>
             <a:pPr>
-              <a:spcBef>
-                <a:spcPts val="800"/>
-              </a:spcBef>
-              <a:spcAft>
-                <a:spcPts val="800"/>
-              </a:spcAft>
               <a:defRPr sz="2200">
                 <a:solidFill>
                   <a:srgbClr val="FFFFFF"/>
@@ -17456,17 +17613,112 @@
               </a:defRPr>
             </a:pPr>
             <a:r>
-              <a:t>  Agent Teams Examples: github.com/ColeMedin/AgentTeamsExamples</a:t>
-            </a:r>
-          </a:p>
+              <a:t>MCP: Connect Claude to any external system</a:t>
+            </a:r>
+          </a:p>
+        </p:txBody>
+      </p:sp>
+      <p:sp>
+        <p:nvSpPr>
+          <p:cNvPr id="19" name="Oval 18"/>
+          <p:cNvSpPr/>
+          <p:nvPr/>
+        </p:nvSpPr>
+        <p:spPr>
+          <a:xfrm>
+            <a:off x="457200" y="5486400"/>
+            <a:ext cx="411480" cy="411480"/>
+          </a:xfrm>
+          <a:prstGeom prst="ellipse">
+            <a:avLst/>
+          </a:prstGeom>
+          <a:solidFill>
+            <a:srgbClr val="00D4AA"/>
+          </a:solidFill>
+          <a:ln>
+            <a:noFill/>
+          </a:ln>
+        </p:spPr>
+        <p:style>
+          <a:lnRef idx="1">
+            <a:schemeClr val="accent1"/>
+          </a:lnRef>
+          <a:fillRef idx="3">
+            <a:schemeClr val="accent1"/>
+          </a:fillRef>
+          <a:effectRef idx="2">
+            <a:schemeClr val="accent1"/>
+          </a:effectRef>
+          <a:fontRef idx="minor">
+            <a:schemeClr val="lt1"/>
+          </a:fontRef>
+        </p:style>
+        <p:txBody>
+          <a:bodyPr rtlCol="0" anchor="ctr"/>
+          <a:lstStyle/>
+          <a:p>
+            <a:pPr algn="ctr"/>
+          </a:p>
+        </p:txBody>
+      </p:sp>
+      <p:sp>
+        <p:nvSpPr>
+          <p:cNvPr id="20" name="TextBox 19"/>
+          <p:cNvSpPr txBox="1"/>
+          <p:nvPr/>
+        </p:nvSpPr>
+        <p:spPr>
+          <a:xfrm>
+            <a:off x="457200" y="5486400"/>
+            <a:ext cx="411480" cy="411480"/>
+          </a:xfrm>
+          <a:prstGeom prst="rect">
+            <a:avLst/>
+          </a:prstGeom>
+          <a:noFill/>
+        </p:spPr>
+        <p:txBody>
+          <a:bodyPr wrap="none" anchor="ctr">
+            <a:spAutoFit/>
+          </a:bodyPr>
+          <a:lstStyle/>
+          <a:p>
+            <a:pPr algn="ctr">
+              <a:defRPr sz="2000" b="1">
+                <a:solidFill>
+                  <a:srgbClr val="0B0F1A"/>
+                </a:solidFill>
+              </a:defRPr>
+            </a:pPr>
+            <a:r>
+              <a:t>v</a:t>
+            </a:r>
+          </a:p>
+        </p:txBody>
+      </p:sp>
+      <p:sp>
+        <p:nvSpPr>
+          <p:cNvPr id="21" name="TextBox 20"/>
+          <p:cNvSpPr txBox="1"/>
+          <p:nvPr/>
+        </p:nvSpPr>
+        <p:spPr>
+          <a:xfrm>
+            <a:off x="1005840" y="5532120"/>
+            <a:ext cx="10728655" cy="731520"/>
+          </a:xfrm>
+          <a:prstGeom prst="rect">
+            <a:avLst/>
+          </a:prstGeom>
+          <a:noFill/>
+        </p:spPr>
+        <p:txBody>
+          <a:bodyPr wrap="square">
+            <a:spAutoFit/>
+          </a:bodyPr>
+          <a:lstStyle/>
           <a:p>
             <a:pPr>
-              <a:spcBef>
-                <a:spcPts val="800"/>
-              </a:spcBef>
-              <a:spcAft>
-                <a:spcPts val="800"/>
-              </a:spcAft>
               <a:defRPr sz="2200">
                 <a:solidFill>
                   <a:srgbClr val="FFFFFF"/>
@@ -17474,25 +17726,7 @@
               </a:defRPr>
             </a:pPr>
             <a:r>
-              <a:t>  Discord: discord.gg/anthropic-community</a:t>
-            </a:r>
-          </a:p>
-          <a:p>
-            <a:pPr>
-              <a:spcBef>
-                <a:spcPts val="800"/>
-              </a:spcBef>
-              <a:spcAft>
-                <a:spcPts val="800"/>
-              </a:spcAft>
-              <a:defRPr sz="2200">
-                <a:solidFill>
-                  <a:srgbClr val="FFFFFF"/>
-                </a:solidFill>
-              </a:defRPr>
-            </a:pPr>
-            <a:r>
-              <a:t>  Your team: Schedule follow-up in 2 weeks to share learnings</a:t>
+              <a:t>Agent Teams: Parallel coordination for complex work</a:t>
             </a:r>
           </a:p>
         </p:txBody>
@@ -17531,6 +17765,494 @@
         </p:nvSpPr>
         <p:spPr>
           <a:xfrm>
+            <a:off x="457200" y="365760"/>
+            <a:ext cx="11277295" cy="822960"/>
+          </a:xfrm>
+          <a:prstGeom prst="rect">
+            <a:avLst/>
+          </a:prstGeom>
+          <a:noFill/>
+        </p:spPr>
+        <p:txBody>
+          <a:bodyPr wrap="none">
+            <a:spAutoFit/>
+          </a:bodyPr>
+          <a:lstStyle/>
+          <a:p>
+            <a:pPr>
+              <a:defRPr sz="4000" b="1">
+                <a:solidFill>
+                  <a:srgbClr val="FFFFFF"/>
+                </a:solidFill>
+              </a:defRPr>
+            </a:pPr>
+            <a:r>
+              <a:t>Getting Started Roadmap</a:t>
+            </a:r>
+          </a:p>
+        </p:txBody>
+      </p:sp>
+      <p:sp>
+        <p:nvSpPr>
+          <p:cNvPr id="3" name="Rectangle 2"/>
+          <p:cNvSpPr/>
+          <p:nvPr/>
+        </p:nvSpPr>
+        <p:spPr>
+          <a:xfrm>
+            <a:off x="457200" y="1234440"/>
+            <a:ext cx="1828800" cy="36576"/>
+          </a:xfrm>
+          <a:prstGeom prst="rect">
+            <a:avLst/>
+          </a:prstGeom>
+          <a:solidFill>
+            <a:srgbClr val="00D4AA"/>
+          </a:solidFill>
+          <a:ln>
+            <a:noFill/>
+          </a:ln>
+        </p:spPr>
+        <p:style>
+          <a:lnRef idx="1">
+            <a:schemeClr val="accent1"/>
+          </a:lnRef>
+          <a:fillRef idx="3">
+            <a:schemeClr val="accent1"/>
+          </a:fillRef>
+          <a:effectRef idx="2">
+            <a:schemeClr val="accent1"/>
+          </a:effectRef>
+          <a:fontRef idx="minor">
+            <a:schemeClr val="lt1"/>
+          </a:fontRef>
+        </p:style>
+        <p:txBody>
+          <a:bodyPr rtlCol="0" anchor="ctr"/>
+          <a:lstStyle/>
+          <a:p>
+            <a:pPr algn="ctr"/>
+          </a:p>
+        </p:txBody>
+      </p:sp>
+      <p:sp>
+        <p:nvSpPr>
+          <p:cNvPr id="4" name="TextBox 3"/>
+          <p:cNvSpPr txBox="1"/>
+          <p:nvPr/>
+        </p:nvSpPr>
+        <p:spPr>
+          <a:xfrm>
+            <a:off x="457200" y="1463040"/>
+            <a:ext cx="11277295" cy="4572000"/>
+          </a:xfrm>
+          <a:prstGeom prst="rect">
+            <a:avLst/>
+          </a:prstGeom>
+          <a:noFill/>
+        </p:spPr>
+        <p:txBody>
+          <a:bodyPr wrap="square">
+            <a:spAutoFit/>
+          </a:bodyPr>
+          <a:lstStyle/>
+          <a:p>
+            <a:pPr>
+              <a:spcBef>
+                <a:spcPts val="800"/>
+              </a:spcBef>
+              <a:spcAft>
+                <a:spcPts val="800"/>
+              </a:spcAft>
+              <a:defRPr sz="2200">
+                <a:solidFill>
+                  <a:srgbClr val="FFFFFF"/>
+                </a:solidFill>
+              </a:defRPr>
+            </a:pPr>
+            <a:r>
+              <a:t>  Week 1: Create 2-3 custom commands for your daily workflows</a:t>
+            </a:r>
+          </a:p>
+          <a:p>
+            <a:pPr>
+              <a:spcBef>
+                <a:spcPts val="800"/>
+              </a:spcBef>
+              <a:spcAft>
+                <a:spcPts val="800"/>
+              </a:spcAft>
+              <a:defRPr sz="2200">
+                <a:solidFill>
+                  <a:srgbClr val="FFFFFF"/>
+                </a:solidFill>
+              </a:defRPr>
+            </a:pPr>
+            <a:r>
+              <a:t>  Week 2: Implement pre-tool hook for security (no secrets)</a:t>
+            </a:r>
+          </a:p>
+          <a:p>
+            <a:pPr>
+              <a:spcBef>
+                <a:spcPts val="800"/>
+              </a:spcBef>
+              <a:spcAft>
+                <a:spcPts val="800"/>
+              </a:spcAft>
+              <a:defRPr sz="2200">
+                <a:solidFill>
+                  <a:srgbClr val="FFFFFF"/>
+                </a:solidFill>
+              </a:defRPr>
+            </a:pPr>
+            <a:r>
+              <a:t>  Week 3: Install 1 MCP server (GitHub or your most-used tool)</a:t>
+            </a:r>
+          </a:p>
+          <a:p>
+            <a:pPr>
+              <a:spcBef>
+                <a:spcPts val="800"/>
+              </a:spcBef>
+              <a:spcAft>
+                <a:spcPts val="800"/>
+              </a:spcAft>
+              <a:defRPr sz="2200">
+                <a:solidFill>
+                  <a:srgbClr val="FFFFFF"/>
+                </a:solidFill>
+              </a:defRPr>
+            </a:pPr>
+            <a:r>
+              <a:t>  Week 4: Create custom subagent for your domain</a:t>
+            </a:r>
+          </a:p>
+          <a:p>
+            <a:pPr>
+              <a:spcBef>
+                <a:spcPts val="800"/>
+              </a:spcBef>
+              <a:spcAft>
+                <a:spcPts val="800"/>
+              </a:spcAft>
+              <a:defRPr sz="2200">
+                <a:solidFill>
+                  <a:srgbClr val="FFFFFF"/>
+                </a:solidFill>
+              </a:defRPr>
+            </a:pPr>
+            <a:r>
+              <a:t>  Month 2: Optimize CLAUDE.md with team conventions</a:t>
+            </a:r>
+          </a:p>
+          <a:p>
+            <a:pPr>
+              <a:spcBef>
+                <a:spcPts val="800"/>
+              </a:spcBef>
+              <a:spcAft>
+                <a:spcPts val="800"/>
+              </a:spcAft>
+              <a:defRPr sz="2200">
+                <a:solidFill>
+                  <a:srgbClr val="FFFFFF"/>
+                </a:solidFill>
+              </a:defRPr>
+            </a:pPr>
+            <a:r>
+              <a:t>  Month 3: Pilot Agent Teams on complex project</a:t>
+            </a:r>
+          </a:p>
+        </p:txBody>
+      </p:sp>
+    </p:spTree>
+  </p:cSld>
+  <p:clrMapOvr>
+    <a:masterClrMapping/>
+  </p:clrMapOvr>
+</p:sld>
+</file>
+
+<file path=ppt/slides/slide106.xml><?xml version="1.0" encoding="utf-8"?>
+<p:sld xmlns:a="http://schemas.openxmlformats.org/drawingml/2006/main" xmlns:p="http://schemas.openxmlformats.org/presentationml/2006/main" xmlns:r="http://schemas.openxmlformats.org/officeDocument/2006/relationships">
+  <p:cSld>
+    <p:bg>
+      <p:bgPr>
+        <a:solidFill>
+          <a:srgbClr val="0B0F1A"/>
+        </a:solidFill>
+        <a:effectLst/>
+      </p:bgPr>
+    </p:bg>
+    <p:spTree>
+      <p:nvGrpSpPr>
+        <p:cNvPr id="1" name=""/>
+        <p:cNvGrpSpPr/>
+        <p:nvPr/>
+      </p:nvGrpSpPr>
+      <p:grpSpPr/>
+      <p:sp>
+        <p:nvSpPr>
+          <p:cNvPr id="2" name="TextBox 1"/>
+          <p:cNvSpPr txBox="1"/>
+          <p:nvPr/>
+        </p:nvSpPr>
+        <p:spPr>
+          <a:xfrm>
+            <a:off x="457200" y="365760"/>
+            <a:ext cx="11277295" cy="822960"/>
+          </a:xfrm>
+          <a:prstGeom prst="rect">
+            <a:avLst/>
+          </a:prstGeom>
+          <a:noFill/>
+        </p:spPr>
+        <p:txBody>
+          <a:bodyPr wrap="none">
+            <a:spAutoFit/>
+          </a:bodyPr>
+          <a:lstStyle/>
+          <a:p>
+            <a:pPr>
+              <a:defRPr sz="4000" b="1">
+                <a:solidFill>
+                  <a:srgbClr val="FFFFFF"/>
+                </a:solidFill>
+              </a:defRPr>
+            </a:pPr>
+            <a:r>
+              <a:t>Resources</a:t>
+            </a:r>
+          </a:p>
+        </p:txBody>
+      </p:sp>
+      <p:sp>
+        <p:nvSpPr>
+          <p:cNvPr id="3" name="Rectangle 2"/>
+          <p:cNvSpPr/>
+          <p:nvPr/>
+        </p:nvSpPr>
+        <p:spPr>
+          <a:xfrm>
+            <a:off x="457200" y="1234440"/>
+            <a:ext cx="1828800" cy="36576"/>
+          </a:xfrm>
+          <a:prstGeom prst="rect">
+            <a:avLst/>
+          </a:prstGeom>
+          <a:solidFill>
+            <a:srgbClr val="00D4AA"/>
+          </a:solidFill>
+          <a:ln>
+            <a:noFill/>
+          </a:ln>
+        </p:spPr>
+        <p:style>
+          <a:lnRef idx="1">
+            <a:schemeClr val="accent1"/>
+          </a:lnRef>
+          <a:fillRef idx="3">
+            <a:schemeClr val="accent1"/>
+          </a:fillRef>
+          <a:effectRef idx="2">
+            <a:schemeClr val="accent1"/>
+          </a:effectRef>
+          <a:fontRef idx="minor">
+            <a:schemeClr val="lt1"/>
+          </a:fontRef>
+        </p:style>
+        <p:txBody>
+          <a:bodyPr rtlCol="0" anchor="ctr"/>
+          <a:lstStyle/>
+          <a:p>
+            <a:pPr algn="ctr"/>
+          </a:p>
+        </p:txBody>
+      </p:sp>
+      <p:sp>
+        <p:nvSpPr>
+          <p:cNvPr id="4" name="TextBox 3"/>
+          <p:cNvSpPr txBox="1"/>
+          <p:nvPr/>
+        </p:nvSpPr>
+        <p:spPr>
+          <a:xfrm>
+            <a:off x="457200" y="1463040"/>
+            <a:ext cx="11277295" cy="4572000"/>
+          </a:xfrm>
+          <a:prstGeom prst="rect">
+            <a:avLst/>
+          </a:prstGeom>
+          <a:noFill/>
+        </p:spPr>
+        <p:txBody>
+          <a:bodyPr wrap="square">
+            <a:spAutoFit/>
+          </a:bodyPr>
+          <a:lstStyle/>
+          <a:p>
+            <a:pPr>
+              <a:spcBef>
+                <a:spcPts val="800"/>
+              </a:spcBef>
+              <a:spcAft>
+                <a:spcPts val="800"/>
+              </a:spcAft>
+              <a:defRPr sz="2200">
+                <a:solidFill>
+                  <a:srgbClr val="FFFFFF"/>
+                </a:solidFill>
+              </a:defRPr>
+            </a:pPr>
+            <a:r>
+              <a:t>  Claude Code Docs: docs.anthropic.com/claude-code</a:t>
+            </a:r>
+          </a:p>
+          <a:p>
+            <a:pPr>
+              <a:spcBef>
+                <a:spcPts val="800"/>
+              </a:spcBef>
+              <a:spcAft>
+                <a:spcPts val="800"/>
+              </a:spcAft>
+              <a:defRPr sz="2200">
+                <a:solidFill>
+                  <a:srgbClr val="FFFFFF"/>
+                </a:solidFill>
+              </a:defRPr>
+            </a:pPr>
+            <a:r>
+              <a:t>  MCP Protocol: modelcontextprotocol.io</a:t>
+            </a:r>
+          </a:p>
+          <a:p>
+            <a:pPr>
+              <a:spcBef>
+                <a:spcPts val="800"/>
+              </a:spcBef>
+              <a:spcAft>
+                <a:spcPts val="800"/>
+              </a:spcAft>
+              <a:defRPr sz="2200">
+                <a:solidFill>
+                  <a:srgbClr val="FFFFFF"/>
+                </a:solidFill>
+              </a:defRPr>
+            </a:pPr>
+            <a:r>
+              <a:t>  MCP Servers: github.com/modelcontextprotocol/servers</a:t>
+            </a:r>
+          </a:p>
+          <a:p>
+            <a:pPr>
+              <a:spcBef>
+                <a:spcPts val="800"/>
+              </a:spcBef>
+              <a:spcAft>
+                <a:spcPts val="800"/>
+              </a:spcAft>
+              <a:defRPr sz="2200">
+                <a:solidFill>
+                  <a:srgbClr val="FFFFFF"/>
+                </a:solidFill>
+              </a:defRPr>
+            </a:pPr>
+            <a:r>
+              <a:t>  Community Commands: github.com/hesreallyhim/awesome-claude-code</a:t>
+            </a:r>
+          </a:p>
+          <a:p>
+            <a:pPr>
+              <a:spcBef>
+                <a:spcPts val="800"/>
+              </a:spcBef>
+              <a:spcAft>
+                <a:spcPts val="800"/>
+              </a:spcAft>
+              <a:defRPr sz="2200">
+                <a:solidFill>
+                  <a:srgbClr val="FFFFFF"/>
+                </a:solidFill>
+              </a:defRPr>
+            </a:pPr>
+            <a:r>
+              <a:t>  Agent Teams Examples: github.com/ColeMedin/AgentTeamsExamples</a:t>
+            </a:r>
+          </a:p>
+          <a:p>
+            <a:pPr>
+              <a:spcBef>
+                <a:spcPts val="800"/>
+              </a:spcBef>
+              <a:spcAft>
+                <a:spcPts val="800"/>
+              </a:spcAft>
+              <a:defRPr sz="2200">
+                <a:solidFill>
+                  <a:srgbClr val="FFFFFF"/>
+                </a:solidFill>
+              </a:defRPr>
+            </a:pPr>
+            <a:r>
+              <a:t>  Discord: discord.gg/anthropic-community</a:t>
+            </a:r>
+          </a:p>
+          <a:p>
+            <a:pPr>
+              <a:spcBef>
+                <a:spcPts val="800"/>
+              </a:spcBef>
+              <a:spcAft>
+                <a:spcPts val="800"/>
+              </a:spcAft>
+              <a:defRPr sz="2200">
+                <a:solidFill>
+                  <a:srgbClr val="FFFFFF"/>
+                </a:solidFill>
+              </a:defRPr>
+            </a:pPr>
+            <a:r>
+              <a:t>  Your team: Schedule follow-up in 2 weeks to share learnings</a:t>
+            </a:r>
+          </a:p>
+        </p:txBody>
+      </p:sp>
+    </p:spTree>
+  </p:cSld>
+  <p:clrMapOvr>
+    <a:masterClrMapping/>
+  </p:clrMapOvr>
+</p:sld>
+</file>
+
+<file path=ppt/slides/slide107.xml><?xml version="1.0" encoding="utf-8"?>
+<p:sld xmlns:a="http://schemas.openxmlformats.org/drawingml/2006/main" xmlns:p="http://schemas.openxmlformats.org/presentationml/2006/main" xmlns:r="http://schemas.openxmlformats.org/officeDocument/2006/relationships">
+  <p:cSld>
+    <p:bg>
+      <p:bgPr>
+        <a:solidFill>
+          <a:srgbClr val="0B0F1A"/>
+        </a:solidFill>
+        <a:effectLst/>
+      </p:bgPr>
+    </p:bg>
+    <p:spTree>
+      <p:nvGrpSpPr>
+        <p:cNvPr id="1" name=""/>
+        <p:cNvGrpSpPr/>
+        <p:nvPr/>
+      </p:nvGrpSpPr>
+      <p:grpSpPr/>
+      <p:sp>
+        <p:nvSpPr>
+          <p:cNvPr id="2" name="TextBox 1"/>
+          <p:cNvSpPr txBox="1"/>
+          <p:nvPr/>
+        </p:nvSpPr>
+        <p:spPr>
+          <a:xfrm>
             <a:off x="457200" y="2286000"/>
             <a:ext cx="11277295" cy="2286000"/>
           </a:xfrm>
@@ -45789,8 +46511,8 @@
         </p:nvSpPr>
         <p:spPr>
           <a:xfrm>
-            <a:off x="457200" y="365760"/>
-            <a:ext cx="11277295" cy="822960"/>
+            <a:off x="457200" y="457200"/>
+            <a:ext cx="11277295" cy="731520"/>
           </a:xfrm>
           <a:prstGeom prst="rect">
             <a:avLst/>
@@ -45803,15 +46525,15 @@
           </a:bodyPr>
           <a:lstStyle/>
           <a:p>
-            <a:pPr>
-              <a:defRPr sz="4000" b="1">
+            <a:pPr algn="ctr">
+              <a:defRPr sz="3600" b="1">
                 <a:solidFill>
                   <a:srgbClr val="FFFFFF"/>
                 </a:solidFill>
               </a:defRPr>
             </a:pPr>
             <a:r>
-              <a:t>Production Deployment Checklist</a:t>
+              <a:t>Spec-Driven AI Development: The 4-Phase Process</a:t>
             </a:r>
           </a:p>
         </p:txBody>
@@ -45824,8 +46546,8 @@
         </p:nvSpPr>
         <p:spPr>
           <a:xfrm>
-            <a:off x="457200" y="1234440"/>
-            <a:ext cx="1828800" cy="36576"/>
+            <a:off x="6077559" y="1371600"/>
+            <a:ext cx="36576" cy="4572000"/>
           </a:xfrm>
           <a:prstGeom prst="rect">
             <a:avLst/>
@@ -45868,7 +46590,7 @@
         <p:spPr>
           <a:xfrm>
             <a:off x="457200" y="1463040"/>
-            <a:ext cx="11277295" cy="4572000"/>
+            <a:ext cx="5364327" cy="731520"/>
           </a:xfrm>
           <a:prstGeom prst="rect">
             <a:avLst/>
@@ -45876,152 +46598,55 @@
           <a:noFill/>
         </p:spPr>
         <p:txBody>
-          <a:bodyPr wrap="square">
+          <a:bodyPr wrap="none">
             <a:spAutoFit/>
           </a:bodyPr>
           <a:lstStyle/>
           <a:p>
-            <a:pPr>
-              <a:spcBef>
-                <a:spcPts val="800"/>
-              </a:spcBef>
-              <a:spcAft>
-                <a:spcPts val="800"/>
-              </a:spcAft>
-              <a:defRPr sz="2200">
-                <a:solidFill>
-                  <a:srgbClr val="FFFFFF"/>
-                </a:solidFill>
-              </a:defRPr>
-            </a:pPr>
-            <a:r>
-              <a:t>  ✅ CLAUDE.md configured with team standards</a:t>
-            </a:r>
-          </a:p>
-          <a:p>
-            <a:pPr>
-              <a:spcBef>
-                <a:spcPts val="800"/>
-              </a:spcBef>
-              <a:spcAft>
-                <a:spcPts val="800"/>
-              </a:spcAft>
-              <a:defRPr sz="2200">
-                <a:solidFill>
-                  <a:srgbClr val="FFFFFF"/>
-                </a:solidFill>
-              </a:defRPr>
-            </a:pPr>
-            <a:r>
-              <a:t>  ✅ Custom commands in .claude/commands/ (versioned in git)</a:t>
-            </a:r>
-          </a:p>
-          <a:p>
-            <a:pPr>
-              <a:spcBef>
-                <a:spcPts val="800"/>
-              </a:spcBef>
-              <a:spcAft>
-                <a:spcPts val="800"/>
-              </a:spcAft>
-              <a:defRPr sz="2200">
-                <a:solidFill>
-                  <a:srgbClr val="FFFFFF"/>
-                </a:solidFill>
-              </a:defRPr>
-            </a:pPr>
-            <a:r>
-              <a:t>  ✅ Pre-tool hooks for security (no secrets, safe commands)</a:t>
-            </a:r>
-          </a:p>
-          <a:p>
-            <a:pPr>
-              <a:spcBef>
-                <a:spcPts val="800"/>
-              </a:spcBef>
-              <a:spcAft>
-                <a:spcPts val="800"/>
-              </a:spcAft>
-              <a:defRPr sz="2200">
-                <a:solidFill>
-                  <a:srgbClr val="FFFFFF"/>
-                </a:solidFill>
-              </a:defRPr>
-            </a:pPr>
-            <a:r>
-              <a:t>  ✅ Post-tool hooks for audit logging</a:t>
-            </a:r>
-          </a:p>
-          <a:p>
-            <a:pPr>
-              <a:spcBef>
-                <a:spcPts val="800"/>
-              </a:spcBef>
-              <a:spcAft>
-                <a:spcPts val="800"/>
-              </a:spcAft>
-              <a:defRPr sz="2200">
-                <a:solidFill>
-                  <a:srgbClr val="FFFFFF"/>
-                </a:solidFill>
-              </a:defRPr>
-            </a:pPr>
-            <a:r>
-              <a:t>  ✅ .claudeignore optimized for project</a:t>
-            </a:r>
-          </a:p>
-          <a:p>
-            <a:pPr>
-              <a:spcBef>
-                <a:spcPts val="800"/>
-              </a:spcBef>
-              <a:spcAft>
-                <a:spcPts val="800"/>
-              </a:spcAft>
-              <a:defRPr sz="2200">
-                <a:solidFill>
-                  <a:srgbClr val="FFFFFF"/>
-                </a:solidFill>
-              </a:defRPr>
-            </a:pPr>
-            <a:r>
-              <a:t>  ✅ MCP servers approved and configured</a:t>
-            </a:r>
-          </a:p>
-          <a:p>
-            <a:pPr>
-              <a:spcBef>
-                <a:spcPts val="800"/>
-              </a:spcBef>
-              <a:spcAft>
-                <a:spcPts val="800"/>
-              </a:spcAft>
-              <a:defRPr sz="2200">
-                <a:solidFill>
-                  <a:srgbClr val="FFFFFF"/>
-                </a:solidFill>
-              </a:defRPr>
-            </a:pPr>
-            <a:r>
-              <a:t>  ✅ Team training on custom commands and workflows</a:t>
-            </a:r>
-          </a:p>
-          <a:p>
-            <a:pPr>
-              <a:spcBef>
-                <a:spcPts val="800"/>
-              </a:spcBef>
-              <a:spcAft>
-                <a:spcPts val="800"/>
-              </a:spcAft>
-              <a:defRPr sz="2200">
-                <a:solidFill>
-                  <a:srgbClr val="FFFFFF"/>
-                </a:solidFill>
-              </a:defRPr>
-            </a:pPr>
-            <a:r>
-              <a:t>  ✅ Cost monitoring and budgets in place</a:t>
+            <a:pPr algn="ctr">
+              <a:defRPr sz="2800" b="1">
+                <a:solidFill>
+                  <a:srgbClr val="E86B4A"/>
+                </a:solidFill>
+              </a:defRPr>
+            </a:pPr>
+            <a:r>
+              <a:t>The Phases</a:t>
+            </a:r>
+          </a:p>
+        </p:txBody>
+      </p:sp>
+      <p:sp>
+        <p:nvSpPr>
+          <p:cNvPr id="5" name="TextBox 4"/>
+          <p:cNvSpPr txBox="1"/>
+          <p:nvPr/>
+        </p:nvSpPr>
+        <p:spPr>
+          <a:xfrm>
+            <a:off x="6370167" y="1463040"/>
+            <a:ext cx="5364327" cy="731520"/>
+          </a:xfrm>
+          <a:prstGeom prst="rect">
+            <a:avLst/>
+          </a:prstGeom>
+          <a:noFill/>
+        </p:spPr>
+        <p:txBody>
+          <a:bodyPr wrap="none">
+            <a:spAutoFit/>
+          </a:bodyPr>
+          <a:lstStyle/>
+          <a:p>
+            <a:pPr algn="ctr">
+              <a:defRPr sz="2800" b="1">
+                <a:solidFill>
+                  <a:srgbClr val="00D4AA"/>
+                </a:solidFill>
+              </a:defRPr>
+            </a:pPr>
+            <a:r>
+              <a:t>Why This Order Matters</a:t>
             </a:r>
           </a:p>
         </p:txBody>

</xml_diff>

<commit_message>
feat: Day 2 overhaul — 4 labs, mindset cheat sheet, images, security section, speaker notes rewrite
</commit_message>
<xml_diff>
--- a/slides/Day3_Claude_Code_Advanced.pptx
+++ b/slides/Day3_Claude_Code_Advanced.pptx
@@ -21479,7 +21479,7 @@
               </a:defRPr>
             </a:pPr>
             <a:r>
-              <a:t>Subagents &amp; Orchestration</a:t>
+              <a:t>Lab 3A: Custom Commands</a:t>
             </a:r>
           </a:p>
         </p:txBody>
@@ -21637,7 +21637,7 @@
               </a:defRPr>
             </a:pPr>
             <a:r>
-              <a:t>Hooks</a:t>
+              <a:t>Hooks &amp; Safety Guardrails</a:t>
             </a:r>
           </a:p>
         </p:txBody>
@@ -21910,7 +21910,7 @@
               </a:defRPr>
             </a:pPr>
             <a:r>
-              <a:t>Plan Mode &amp; Thinking</a:t>
+              <a:t>Lab 3B: Hooks</a:t>
             </a:r>
           </a:p>
         </p:txBody>
@@ -22025,7 +22025,7 @@
               </a:defRPr>
             </a:pPr>
             <a:r>
-              <a:t>Lab 1</a:t>
+              <a:t>MCP Fundamentals</a:t>
             </a:r>
           </a:p>
         </p:txBody>
@@ -22261,7 +22261,7 @@
               </a:defRPr>
             </a:pPr>
             <a:r>
-              <a:t>Skills &amp; CLAUDE.md</a:t>
+              <a:t>Lab 3C: MCP</a:t>
             </a:r>
           </a:p>
         </p:txBody>
@@ -22341,7 +22341,7 @@
               </a:defRPr>
             </a:pPr>
             <a:r>
-              <a:t>30 min</a:t>
+              <a:t>45 min</a:t>
             </a:r>
           </a:p>
         </p:txBody>
@@ -22376,7 +22376,7 @@
               </a:defRPr>
             </a:pPr>
             <a:r>
-              <a:t>MCP Fundamentals</a:t>
+              <a:t>Subagents &amp; Agent Teams</a:t>
             </a:r>
           </a:p>
         </p:txBody>
@@ -22534,7 +22534,7 @@
               </a:defRPr>
             </a:pPr>
             <a:r>
-              <a:t>MCP Practical</a:t>
+              <a:t>Lab 3D: Subagents</a:t>
             </a:r>
           </a:p>
         </p:txBody>
@@ -22807,7 +22807,7 @@
               </a:defRPr>
             </a:pPr>
             <a:r>
-              <a:t>Cowork &amp; Agent Teams</a:t>
+              <a:t>Lab 3E: Production (Optional)</a:t>
             </a:r>
           </a:p>
         </p:txBody>
@@ -22922,7 +22922,7 @@
               </a:defRPr>
             </a:pPr>
             <a:r>
-              <a:t>Lab 2</a:t>
+              <a:t>Advanced Workflows</a:t>
             </a:r>
           </a:p>
         </p:txBody>
@@ -23002,7 +23002,7 @@
               </a:defRPr>
             </a:pPr>
             <a:r>
-              <a:t>45 min</a:t>
+              <a:t>30 min</a:t>
             </a:r>
           </a:p>
         </p:txBody>
@@ -23080,7 +23080,7 @@
               </a:defRPr>
             </a:pPr>
             <a:r>
-              <a:t>Advanced Workflows</a:t>
+              <a:t>Wrap-up &amp; Next Steps</a:t>
             </a:r>
           </a:p>
         </p:txBody>
@@ -23195,7 +23195,7 @@
               </a:defRPr>
             </a:pPr>
             <a:r>
-              <a:t>Wrap-up</a:t>
+              <a:t/>
             </a:r>
           </a:p>
         </p:txBody>
@@ -23275,7 +23275,7 @@
               </a:defRPr>
             </a:pPr>
             <a:r>
-              <a:t>30 min</a:t>
+              <a:t/>
             </a:r>
           </a:p>
         </p:txBody>

</xml_diff>